<commit_message>
shrimp Task Manager PPT 정리
</commit_message>
<xml_diff>
--- a/PPT정리/28. Shrimp Task Master AI.pptx
+++ b/PPT정리/28. Shrimp Task Master AI.pptx
@@ -6,9 +6,22 @@
   </p:sldMasterIdLst>
   <p:sldIdLst>
     <p:sldId id="256" r:id="rId2"/>
-    <p:sldId id="258" r:id="rId3"/>
-    <p:sldId id="259" r:id="rId4"/>
-    <p:sldId id="260" r:id="rId5"/>
+    <p:sldId id="261" r:id="rId3"/>
+    <p:sldId id="258" r:id="rId4"/>
+    <p:sldId id="262" r:id="rId5"/>
+    <p:sldId id="260" r:id="rId6"/>
+    <p:sldId id="263" r:id="rId7"/>
+    <p:sldId id="264" r:id="rId8"/>
+    <p:sldId id="265" r:id="rId9"/>
+    <p:sldId id="266" r:id="rId10"/>
+    <p:sldId id="267" r:id="rId11"/>
+    <p:sldId id="268" r:id="rId12"/>
+    <p:sldId id="269" r:id="rId13"/>
+    <p:sldId id="274" r:id="rId14"/>
+    <p:sldId id="270" r:id="rId15"/>
+    <p:sldId id="271" r:id="rId16"/>
+    <p:sldId id="272" r:id="rId17"/>
+    <p:sldId id="273" r:id="rId18"/>
   </p:sldIdLst>
   <p:sldSz cx="12192000" cy="6858000"/>
   <p:notesSz cx="6858000" cy="9144000"/>
@@ -107,6 +120,11 @@
       </a:defRPr>
     </a:lvl9pPr>
   </p:defaultTextStyle>
+  <p:extLst>
+    <p:ext uri="{EFAFB233-063F-42B5-8137-9DF3F51BA10A}">
+      <p15:sldGuideLst xmlns:p15="http://schemas.microsoft.com/office/powerpoint/2012/main"/>
+    </p:ext>
+  </p:extLst>
 </p:presentation>
 </file>
 
@@ -3825,14 +3843,16 @@
         </p:nvSpPr>
         <p:spPr/>
         <p:txBody>
-          <a:bodyPr/>
-          <a:lstStyle/>
-          <a:p>
-            <a:r>
-              <a:rPr lang="en-US" altLang="ko-KR" dirty="0"/>
-              <a:t>Task Master AI</a:t>
-            </a:r>
-            <a:endParaRPr lang="ko-KR" altLang="en-US" dirty="0"/>
+          <a:bodyPr>
+            <a:normAutofit/>
+          </a:bodyPr>
+          <a:lstStyle/>
+          <a:p>
+            <a:r>
+              <a:rPr lang="en-US" altLang="ko-KR" sz="6600" dirty="0"/>
+              <a:t>Shrimp Task Master MCP</a:t>
+            </a:r>
+            <a:endParaRPr lang="ko-KR" altLang="en-US" sz="6600" dirty="0"/>
           </a:p>
         </p:txBody>
       </p:sp>
@@ -3865,6 +3885,1084 @@
     <p:extLst>
       <p:ext uri="{BB962C8B-B14F-4D97-AF65-F5344CB8AC3E}">
         <p14:creationId xmlns:p14="http://schemas.microsoft.com/office/powerpoint/2010/main" val="1811025580"/>
+      </p:ext>
+    </p:extLst>
+  </p:cSld>
+  <p:clrMapOvr>
+    <a:masterClrMapping/>
+  </p:clrMapOvr>
+</p:sld>
+</file>
+
+<file path=ppt/slides/slide10.xml><?xml version="1.0" encoding="utf-8"?>
+<p:sld xmlns:a="http://schemas.openxmlformats.org/drawingml/2006/main" xmlns:r="http://schemas.openxmlformats.org/officeDocument/2006/relationships" xmlns:p="http://schemas.openxmlformats.org/presentationml/2006/main">
+  <p:cSld>
+    <p:spTree>
+      <p:nvGrpSpPr>
+        <p:cNvPr id="1" name=""/>
+        <p:cNvGrpSpPr/>
+        <p:nvPr/>
+      </p:nvGrpSpPr>
+      <p:grpSpPr>
+        <a:xfrm>
+          <a:off x="0" y="0"/>
+          <a:ext cx="0" cy="0"/>
+          <a:chOff x="0" y="0"/>
+          <a:chExt cx="0" cy="0"/>
+        </a:xfrm>
+      </p:grpSpPr>
+      <p:sp>
+        <p:nvSpPr>
+          <p:cNvPr id="2" name="제목 1">
+            <a:extLst>
+              <a:ext uri="{FF2B5EF4-FFF2-40B4-BE49-F238E27FC236}">
+                <a16:creationId xmlns:a16="http://schemas.microsoft.com/office/drawing/2014/main" id="{4518BC66-C47F-C02A-C95A-403AD85281BF}"/>
+              </a:ext>
+            </a:extLst>
+          </p:cNvPr>
+          <p:cNvSpPr>
+            <a:spLocks noGrp="1"/>
+          </p:cNvSpPr>
+          <p:nvPr>
+            <p:ph type="title"/>
+          </p:nvPr>
+        </p:nvSpPr>
+        <p:spPr/>
+        <p:txBody>
+          <a:bodyPr/>
+          <a:lstStyle/>
+          <a:p>
+            <a:r>
+              <a:rPr lang="en-US" altLang="ko-KR" dirty="0" err="1"/>
+              <a:t>Execute_task</a:t>
+            </a:r>
+            <a:endParaRPr lang="ko-KR" altLang="en-US" dirty="0"/>
+          </a:p>
+        </p:txBody>
+      </p:sp>
+      <p:pic>
+        <p:nvPicPr>
+          <p:cNvPr id="4" name="그림 3">
+            <a:extLst>
+              <a:ext uri="{FF2B5EF4-FFF2-40B4-BE49-F238E27FC236}">
+                <a16:creationId xmlns:a16="http://schemas.microsoft.com/office/drawing/2014/main" id="{6AFCD848-40F7-907D-F4C5-2D571FF4670E}"/>
+              </a:ext>
+            </a:extLst>
+          </p:cNvPr>
+          <p:cNvPicPr>
+            <a:picLocks noChangeAspect="1"/>
+          </p:cNvPicPr>
+          <p:nvPr/>
+        </p:nvPicPr>
+        <p:blipFill>
+          <a:blip r:embed="rId2"/>
+          <a:stretch>
+            <a:fillRect/>
+          </a:stretch>
+        </p:blipFill>
+        <p:spPr>
+          <a:xfrm>
+            <a:off x="4632799" y="1911822"/>
+            <a:ext cx="3103478" cy="724145"/>
+          </a:xfrm>
+          <a:prstGeom prst="rect">
+            <a:avLst/>
+          </a:prstGeom>
+        </p:spPr>
+      </p:pic>
+      <p:pic>
+        <p:nvPicPr>
+          <p:cNvPr id="5" name="그림 4">
+            <a:extLst>
+              <a:ext uri="{FF2B5EF4-FFF2-40B4-BE49-F238E27FC236}">
+                <a16:creationId xmlns:a16="http://schemas.microsoft.com/office/drawing/2014/main" id="{A33255ED-A615-5D62-7874-349A0DAAACB8}"/>
+              </a:ext>
+            </a:extLst>
+          </p:cNvPr>
+          <p:cNvPicPr>
+            <a:picLocks noChangeAspect="1"/>
+          </p:cNvPicPr>
+          <p:nvPr/>
+        </p:nvPicPr>
+        <p:blipFill>
+          <a:blip r:embed="rId3"/>
+          <a:stretch>
+            <a:fillRect/>
+          </a:stretch>
+        </p:blipFill>
+        <p:spPr>
+          <a:xfrm>
+            <a:off x="1097280" y="1911822"/>
+            <a:ext cx="3358445" cy="3748162"/>
+          </a:xfrm>
+          <a:prstGeom prst="rect">
+            <a:avLst/>
+          </a:prstGeom>
+        </p:spPr>
+      </p:pic>
+      <p:sp>
+        <p:nvSpPr>
+          <p:cNvPr id="6" name="TextBox 5">
+            <a:extLst>
+              <a:ext uri="{FF2B5EF4-FFF2-40B4-BE49-F238E27FC236}">
+                <a16:creationId xmlns:a16="http://schemas.microsoft.com/office/drawing/2014/main" id="{4D274BFC-17EF-F61C-3A6E-778DD04C5445}"/>
+              </a:ext>
+            </a:extLst>
+          </p:cNvPr>
+          <p:cNvSpPr txBox="1"/>
+          <p:nvPr/>
+        </p:nvSpPr>
+        <p:spPr>
+          <a:xfrm>
+            <a:off x="4628561" y="2790334"/>
+            <a:ext cx="7004115" cy="2593018"/>
+          </a:xfrm>
+          <a:prstGeom prst="rect">
+            <a:avLst/>
+          </a:prstGeom>
+          <a:noFill/>
+        </p:spPr>
+        <p:txBody>
+          <a:bodyPr wrap="square" rtlCol="0">
+            <a:spAutoFit/>
+          </a:bodyPr>
+          <a:lstStyle/>
+          <a:p>
+            <a:r>
+              <a:rPr lang="en-US" altLang="ko-KR" sz="1400" dirty="0" err="1"/>
+              <a:t>execute_task</a:t>
+            </a:r>
+            <a:r>
+              <a:rPr lang="en-US" altLang="ko-KR" sz="1400" dirty="0"/>
+              <a:t> </a:t>
+            </a:r>
+            <a:r>
+              <a:rPr lang="en-US" altLang="ko-KR" sz="1400" dirty="0">
+                <a:sym typeface="Wingdings" panose="05000000000000000000" pitchFamily="2" charset="2"/>
+              </a:rPr>
+              <a:t> </a:t>
+            </a:r>
+            <a:r>
+              <a:rPr lang="ko-KR" altLang="en-US" sz="1400" dirty="0">
+                <a:sym typeface="Wingdings" panose="05000000000000000000" pitchFamily="2" charset="2"/>
+              </a:rPr>
+              <a:t>단계 별로 계획을 실행시키는 명령어</a:t>
+            </a:r>
+            <a:r>
+              <a:rPr lang="en-US" altLang="ko-KR" sz="1400" dirty="0">
+                <a:sym typeface="Wingdings" panose="05000000000000000000" pitchFamily="2" charset="2"/>
+              </a:rPr>
+              <a:t>.</a:t>
+            </a:r>
+            <a:br>
+              <a:rPr lang="en-US" altLang="ko-KR" sz="1400" dirty="0">
+                <a:sym typeface="Wingdings" panose="05000000000000000000" pitchFamily="2" charset="2"/>
+              </a:rPr>
+            </a:br>
+            <a:r>
+              <a:rPr lang="en-US" altLang="ko-KR" sz="1400" dirty="0">
+                <a:sym typeface="Wingdings" panose="05000000000000000000" pitchFamily="2" charset="2"/>
+              </a:rPr>
+              <a:t>                              </a:t>
+            </a:r>
+            <a:r>
+              <a:rPr lang="ko-KR" altLang="en-US" sz="1400" dirty="0">
+                <a:sym typeface="Wingdings" panose="05000000000000000000" pitchFamily="2" charset="2"/>
+              </a:rPr>
+              <a:t>연속적으로 단계를 실행시킬 수도 있고</a:t>
+            </a:r>
+            <a:r>
+              <a:rPr lang="en-US" altLang="ko-KR" sz="1400" dirty="0">
+                <a:sym typeface="Wingdings" panose="05000000000000000000" pitchFamily="2" charset="2"/>
+              </a:rPr>
+              <a:t>, </a:t>
+            </a:r>
+            <a:r>
+              <a:rPr lang="ko-KR" altLang="en-US" sz="1400" dirty="0">
+                <a:sym typeface="Wingdings" panose="05000000000000000000" pitchFamily="2" charset="2"/>
+              </a:rPr>
+              <a:t>사진과 같이 </a:t>
+            </a:r>
+            <a:br>
+              <a:rPr lang="en-US" altLang="ko-KR" sz="1400" dirty="0">
+                <a:sym typeface="Wingdings" panose="05000000000000000000" pitchFamily="2" charset="2"/>
+              </a:rPr>
+            </a:br>
+            <a:r>
+              <a:rPr lang="en-US" altLang="ko-KR" sz="1400" dirty="0">
+                <a:sym typeface="Wingdings" panose="05000000000000000000" pitchFamily="2" charset="2"/>
+              </a:rPr>
+              <a:t>                              </a:t>
+            </a:r>
+            <a:r>
+              <a:rPr lang="ko-KR" altLang="en-US" sz="1400" dirty="0">
+                <a:sym typeface="Wingdings" panose="05000000000000000000" pitchFamily="2" charset="2"/>
+              </a:rPr>
+              <a:t>작은 단위로 계획을 실행 </a:t>
+            </a:r>
+            <a:r>
+              <a:rPr lang="ko-KR" altLang="en-US" sz="1400" dirty="0" err="1">
+                <a:sym typeface="Wingdings" panose="05000000000000000000" pitchFamily="2" charset="2"/>
+              </a:rPr>
+              <a:t>시킬수</a:t>
+            </a:r>
+            <a:r>
+              <a:rPr lang="ko-KR" altLang="en-US" sz="1400" dirty="0">
+                <a:sym typeface="Wingdings" panose="05000000000000000000" pitchFamily="2" charset="2"/>
+              </a:rPr>
+              <a:t> 있다</a:t>
+            </a:r>
+            <a:r>
+              <a:rPr lang="en-US" altLang="ko-KR" sz="1400" dirty="0">
+                <a:sym typeface="Wingdings" panose="05000000000000000000" pitchFamily="2" charset="2"/>
+              </a:rPr>
+              <a:t>. </a:t>
+            </a:r>
+          </a:p>
+          <a:p>
+            <a:br>
+              <a:rPr lang="en-US" altLang="ko-KR" sz="1000" dirty="0">
+                <a:sym typeface="Wingdings" panose="05000000000000000000" pitchFamily="2" charset="2"/>
+              </a:rPr>
+            </a:br>
+            <a:r>
+              <a:rPr lang="en-US" altLang="ko-KR" sz="1000" dirty="0">
+                <a:sym typeface="Wingdings" panose="05000000000000000000" pitchFamily="2" charset="2"/>
+              </a:rPr>
+              <a:t>(※ </a:t>
+            </a:r>
+            <a:r>
+              <a:rPr lang="ko-KR" altLang="en-US" sz="1000" dirty="0">
+                <a:sym typeface="Wingdings" panose="05000000000000000000" pitchFamily="2" charset="2"/>
+              </a:rPr>
+              <a:t>개발 계획의 경우 </a:t>
+            </a:r>
+            <a:r>
+              <a:rPr lang="en-US" altLang="ko-KR" sz="1000" dirty="0">
+                <a:sym typeface="Wingdings" panose="05000000000000000000" pitchFamily="2" charset="2"/>
+              </a:rPr>
+              <a:t>1</a:t>
+            </a:r>
+            <a:r>
+              <a:rPr lang="ko-KR" altLang="en-US" sz="1000" dirty="0">
+                <a:sym typeface="Wingdings" panose="05000000000000000000" pitchFamily="2" charset="2"/>
+              </a:rPr>
+              <a:t>번을 작업하다 </a:t>
+            </a:r>
+            <a:r>
+              <a:rPr lang="en-US" altLang="ko-KR" sz="1000" dirty="0">
+                <a:sym typeface="Wingdings" panose="05000000000000000000" pitchFamily="2" charset="2"/>
+              </a:rPr>
+              <a:t>4</a:t>
+            </a:r>
+            <a:r>
+              <a:rPr lang="ko-KR" altLang="en-US" sz="1000" dirty="0">
+                <a:sym typeface="Wingdings" panose="05000000000000000000" pitchFamily="2" charset="2"/>
+              </a:rPr>
+              <a:t>번을 작업하라는 둥 명령은 내릴 수 있지만</a:t>
+            </a:r>
+            <a:r>
+              <a:rPr lang="en-US" altLang="ko-KR" sz="1000" dirty="0">
+                <a:sym typeface="Wingdings" panose="05000000000000000000" pitchFamily="2" charset="2"/>
+              </a:rPr>
+              <a:t>.</a:t>
+            </a:r>
+            <a:br>
+              <a:rPr lang="en-US" altLang="ko-KR" sz="1000" dirty="0">
+                <a:sym typeface="Wingdings" panose="05000000000000000000" pitchFamily="2" charset="2"/>
+              </a:rPr>
+            </a:br>
+            <a:r>
+              <a:rPr lang="en-US" altLang="ko-KR" sz="1000" dirty="0">
+                <a:sym typeface="Wingdings" panose="05000000000000000000" pitchFamily="2" charset="2"/>
+              </a:rPr>
+              <a:t>      </a:t>
+            </a:r>
+            <a:r>
+              <a:rPr lang="ko-KR" altLang="en-US" sz="1000" dirty="0">
+                <a:sym typeface="Wingdings" panose="05000000000000000000" pitchFamily="2" charset="2"/>
+              </a:rPr>
+              <a:t>개발 계획 순서대로 개발이 진행되지 </a:t>
+            </a:r>
+            <a:r>
+              <a:rPr lang="ko-KR" altLang="en-US" sz="1000" dirty="0" err="1">
+                <a:sym typeface="Wingdings" panose="05000000000000000000" pitchFamily="2" charset="2"/>
+              </a:rPr>
+              <a:t>않을경우</a:t>
+            </a:r>
+            <a:r>
+              <a:rPr lang="ko-KR" altLang="en-US" sz="1000" dirty="0">
+                <a:sym typeface="Wingdings" panose="05000000000000000000" pitchFamily="2" charset="2"/>
+              </a:rPr>
+              <a:t> 어떠한 문제가 생길지 모른다</a:t>
+            </a:r>
+            <a:r>
+              <a:rPr lang="en-US" altLang="ko-KR" sz="1000" dirty="0">
+                <a:sym typeface="Wingdings" panose="05000000000000000000" pitchFamily="2" charset="2"/>
+              </a:rPr>
+              <a:t>.</a:t>
+            </a:r>
+            <a:br>
+              <a:rPr lang="en-US" altLang="ko-KR" sz="1000" dirty="0">
+                <a:sym typeface="Wingdings" panose="05000000000000000000" pitchFamily="2" charset="2"/>
+              </a:rPr>
+            </a:br>
+            <a:r>
+              <a:rPr lang="en-US" altLang="ko-KR" sz="1000" dirty="0">
+                <a:sym typeface="Wingdings" panose="05000000000000000000" pitchFamily="2" charset="2"/>
+              </a:rPr>
+              <a:t>      </a:t>
+            </a:r>
+            <a:r>
+              <a:rPr lang="ko-KR" altLang="en-US" sz="1000" dirty="0">
+                <a:sym typeface="Wingdings" panose="05000000000000000000" pitchFamily="2" charset="2"/>
+              </a:rPr>
+              <a:t>연속 개발이든 작은 범위의 계획 수행이든 순서대로 계획이 진행되도록 권장한다</a:t>
+            </a:r>
+            <a:r>
+              <a:rPr lang="en-US" altLang="ko-KR" sz="1000" dirty="0">
+                <a:sym typeface="Wingdings" panose="05000000000000000000" pitchFamily="2" charset="2"/>
+              </a:rPr>
+              <a:t>.)</a:t>
+            </a:r>
+          </a:p>
+          <a:p>
+            <a:endParaRPr lang="en-US" altLang="ko-KR" sz="1050" dirty="0">
+              <a:sym typeface="Wingdings" panose="05000000000000000000" pitchFamily="2" charset="2"/>
+            </a:endParaRPr>
+          </a:p>
+          <a:p>
+            <a:r>
+              <a:rPr lang="ko-KR" altLang="en-US" sz="1400" dirty="0">
+                <a:sym typeface="Wingdings" panose="05000000000000000000" pitchFamily="2" charset="2"/>
+              </a:rPr>
+              <a:t>계획 수행 완료 시 생성된 앱에 에러가 발생했을 경우에는 에러의 피드백을 전달하고 다시 앱 작성을 요청한다</a:t>
+            </a:r>
+            <a:r>
+              <a:rPr lang="en-US" altLang="ko-KR" sz="1400" dirty="0">
+                <a:sym typeface="Wingdings" panose="05000000000000000000" pitchFamily="2" charset="2"/>
+              </a:rPr>
+              <a:t>.</a:t>
+            </a:r>
+            <a:br>
+              <a:rPr lang="en-US" altLang="ko-KR" sz="1400" dirty="0">
+                <a:sym typeface="Wingdings" panose="05000000000000000000" pitchFamily="2" charset="2"/>
+              </a:rPr>
+            </a:br>
+            <a:br>
+              <a:rPr lang="en-US" altLang="ko-KR" sz="1400" dirty="0">
+                <a:sym typeface="Wingdings" panose="05000000000000000000" pitchFamily="2" charset="2"/>
+              </a:rPr>
+            </a:br>
+            <a:r>
+              <a:rPr lang="ko-KR" altLang="en-US" sz="1400" dirty="0">
+                <a:sym typeface="Wingdings" panose="05000000000000000000" pitchFamily="2" charset="2"/>
+              </a:rPr>
+              <a:t>계획 수행이 정상적이라면 다시 </a:t>
+            </a:r>
+            <a:r>
+              <a:rPr lang="en-US" altLang="ko-KR" sz="1400" dirty="0" err="1">
+                <a:sym typeface="Wingdings" panose="05000000000000000000" pitchFamily="2" charset="2"/>
+              </a:rPr>
+              <a:t>list_tasks</a:t>
+            </a:r>
+            <a:r>
+              <a:rPr lang="en-US" altLang="ko-KR" sz="1400" dirty="0">
+                <a:sym typeface="Wingdings" panose="05000000000000000000" pitchFamily="2" charset="2"/>
+              </a:rPr>
+              <a:t> </a:t>
+            </a:r>
+            <a:r>
+              <a:rPr lang="ko-KR" altLang="en-US" sz="1400" dirty="0">
+                <a:sym typeface="Wingdings" panose="05000000000000000000" pitchFamily="2" charset="2"/>
+              </a:rPr>
+              <a:t>명령으로 완료된 작업과 남은 작업을 확인 가능하다</a:t>
+            </a:r>
+            <a:r>
+              <a:rPr lang="en-US" altLang="ko-KR" sz="1400" dirty="0">
+                <a:sym typeface="Wingdings" panose="05000000000000000000" pitchFamily="2" charset="2"/>
+              </a:rPr>
+              <a:t>.</a:t>
+            </a:r>
+          </a:p>
+        </p:txBody>
+      </p:sp>
+    </p:spTree>
+    <p:extLst>
+      <p:ext uri="{BB962C8B-B14F-4D97-AF65-F5344CB8AC3E}">
+        <p14:creationId xmlns:p14="http://schemas.microsoft.com/office/powerpoint/2010/main" val="2428914857"/>
+      </p:ext>
+    </p:extLst>
+  </p:cSld>
+  <p:clrMapOvr>
+    <a:masterClrMapping/>
+  </p:clrMapOvr>
+</p:sld>
+</file>
+
+<file path=ppt/slides/slide11.xml><?xml version="1.0" encoding="utf-8"?>
+<p:sld xmlns:a="http://schemas.openxmlformats.org/drawingml/2006/main" xmlns:r="http://schemas.openxmlformats.org/officeDocument/2006/relationships" xmlns:p="http://schemas.openxmlformats.org/presentationml/2006/main">
+  <p:cSld>
+    <p:spTree>
+      <p:nvGrpSpPr>
+        <p:cNvPr id="1" name=""/>
+        <p:cNvGrpSpPr/>
+        <p:nvPr/>
+      </p:nvGrpSpPr>
+      <p:grpSpPr>
+        <a:xfrm>
+          <a:off x="0" y="0"/>
+          <a:ext cx="0" cy="0"/>
+          <a:chOff x="0" y="0"/>
+          <a:chExt cx="0" cy="0"/>
+        </a:xfrm>
+      </p:grpSpPr>
+      <p:sp>
+        <p:nvSpPr>
+          <p:cNvPr id="2" name="제목 1">
+            <a:extLst>
+              <a:ext uri="{FF2B5EF4-FFF2-40B4-BE49-F238E27FC236}">
+                <a16:creationId xmlns:a16="http://schemas.microsoft.com/office/drawing/2014/main" id="{DDA31E90-21C5-8B68-16E9-D64492775604}"/>
+              </a:ext>
+            </a:extLst>
+          </p:cNvPr>
+          <p:cNvSpPr>
+            <a:spLocks noGrp="1"/>
+          </p:cNvSpPr>
+          <p:nvPr>
+            <p:ph type="title"/>
+          </p:nvPr>
+        </p:nvSpPr>
+        <p:spPr/>
+        <p:txBody>
+          <a:bodyPr/>
+          <a:lstStyle/>
+          <a:p>
+            <a:r>
+              <a:rPr lang="en-US" altLang="ko-KR" dirty="0" err="1"/>
+              <a:t>Delete_task</a:t>
+            </a:r>
+            <a:endParaRPr lang="ko-KR" altLang="en-US" dirty="0"/>
+          </a:p>
+        </p:txBody>
+      </p:sp>
+      <p:sp>
+        <p:nvSpPr>
+          <p:cNvPr id="3" name="TextBox 2">
+            <a:extLst>
+              <a:ext uri="{FF2B5EF4-FFF2-40B4-BE49-F238E27FC236}">
+                <a16:creationId xmlns:a16="http://schemas.microsoft.com/office/drawing/2014/main" id="{53858F7B-A5B7-6FE9-56B2-B947669D91FD}"/>
+              </a:ext>
+            </a:extLst>
+          </p:cNvPr>
+          <p:cNvSpPr txBox="1"/>
+          <p:nvPr/>
+        </p:nvSpPr>
+        <p:spPr>
+          <a:xfrm>
+            <a:off x="1084082" y="1847654"/>
+            <a:ext cx="10105534" cy="369332"/>
+          </a:xfrm>
+          <a:prstGeom prst="rect">
+            <a:avLst/>
+          </a:prstGeom>
+          <a:noFill/>
+        </p:spPr>
+        <p:txBody>
+          <a:bodyPr wrap="square" rtlCol="0">
+            <a:spAutoFit/>
+          </a:bodyPr>
+          <a:lstStyle/>
+          <a:p>
+            <a:r>
+              <a:rPr lang="en-US" altLang="ko-KR" dirty="0"/>
+              <a:t>Task</a:t>
+            </a:r>
+            <a:r>
+              <a:rPr lang="ko-KR" altLang="en-US" dirty="0"/>
+              <a:t>가 마음에 들지 않을 때 사용함</a:t>
+            </a:r>
+            <a:r>
+              <a:rPr lang="en-US" altLang="ko-KR" dirty="0"/>
+              <a:t>.</a:t>
+            </a:r>
+            <a:endParaRPr lang="ko-KR" altLang="en-US" dirty="0"/>
+          </a:p>
+        </p:txBody>
+      </p:sp>
+    </p:spTree>
+    <p:extLst>
+      <p:ext uri="{BB962C8B-B14F-4D97-AF65-F5344CB8AC3E}">
+        <p14:creationId xmlns:p14="http://schemas.microsoft.com/office/powerpoint/2010/main" val="4105197519"/>
+      </p:ext>
+    </p:extLst>
+  </p:cSld>
+  <p:clrMapOvr>
+    <a:masterClrMapping/>
+  </p:clrMapOvr>
+</p:sld>
+</file>
+
+<file path=ppt/slides/slide12.xml><?xml version="1.0" encoding="utf-8"?>
+<p:sld xmlns:a="http://schemas.openxmlformats.org/drawingml/2006/main" xmlns:r="http://schemas.openxmlformats.org/officeDocument/2006/relationships" xmlns:p="http://schemas.openxmlformats.org/presentationml/2006/main">
+  <p:cSld>
+    <p:spTree>
+      <p:nvGrpSpPr>
+        <p:cNvPr id="1" name=""/>
+        <p:cNvGrpSpPr/>
+        <p:nvPr/>
+      </p:nvGrpSpPr>
+      <p:grpSpPr>
+        <a:xfrm>
+          <a:off x="0" y="0"/>
+          <a:ext cx="0" cy="0"/>
+          <a:chOff x="0" y="0"/>
+          <a:chExt cx="0" cy="0"/>
+        </a:xfrm>
+      </p:grpSpPr>
+      <p:sp>
+        <p:nvSpPr>
+          <p:cNvPr id="2" name="제목 1">
+            <a:extLst>
+              <a:ext uri="{FF2B5EF4-FFF2-40B4-BE49-F238E27FC236}">
+                <a16:creationId xmlns:a16="http://schemas.microsoft.com/office/drawing/2014/main" id="{7CC38293-911E-EA5E-FF24-2AE15CB45267}"/>
+              </a:ext>
+            </a:extLst>
+          </p:cNvPr>
+          <p:cNvSpPr>
+            <a:spLocks noGrp="1"/>
+          </p:cNvSpPr>
+          <p:nvPr>
+            <p:ph type="title"/>
+          </p:nvPr>
+        </p:nvSpPr>
+        <p:spPr/>
+        <p:txBody>
+          <a:bodyPr/>
+          <a:lstStyle/>
+          <a:p>
+            <a:r>
+              <a:rPr lang="en-US" altLang="ko-KR" dirty="0" err="1"/>
+              <a:t>Update_task</a:t>
+            </a:r>
+            <a:endParaRPr lang="ko-KR" altLang="en-US" dirty="0"/>
+          </a:p>
+        </p:txBody>
+      </p:sp>
+      <p:sp>
+        <p:nvSpPr>
+          <p:cNvPr id="3" name="TextBox 2">
+            <a:extLst>
+              <a:ext uri="{FF2B5EF4-FFF2-40B4-BE49-F238E27FC236}">
+                <a16:creationId xmlns:a16="http://schemas.microsoft.com/office/drawing/2014/main" id="{DBBE976C-57AA-621C-2A96-9D59DF4375E6}"/>
+              </a:ext>
+            </a:extLst>
+          </p:cNvPr>
+          <p:cNvSpPr txBox="1"/>
+          <p:nvPr/>
+        </p:nvSpPr>
+        <p:spPr>
+          <a:xfrm>
+            <a:off x="1102936" y="1828800"/>
+            <a:ext cx="10077254" cy="369332"/>
+          </a:xfrm>
+          <a:prstGeom prst="rect">
+            <a:avLst/>
+          </a:prstGeom>
+          <a:noFill/>
+        </p:spPr>
+        <p:txBody>
+          <a:bodyPr wrap="square" rtlCol="0">
+            <a:spAutoFit/>
+          </a:bodyPr>
+          <a:lstStyle/>
+          <a:p>
+            <a:r>
+              <a:rPr lang="ko-KR" altLang="en-US" dirty="0"/>
+              <a:t>작업계획의 세부내용을 조정할 때 사용</a:t>
+            </a:r>
+          </a:p>
+        </p:txBody>
+      </p:sp>
+    </p:spTree>
+    <p:extLst>
+      <p:ext uri="{BB962C8B-B14F-4D97-AF65-F5344CB8AC3E}">
+        <p14:creationId xmlns:p14="http://schemas.microsoft.com/office/powerpoint/2010/main" val="3659205008"/>
+      </p:ext>
+    </p:extLst>
+  </p:cSld>
+  <p:clrMapOvr>
+    <a:masterClrMapping/>
+  </p:clrMapOvr>
+</p:sld>
+</file>
+
+<file path=ppt/slides/slide13.xml><?xml version="1.0" encoding="utf-8"?>
+<p:sld xmlns:a="http://schemas.openxmlformats.org/drawingml/2006/main" xmlns:r="http://schemas.openxmlformats.org/officeDocument/2006/relationships" xmlns:p="http://schemas.openxmlformats.org/presentationml/2006/main">
+  <p:cSld>
+    <p:spTree>
+      <p:nvGrpSpPr>
+        <p:cNvPr id="1" name=""/>
+        <p:cNvGrpSpPr/>
+        <p:nvPr/>
+      </p:nvGrpSpPr>
+      <p:grpSpPr>
+        <a:xfrm>
+          <a:off x="0" y="0"/>
+          <a:ext cx="0" cy="0"/>
+          <a:chOff x="0" y="0"/>
+          <a:chExt cx="0" cy="0"/>
+        </a:xfrm>
+      </p:grpSpPr>
+      <p:sp>
+        <p:nvSpPr>
+          <p:cNvPr id="2" name="제목 1">
+            <a:extLst>
+              <a:ext uri="{FF2B5EF4-FFF2-40B4-BE49-F238E27FC236}">
+                <a16:creationId xmlns:a16="http://schemas.microsoft.com/office/drawing/2014/main" id="{1B9B4DEB-78B2-1327-2C16-E96638843393}"/>
+              </a:ext>
+            </a:extLst>
+          </p:cNvPr>
+          <p:cNvSpPr>
+            <a:spLocks noGrp="1"/>
+          </p:cNvSpPr>
+          <p:nvPr>
+            <p:ph type="title"/>
+          </p:nvPr>
+        </p:nvSpPr>
+        <p:spPr/>
+        <p:txBody>
+          <a:bodyPr/>
+          <a:lstStyle/>
+          <a:p>
+            <a:r>
+              <a:rPr lang="en-US" altLang="ko-KR" dirty="0" err="1"/>
+              <a:t>Analyze_task</a:t>
+            </a:r>
+            <a:endParaRPr lang="ko-KR" altLang="en-US" dirty="0"/>
+          </a:p>
+        </p:txBody>
+      </p:sp>
+      <p:sp>
+        <p:nvSpPr>
+          <p:cNvPr id="3" name="TextBox 2">
+            <a:extLst>
+              <a:ext uri="{FF2B5EF4-FFF2-40B4-BE49-F238E27FC236}">
+                <a16:creationId xmlns:a16="http://schemas.microsoft.com/office/drawing/2014/main" id="{6C92F768-9667-FA2C-B612-B28035BA5ECB}"/>
+              </a:ext>
+            </a:extLst>
+          </p:cNvPr>
+          <p:cNvSpPr txBox="1"/>
+          <p:nvPr/>
+        </p:nvSpPr>
+        <p:spPr>
+          <a:xfrm>
+            <a:off x="1102936" y="1828800"/>
+            <a:ext cx="10077254" cy="369332"/>
+          </a:xfrm>
+          <a:prstGeom prst="rect">
+            <a:avLst/>
+          </a:prstGeom>
+          <a:noFill/>
+        </p:spPr>
+        <p:txBody>
+          <a:bodyPr wrap="square" rtlCol="0">
+            <a:spAutoFit/>
+          </a:bodyPr>
+          <a:lstStyle/>
+          <a:p>
+            <a:r>
+              <a:rPr lang="ko-KR" altLang="en-US" dirty="0"/>
+              <a:t>계획을 쪼개거나 </a:t>
+            </a:r>
+            <a:r>
+              <a:rPr lang="ko-KR" altLang="en-US" dirty="0" err="1"/>
+              <a:t>실행전</a:t>
+            </a:r>
+            <a:r>
+              <a:rPr lang="ko-KR" altLang="en-US" dirty="0"/>
+              <a:t> 기술적으로 타당한지 검토하는 명령어</a:t>
+            </a:r>
+          </a:p>
+        </p:txBody>
+      </p:sp>
+    </p:spTree>
+    <p:extLst>
+      <p:ext uri="{BB962C8B-B14F-4D97-AF65-F5344CB8AC3E}">
+        <p14:creationId xmlns:p14="http://schemas.microsoft.com/office/powerpoint/2010/main" val="4073534036"/>
+      </p:ext>
+    </p:extLst>
+  </p:cSld>
+  <p:clrMapOvr>
+    <a:masterClrMapping/>
+  </p:clrMapOvr>
+</p:sld>
+</file>
+
+<file path=ppt/slides/slide14.xml><?xml version="1.0" encoding="utf-8"?>
+<p:sld xmlns:a="http://schemas.openxmlformats.org/drawingml/2006/main" xmlns:r="http://schemas.openxmlformats.org/officeDocument/2006/relationships" xmlns:p="http://schemas.openxmlformats.org/presentationml/2006/main">
+  <p:cSld>
+    <p:spTree>
+      <p:nvGrpSpPr>
+        <p:cNvPr id="1" name=""/>
+        <p:cNvGrpSpPr/>
+        <p:nvPr/>
+      </p:nvGrpSpPr>
+      <p:grpSpPr>
+        <a:xfrm>
+          <a:off x="0" y="0"/>
+          <a:ext cx="0" cy="0"/>
+          <a:chOff x="0" y="0"/>
+          <a:chExt cx="0" cy="0"/>
+        </a:xfrm>
+      </p:grpSpPr>
+      <p:sp>
+        <p:nvSpPr>
+          <p:cNvPr id="2" name="제목 1">
+            <a:extLst>
+              <a:ext uri="{FF2B5EF4-FFF2-40B4-BE49-F238E27FC236}">
+                <a16:creationId xmlns:a16="http://schemas.microsoft.com/office/drawing/2014/main" id="{3FB53422-BB29-EC12-4E78-5867CEB5F7E2}"/>
+              </a:ext>
+            </a:extLst>
+          </p:cNvPr>
+          <p:cNvSpPr>
+            <a:spLocks noGrp="1"/>
+          </p:cNvSpPr>
+          <p:nvPr>
+            <p:ph type="title"/>
+          </p:nvPr>
+        </p:nvSpPr>
+        <p:spPr/>
+        <p:txBody>
+          <a:bodyPr/>
+          <a:lstStyle/>
+          <a:p>
+            <a:r>
+              <a:rPr lang="en-US" altLang="ko-KR" b="1" dirty="0" err="1"/>
+              <a:t>split_tasks</a:t>
+            </a:r>
+            <a:endParaRPr lang="ko-KR" altLang="en-US" dirty="0"/>
+          </a:p>
+        </p:txBody>
+      </p:sp>
+      <p:sp>
+        <p:nvSpPr>
+          <p:cNvPr id="3" name="TextBox 2">
+            <a:extLst>
+              <a:ext uri="{FF2B5EF4-FFF2-40B4-BE49-F238E27FC236}">
+                <a16:creationId xmlns:a16="http://schemas.microsoft.com/office/drawing/2014/main" id="{7DF82DDD-E27A-5AE3-A330-EF6D5BCEC506}"/>
+              </a:ext>
+            </a:extLst>
+          </p:cNvPr>
+          <p:cNvSpPr txBox="1"/>
+          <p:nvPr/>
+        </p:nvSpPr>
+        <p:spPr>
+          <a:xfrm>
+            <a:off x="1102936" y="1828800"/>
+            <a:ext cx="10077254" cy="369332"/>
+          </a:xfrm>
+          <a:prstGeom prst="rect">
+            <a:avLst/>
+          </a:prstGeom>
+          <a:noFill/>
+        </p:spPr>
+        <p:txBody>
+          <a:bodyPr wrap="square" rtlCol="0">
+            <a:spAutoFit/>
+          </a:bodyPr>
+          <a:lstStyle/>
+          <a:p>
+            <a:r>
+              <a:rPr lang="ko-KR" altLang="en-US" dirty="0"/>
+              <a:t>복잡한 계획을 더 작은 단위의 </a:t>
+            </a:r>
+            <a:r>
+              <a:rPr lang="en-US" altLang="ko-KR" dirty="0"/>
+              <a:t>task</a:t>
+            </a:r>
+            <a:r>
+              <a:rPr lang="ko-KR" altLang="en-US" dirty="0"/>
+              <a:t>로 쪼개는 명령어</a:t>
+            </a:r>
+          </a:p>
+        </p:txBody>
+      </p:sp>
+    </p:spTree>
+    <p:extLst>
+      <p:ext uri="{BB962C8B-B14F-4D97-AF65-F5344CB8AC3E}">
+        <p14:creationId xmlns:p14="http://schemas.microsoft.com/office/powerpoint/2010/main" val="1716866700"/>
+      </p:ext>
+    </p:extLst>
+  </p:cSld>
+  <p:clrMapOvr>
+    <a:masterClrMapping/>
+  </p:clrMapOvr>
+</p:sld>
+</file>
+
+<file path=ppt/slides/slide15.xml><?xml version="1.0" encoding="utf-8"?>
+<p:sld xmlns:a="http://schemas.openxmlformats.org/drawingml/2006/main" xmlns:r="http://schemas.openxmlformats.org/officeDocument/2006/relationships" xmlns:p="http://schemas.openxmlformats.org/presentationml/2006/main">
+  <p:cSld>
+    <p:spTree>
+      <p:nvGrpSpPr>
+        <p:cNvPr id="1" name=""/>
+        <p:cNvGrpSpPr/>
+        <p:nvPr/>
+      </p:nvGrpSpPr>
+      <p:grpSpPr>
+        <a:xfrm>
+          <a:off x="0" y="0"/>
+          <a:ext cx="0" cy="0"/>
+          <a:chOff x="0" y="0"/>
+          <a:chExt cx="0" cy="0"/>
+        </a:xfrm>
+      </p:grpSpPr>
+      <p:sp>
+        <p:nvSpPr>
+          <p:cNvPr id="2" name="제목 1">
+            <a:extLst>
+              <a:ext uri="{FF2B5EF4-FFF2-40B4-BE49-F238E27FC236}">
+                <a16:creationId xmlns:a16="http://schemas.microsoft.com/office/drawing/2014/main" id="{F8205E9A-B512-F3A3-FF0C-1777FF901961}"/>
+              </a:ext>
+            </a:extLst>
+          </p:cNvPr>
+          <p:cNvSpPr>
+            <a:spLocks noGrp="1"/>
+          </p:cNvSpPr>
+          <p:nvPr>
+            <p:ph type="title"/>
+          </p:nvPr>
+        </p:nvSpPr>
+        <p:spPr/>
+        <p:txBody>
+          <a:bodyPr/>
+          <a:lstStyle/>
+          <a:p>
+            <a:r>
+              <a:rPr lang="en-US" altLang="ko-KR" dirty="0"/>
+              <a:t>Reflect task</a:t>
+            </a:r>
+            <a:endParaRPr lang="ko-KR" altLang="en-US" dirty="0"/>
+          </a:p>
+        </p:txBody>
+      </p:sp>
+      <p:sp>
+        <p:nvSpPr>
+          <p:cNvPr id="3" name="TextBox 2">
+            <a:extLst>
+              <a:ext uri="{FF2B5EF4-FFF2-40B4-BE49-F238E27FC236}">
+                <a16:creationId xmlns:a16="http://schemas.microsoft.com/office/drawing/2014/main" id="{854AECFE-4326-81D1-B3EC-D68D9AC89F32}"/>
+              </a:ext>
+            </a:extLst>
+          </p:cNvPr>
+          <p:cNvSpPr txBox="1"/>
+          <p:nvPr/>
+        </p:nvSpPr>
+        <p:spPr>
+          <a:xfrm>
+            <a:off x="1102936" y="1828800"/>
+            <a:ext cx="10077254" cy="369332"/>
+          </a:xfrm>
+          <a:prstGeom prst="rect">
+            <a:avLst/>
+          </a:prstGeom>
+          <a:noFill/>
+        </p:spPr>
+        <p:txBody>
+          <a:bodyPr wrap="square" rtlCol="0">
+            <a:spAutoFit/>
+          </a:bodyPr>
+          <a:lstStyle/>
+          <a:p>
+            <a:r>
+              <a:rPr lang="ko-KR" altLang="en-US" dirty="0"/>
+              <a:t>작업을 한번 더 검토하고 개선</a:t>
+            </a:r>
+          </a:p>
+        </p:txBody>
+      </p:sp>
+    </p:spTree>
+    <p:extLst>
+      <p:ext uri="{BB962C8B-B14F-4D97-AF65-F5344CB8AC3E}">
+        <p14:creationId xmlns:p14="http://schemas.microsoft.com/office/powerpoint/2010/main" val="3582645582"/>
+      </p:ext>
+    </p:extLst>
+  </p:cSld>
+  <p:clrMapOvr>
+    <a:masterClrMapping/>
+  </p:clrMapOvr>
+</p:sld>
+</file>
+
+<file path=ppt/slides/slide16.xml><?xml version="1.0" encoding="utf-8"?>
+<p:sld xmlns:a="http://schemas.openxmlformats.org/drawingml/2006/main" xmlns:r="http://schemas.openxmlformats.org/officeDocument/2006/relationships" xmlns:p="http://schemas.openxmlformats.org/presentationml/2006/main">
+  <p:cSld>
+    <p:spTree>
+      <p:nvGrpSpPr>
+        <p:cNvPr id="1" name=""/>
+        <p:cNvGrpSpPr/>
+        <p:nvPr/>
+      </p:nvGrpSpPr>
+      <p:grpSpPr>
+        <a:xfrm>
+          <a:off x="0" y="0"/>
+          <a:ext cx="0" cy="0"/>
+          <a:chOff x="0" y="0"/>
+          <a:chExt cx="0" cy="0"/>
+        </a:xfrm>
+      </p:grpSpPr>
+      <p:sp>
+        <p:nvSpPr>
+          <p:cNvPr id="2" name="제목 1">
+            <a:extLst>
+              <a:ext uri="{FF2B5EF4-FFF2-40B4-BE49-F238E27FC236}">
+                <a16:creationId xmlns:a16="http://schemas.microsoft.com/office/drawing/2014/main" id="{7F66CF5A-F335-6FEB-61AC-A1B475503E79}"/>
+              </a:ext>
+            </a:extLst>
+          </p:cNvPr>
+          <p:cNvSpPr>
+            <a:spLocks noGrp="1"/>
+          </p:cNvSpPr>
+          <p:nvPr>
+            <p:ph type="title"/>
+          </p:nvPr>
+        </p:nvSpPr>
+        <p:spPr/>
+        <p:txBody>
+          <a:bodyPr/>
+          <a:lstStyle/>
+          <a:p>
+            <a:r>
+              <a:rPr lang="en-US" altLang="ko-KR" dirty="0" err="1"/>
+              <a:t>Analyze_task</a:t>
+            </a:r>
+            <a:endParaRPr lang="ko-KR" altLang="en-US" dirty="0"/>
+          </a:p>
+        </p:txBody>
+      </p:sp>
+    </p:spTree>
+    <p:extLst>
+      <p:ext uri="{BB962C8B-B14F-4D97-AF65-F5344CB8AC3E}">
+        <p14:creationId xmlns:p14="http://schemas.microsoft.com/office/powerpoint/2010/main" val="2110787744"/>
+      </p:ext>
+    </p:extLst>
+  </p:cSld>
+  <p:clrMapOvr>
+    <a:masterClrMapping/>
+  </p:clrMapOvr>
+</p:sld>
+</file>
+
+<file path=ppt/slides/slide17.xml><?xml version="1.0" encoding="utf-8"?>
+<p:sld xmlns:a="http://schemas.openxmlformats.org/drawingml/2006/main" xmlns:r="http://schemas.openxmlformats.org/officeDocument/2006/relationships" xmlns:p="http://schemas.openxmlformats.org/presentationml/2006/main">
+  <p:cSld>
+    <p:spTree>
+      <p:nvGrpSpPr>
+        <p:cNvPr id="1" name=""/>
+        <p:cNvGrpSpPr/>
+        <p:nvPr/>
+      </p:nvGrpSpPr>
+      <p:grpSpPr>
+        <a:xfrm>
+          <a:off x="0" y="0"/>
+          <a:ext cx="0" cy="0"/>
+          <a:chOff x="0" y="0"/>
+          <a:chExt cx="0" cy="0"/>
+        </a:xfrm>
+      </p:grpSpPr>
+      <p:sp>
+        <p:nvSpPr>
+          <p:cNvPr id="2" name="제목 1">
+            <a:extLst>
+              <a:ext uri="{FF2B5EF4-FFF2-40B4-BE49-F238E27FC236}">
+                <a16:creationId xmlns:a16="http://schemas.microsoft.com/office/drawing/2014/main" id="{158EEEB0-2A0D-8A82-CF98-96628313224F}"/>
+              </a:ext>
+            </a:extLst>
+          </p:cNvPr>
+          <p:cNvSpPr>
+            <a:spLocks noGrp="1"/>
+          </p:cNvSpPr>
+          <p:nvPr>
+            <p:ph type="title"/>
+          </p:nvPr>
+        </p:nvSpPr>
+        <p:spPr/>
+        <p:txBody>
+          <a:bodyPr/>
+          <a:lstStyle/>
+          <a:p>
+            <a:r>
+              <a:rPr lang="en-US" altLang="ko-KR" dirty="0" err="1"/>
+              <a:t>Verify_task</a:t>
+            </a:r>
+            <a:endParaRPr lang="ko-KR" altLang="en-US" dirty="0"/>
+          </a:p>
+        </p:txBody>
+      </p:sp>
+      <p:sp>
+        <p:nvSpPr>
+          <p:cNvPr id="3" name="TextBox 2">
+            <a:extLst>
+              <a:ext uri="{FF2B5EF4-FFF2-40B4-BE49-F238E27FC236}">
+                <a16:creationId xmlns:a16="http://schemas.microsoft.com/office/drawing/2014/main" id="{B691990F-E311-6CEB-9EFE-751AD519F85D}"/>
+              </a:ext>
+            </a:extLst>
+          </p:cNvPr>
+          <p:cNvSpPr txBox="1"/>
+          <p:nvPr/>
+        </p:nvSpPr>
+        <p:spPr>
+          <a:xfrm>
+            <a:off x="1112363" y="1894788"/>
+            <a:ext cx="10105534" cy="369332"/>
+          </a:xfrm>
+          <a:prstGeom prst="rect">
+            <a:avLst/>
+          </a:prstGeom>
+          <a:noFill/>
+        </p:spPr>
+        <p:txBody>
+          <a:bodyPr wrap="square" rtlCol="0">
+            <a:spAutoFit/>
+          </a:bodyPr>
+          <a:lstStyle/>
+          <a:p>
+            <a:r>
+              <a:rPr lang="ko-KR" altLang="en-US" dirty="0"/>
+              <a:t>완료</a:t>
+            </a:r>
+            <a:r>
+              <a:rPr lang="en-US" altLang="ko-KR" dirty="0"/>
+              <a:t> </a:t>
+            </a:r>
+            <a:r>
+              <a:rPr lang="ko-KR" altLang="en-US" dirty="0"/>
+              <a:t>여부를 점수로 판정하는 </a:t>
+            </a:r>
+            <a:r>
+              <a:rPr lang="en-US" altLang="ko-KR" dirty="0"/>
+              <a:t>“</a:t>
+            </a:r>
+            <a:r>
+              <a:rPr lang="ko-KR" altLang="en-US" dirty="0"/>
+              <a:t>자가 채점</a:t>
+            </a:r>
+            <a:r>
+              <a:rPr lang="en-US" altLang="ko-KR" dirty="0"/>
+              <a:t>“ </a:t>
+            </a:r>
+            <a:r>
+              <a:rPr lang="ko-KR" altLang="en-US" dirty="0"/>
+              <a:t>명령어</a:t>
+            </a:r>
+          </a:p>
+        </p:txBody>
+      </p:sp>
+    </p:spTree>
+    <p:extLst>
+      <p:ext uri="{BB962C8B-B14F-4D97-AF65-F5344CB8AC3E}">
+        <p14:creationId xmlns:p14="http://schemas.microsoft.com/office/powerpoint/2010/main" val="3729531038"/>
       </p:ext>
     </p:extLst>
   </p:cSld>
@@ -3896,7 +4994,7 @@
           <p:cNvPr id="2" name="제목 1">
             <a:extLst>
               <a:ext uri="{FF2B5EF4-FFF2-40B4-BE49-F238E27FC236}">
-                <a16:creationId xmlns:a16="http://schemas.microsoft.com/office/drawing/2014/main" id="{BAA11D4E-5DA3-55D9-3369-0B6E07C30DFE}"/>
+                <a16:creationId xmlns:a16="http://schemas.microsoft.com/office/drawing/2014/main" id="{AD8A72FA-8098-D89A-5F61-F6590825F580}"/>
               </a:ext>
             </a:extLst>
           </p:cNvPr>
@@ -3914,89 +5012,70 @@
           <a:p>
             <a:r>
               <a:rPr lang="en-US" altLang="ko-KR" dirty="0"/>
-              <a:t>Task Master AI </a:t>
+              <a:t>Shrimp</a:t>
             </a:r>
             <a:r>
               <a:rPr lang="ko-KR" altLang="en-US" dirty="0"/>
-              <a:t>필요성</a:t>
-            </a:r>
-          </a:p>
-        </p:txBody>
-      </p:sp>
-      <p:sp>
-        <p:nvSpPr>
-          <p:cNvPr id="3" name="TextBox 2">
+              <a:t> </a:t>
+            </a:r>
+            <a:r>
+              <a:rPr lang="en-US" altLang="ko-KR" dirty="0"/>
+              <a:t>Task</a:t>
+            </a:r>
+            <a:r>
+              <a:rPr lang="ko-KR" altLang="en-US" dirty="0"/>
+              <a:t> </a:t>
+            </a:r>
+            <a:r>
+              <a:rPr lang="en-US" altLang="ko-KR" dirty="0"/>
+              <a:t>Manager</a:t>
+            </a:r>
+            <a:r>
+              <a:rPr lang="ko-KR" altLang="en-US" dirty="0"/>
+              <a:t> 학습 참고 주소</a:t>
+            </a:r>
+          </a:p>
+        </p:txBody>
+      </p:sp>
+      <p:sp>
+        <p:nvSpPr>
+          <p:cNvPr id="3" name="내용 개체 틀 2">
             <a:extLst>
               <a:ext uri="{FF2B5EF4-FFF2-40B4-BE49-F238E27FC236}">
-                <a16:creationId xmlns:a16="http://schemas.microsoft.com/office/drawing/2014/main" id="{4E50AEAF-F878-617B-C129-0C86D0245D8B}"/>
+                <a16:creationId xmlns:a16="http://schemas.microsoft.com/office/drawing/2014/main" id="{B11B345C-152A-95E6-E664-1ECE63F2F185}"/>
               </a:ext>
             </a:extLst>
           </p:cNvPr>
-          <p:cNvSpPr txBox="1"/>
-          <p:nvPr/>
-        </p:nvSpPr>
-        <p:spPr>
-          <a:xfrm>
-            <a:off x="1253765" y="1913641"/>
-            <a:ext cx="9901915" cy="1200329"/>
-          </a:xfrm>
-          <a:prstGeom prst="rect">
-            <a:avLst/>
-          </a:prstGeom>
-          <a:noFill/>
-        </p:spPr>
-        <p:txBody>
-          <a:bodyPr wrap="square" rtlCol="0">
-            <a:spAutoFit/>
-          </a:bodyPr>
-          <a:lstStyle/>
-          <a:p>
+          <p:cNvSpPr>
+            <a:spLocks noGrp="1"/>
+          </p:cNvSpPr>
+          <p:nvPr>
+            <p:ph idx="1"/>
+          </p:nvPr>
+        </p:nvSpPr>
+        <p:spPr/>
+        <p:txBody>
+          <a:bodyPr/>
+          <a:lstStyle/>
+          <a:p>
+            <a:r>
+              <a:rPr lang="ko-KR" altLang="en-US" dirty="0"/>
+              <a:t>참고 주소 </a:t>
+            </a:r>
             <a:r>
               <a:rPr lang="en-US" altLang="ko-KR" dirty="0"/>
-              <a:t>1. AI </a:t>
-            </a:r>
-            <a:r>
-              <a:rPr lang="ko-KR" altLang="en-US" dirty="0" err="1"/>
-              <a:t>개발시</a:t>
-            </a:r>
-            <a:r>
-              <a:rPr lang="ko-KR" altLang="en-US" dirty="0"/>
-              <a:t> 갑자기 이상한 방향으로 개발하는 경우</a:t>
-            </a:r>
-            <a:r>
-              <a:rPr lang="en-US" altLang="ko-KR" dirty="0"/>
-              <a:t>. </a:t>
-            </a:r>
-            <a:br>
-              <a:rPr lang="en-US" altLang="ko-KR" dirty="0"/>
-            </a:br>
-            <a:r>
-              <a:rPr lang="en-US" altLang="ko-KR" dirty="0"/>
-              <a:t>2. </a:t>
-            </a:r>
-            <a:r>
-              <a:rPr lang="ko-KR" altLang="en-US" dirty="0"/>
-              <a:t>개발했던 기능을 다시 개발하려는 경우</a:t>
-            </a:r>
-            <a:r>
-              <a:rPr lang="en-US" altLang="ko-KR" dirty="0"/>
-              <a:t>.</a:t>
-            </a:r>
-            <a:br>
-              <a:rPr lang="en-US" altLang="ko-KR" dirty="0"/>
-            </a:br>
-            <a:r>
-              <a:rPr lang="en-US" altLang="ko-KR" dirty="0"/>
-              <a:t>3. </a:t>
-            </a:r>
-            <a:r>
-              <a:rPr lang="ko-KR" altLang="en-US" dirty="0"/>
-              <a:t>요청하지 않은 기능이지만 방대한 기능을 작성하는 경우</a:t>
-            </a:r>
-            <a:r>
-              <a:rPr lang="en-US" altLang="ko-KR" dirty="0"/>
-              <a:t>.</a:t>
-            </a:r>
+              <a:t>: </a:t>
+            </a:r>
+            <a:r>
+              <a:rPr lang="ko-KR" altLang="en-US" dirty="0">
+                <a:hlinkClick r:id="rId2"/>
+              </a:rPr>
+              <a:t>https://glama.ai/mcp/servers/cjo4m06/mcp-shrimp-task-manager?locale=ko-KR</a:t>
+            </a:r>
+            <a:endParaRPr lang="en-US" altLang="ko-KR" dirty="0"/>
+          </a:p>
+          <a:p>
+            <a:endParaRPr lang="ko-KR" altLang="en-US" dirty="0"/>
           </a:p>
           <a:p>
             <a:endParaRPr lang="ko-KR" altLang="en-US" dirty="0"/>
@@ -4006,7 +5085,7 @@
     </p:spTree>
     <p:extLst>
       <p:ext uri="{BB962C8B-B14F-4D97-AF65-F5344CB8AC3E}">
-        <p14:creationId xmlns:p14="http://schemas.microsoft.com/office/powerpoint/2010/main" val="1416959602"/>
+        <p14:creationId xmlns:p14="http://schemas.microsoft.com/office/powerpoint/2010/main" val="2124418163"/>
       </p:ext>
     </p:extLst>
   </p:cSld>
@@ -4038,7 +5117,7 @@
           <p:cNvPr id="2" name="제목 1">
             <a:extLst>
               <a:ext uri="{FF2B5EF4-FFF2-40B4-BE49-F238E27FC236}">
-                <a16:creationId xmlns:a16="http://schemas.microsoft.com/office/drawing/2014/main" id="{4413AA87-59CB-468E-DBA7-6F1A5DEA98A9}"/>
+                <a16:creationId xmlns:a16="http://schemas.microsoft.com/office/drawing/2014/main" id="{BAA11D4E-5DA3-55D9-3369-0B6E07C30DFE}"/>
               </a:ext>
             </a:extLst>
           </p:cNvPr>
@@ -4056,9 +5135,1264 @@
           <a:p>
             <a:r>
               <a:rPr lang="en-US" altLang="ko-KR" dirty="0"/>
-              <a:t>Cli - Install </a:t>
+              <a:t>Shrimp Task </a:t>
+            </a:r>
+            <a:r>
+              <a:rPr lang="en-US" altLang="ko-KR" dirty="0" err="1"/>
+              <a:t>Mananger</a:t>
+            </a:r>
+            <a:r>
+              <a:rPr lang="en-US" altLang="ko-KR" dirty="0"/>
+              <a:t> </a:t>
+            </a:r>
+            <a:r>
+              <a:rPr lang="ko-KR" altLang="en-US" dirty="0"/>
+              <a:t>설치</a:t>
+            </a:r>
+            <a:r>
+              <a:rPr lang="en-US" altLang="ko-KR" dirty="0"/>
+              <a:t>-1</a:t>
             </a:r>
             <a:endParaRPr lang="ko-KR" altLang="en-US" dirty="0"/>
+          </a:p>
+        </p:txBody>
+      </p:sp>
+      <p:sp>
+        <p:nvSpPr>
+          <p:cNvPr id="5" name="TextBox 4">
+            <a:extLst>
+              <a:ext uri="{FF2B5EF4-FFF2-40B4-BE49-F238E27FC236}">
+                <a16:creationId xmlns:a16="http://schemas.microsoft.com/office/drawing/2014/main" id="{4E84AFE9-B46F-E195-9D5B-88F1AF06B165}"/>
+              </a:ext>
+            </a:extLst>
+          </p:cNvPr>
+          <p:cNvSpPr txBox="1"/>
+          <p:nvPr/>
+        </p:nvSpPr>
+        <p:spPr>
+          <a:xfrm>
+            <a:off x="1097280" y="1816718"/>
+            <a:ext cx="7567366" cy="461665"/>
+          </a:xfrm>
+          <a:prstGeom prst="rect">
+            <a:avLst/>
+          </a:prstGeom>
+          <a:noFill/>
+        </p:spPr>
+        <p:txBody>
+          <a:bodyPr wrap="square">
+            <a:spAutoFit/>
+          </a:bodyPr>
+          <a:lstStyle/>
+          <a:p>
+            <a:r>
+              <a:rPr lang="ko-KR" altLang="en-US" sz="1200" dirty="0"/>
+              <a:t>참고 주소 </a:t>
+            </a:r>
+            <a:r>
+              <a:rPr lang="en-US" altLang="ko-KR" sz="1200" dirty="0"/>
+              <a:t>: </a:t>
+            </a:r>
+            <a:r>
+              <a:rPr lang="en-US" altLang="ko-KR" sz="1200" dirty="0">
+                <a:hlinkClick r:id="rId2"/>
+              </a:rPr>
+              <a:t>https://github.com/cjo4m06/mcp-shrimp-task-manager/tree/main#installation</a:t>
+            </a:r>
+            <a:r>
+              <a:rPr lang="en-US" altLang="ko-KR" sz="1200" dirty="0"/>
+              <a:t> </a:t>
+            </a:r>
+          </a:p>
+          <a:p>
+            <a:endParaRPr lang="ko-KR" altLang="en-US" sz="1200" dirty="0"/>
+          </a:p>
+        </p:txBody>
+      </p:sp>
+      <p:pic>
+        <p:nvPicPr>
+          <p:cNvPr id="11" name="그림 10">
+            <a:extLst>
+              <a:ext uri="{FF2B5EF4-FFF2-40B4-BE49-F238E27FC236}">
+                <a16:creationId xmlns:a16="http://schemas.microsoft.com/office/drawing/2014/main" id="{4EF0E293-1C2A-F891-A1FE-6AA219EB6CE6}"/>
+              </a:ext>
+            </a:extLst>
+          </p:cNvPr>
+          <p:cNvPicPr>
+            <a:picLocks noChangeAspect="1"/>
+          </p:cNvPicPr>
+          <p:nvPr/>
+        </p:nvPicPr>
+        <p:blipFill>
+          <a:blip r:embed="rId3"/>
+          <a:stretch>
+            <a:fillRect/>
+          </a:stretch>
+        </p:blipFill>
+        <p:spPr>
+          <a:xfrm>
+            <a:off x="262291" y="2278383"/>
+            <a:ext cx="5864189" cy="3843421"/>
+          </a:xfrm>
+          <a:prstGeom prst="rect">
+            <a:avLst/>
+          </a:prstGeom>
+          <a:ln>
+            <a:solidFill>
+              <a:schemeClr val="tx1"/>
+            </a:solidFill>
+          </a:ln>
+        </p:spPr>
+      </p:pic>
+      <p:pic>
+        <p:nvPicPr>
+          <p:cNvPr id="13" name="그림 12">
+            <a:extLst>
+              <a:ext uri="{FF2B5EF4-FFF2-40B4-BE49-F238E27FC236}">
+                <a16:creationId xmlns:a16="http://schemas.microsoft.com/office/drawing/2014/main" id="{912FE791-EA9A-99BC-5510-D8520F73CBC6}"/>
+              </a:ext>
+            </a:extLst>
+          </p:cNvPr>
+          <p:cNvPicPr>
+            <a:picLocks noChangeAspect="1"/>
+          </p:cNvPicPr>
+          <p:nvPr/>
+        </p:nvPicPr>
+        <p:blipFill>
+          <a:blip r:embed="rId4"/>
+          <a:stretch>
+            <a:fillRect/>
+          </a:stretch>
+        </p:blipFill>
+        <p:spPr>
+          <a:xfrm>
+            <a:off x="4959695" y="2278383"/>
+            <a:ext cx="6043406" cy="1841130"/>
+          </a:xfrm>
+          <a:prstGeom prst="rect">
+            <a:avLst/>
+          </a:prstGeom>
+          <a:ln>
+            <a:solidFill>
+              <a:schemeClr val="tx1"/>
+            </a:solidFill>
+          </a:ln>
+        </p:spPr>
+      </p:pic>
+    </p:spTree>
+    <p:extLst>
+      <p:ext uri="{BB962C8B-B14F-4D97-AF65-F5344CB8AC3E}">
+        <p14:creationId xmlns:p14="http://schemas.microsoft.com/office/powerpoint/2010/main" val="1416959602"/>
+      </p:ext>
+    </p:extLst>
+  </p:cSld>
+  <p:clrMapOvr>
+    <a:masterClrMapping/>
+  </p:clrMapOvr>
+</p:sld>
+</file>
+
+<file path=ppt/slides/slide4.xml><?xml version="1.0" encoding="utf-8"?>
+<p:sld xmlns:a="http://schemas.openxmlformats.org/drawingml/2006/main" xmlns:r="http://schemas.openxmlformats.org/officeDocument/2006/relationships" xmlns:p="http://schemas.openxmlformats.org/presentationml/2006/main">
+  <p:cSld>
+    <p:spTree>
+      <p:nvGrpSpPr>
+        <p:cNvPr id="1" name="">
+          <a:extLst>
+            <a:ext uri="{FF2B5EF4-FFF2-40B4-BE49-F238E27FC236}">
+              <a16:creationId xmlns:a16="http://schemas.microsoft.com/office/drawing/2014/main" id="{77CEFAD2-0E27-E4C7-9641-E86256F9D3D7}"/>
+            </a:ext>
+          </a:extLst>
+        </p:cNvPr>
+        <p:cNvGrpSpPr/>
+        <p:nvPr/>
+      </p:nvGrpSpPr>
+      <p:grpSpPr>
+        <a:xfrm>
+          <a:off x="0" y="0"/>
+          <a:ext cx="0" cy="0"/>
+          <a:chOff x="0" y="0"/>
+          <a:chExt cx="0" cy="0"/>
+        </a:xfrm>
+      </p:grpSpPr>
+      <p:sp>
+        <p:nvSpPr>
+          <p:cNvPr id="2" name="제목 1">
+            <a:extLst>
+              <a:ext uri="{FF2B5EF4-FFF2-40B4-BE49-F238E27FC236}">
+                <a16:creationId xmlns:a16="http://schemas.microsoft.com/office/drawing/2014/main" id="{4B7ACF83-A82B-4593-6E34-4EA1898A3091}"/>
+              </a:ext>
+            </a:extLst>
+          </p:cNvPr>
+          <p:cNvSpPr>
+            <a:spLocks noGrp="1"/>
+          </p:cNvSpPr>
+          <p:nvPr>
+            <p:ph type="title"/>
+          </p:nvPr>
+        </p:nvSpPr>
+        <p:spPr/>
+        <p:txBody>
+          <a:bodyPr/>
+          <a:lstStyle/>
+          <a:p>
+            <a:r>
+              <a:rPr lang="en-US" altLang="ko-KR" dirty="0"/>
+              <a:t>Shrimp Task </a:t>
+            </a:r>
+            <a:r>
+              <a:rPr lang="en-US" altLang="ko-KR" dirty="0" err="1"/>
+              <a:t>Mananger</a:t>
+            </a:r>
+            <a:r>
+              <a:rPr lang="en-US" altLang="ko-KR" dirty="0"/>
+              <a:t> </a:t>
+            </a:r>
+            <a:r>
+              <a:rPr lang="ko-KR" altLang="en-US" dirty="0"/>
+              <a:t>설치</a:t>
+            </a:r>
+            <a:r>
+              <a:rPr lang="en-US" altLang="ko-KR" dirty="0"/>
+              <a:t>-2</a:t>
+            </a:r>
+            <a:endParaRPr lang="ko-KR" altLang="en-US" dirty="0"/>
+          </a:p>
+        </p:txBody>
+      </p:sp>
+      <p:sp>
+        <p:nvSpPr>
+          <p:cNvPr id="5" name="TextBox 4">
+            <a:extLst>
+              <a:ext uri="{FF2B5EF4-FFF2-40B4-BE49-F238E27FC236}">
+                <a16:creationId xmlns:a16="http://schemas.microsoft.com/office/drawing/2014/main" id="{D2909DAE-244E-1A1A-9B63-B20BE911635D}"/>
+              </a:ext>
+            </a:extLst>
+          </p:cNvPr>
+          <p:cNvSpPr txBox="1"/>
+          <p:nvPr/>
+        </p:nvSpPr>
+        <p:spPr>
+          <a:xfrm>
+            <a:off x="1097280" y="1816718"/>
+            <a:ext cx="7567366" cy="461665"/>
+          </a:xfrm>
+          <a:prstGeom prst="rect">
+            <a:avLst/>
+          </a:prstGeom>
+          <a:noFill/>
+        </p:spPr>
+        <p:txBody>
+          <a:bodyPr wrap="square">
+            <a:spAutoFit/>
+          </a:bodyPr>
+          <a:lstStyle/>
+          <a:p>
+            <a:r>
+              <a:rPr lang="ko-KR" altLang="en-US" sz="1200" dirty="0"/>
+              <a:t>참고 주소 </a:t>
+            </a:r>
+            <a:r>
+              <a:rPr lang="en-US" altLang="ko-KR" sz="1200" dirty="0"/>
+              <a:t>: </a:t>
+            </a:r>
+            <a:r>
+              <a:rPr lang="en-US" altLang="ko-KR" sz="1200" dirty="0">
+                <a:hlinkClick r:id="rId2"/>
+              </a:rPr>
+              <a:t>https://github.com/cjo4m06/mcp-shrimp-task-manager/tree/main#installation</a:t>
+            </a:r>
+            <a:r>
+              <a:rPr lang="en-US" altLang="ko-KR" sz="1200" dirty="0"/>
+              <a:t> </a:t>
+            </a:r>
+          </a:p>
+          <a:p>
+            <a:endParaRPr lang="ko-KR" altLang="en-US" sz="1200" dirty="0"/>
+          </a:p>
+        </p:txBody>
+      </p:sp>
+      <p:sp>
+        <p:nvSpPr>
+          <p:cNvPr id="4" name="TextBox 3">
+            <a:extLst>
+              <a:ext uri="{FF2B5EF4-FFF2-40B4-BE49-F238E27FC236}">
+                <a16:creationId xmlns:a16="http://schemas.microsoft.com/office/drawing/2014/main" id="{5ED099D0-85CD-7197-D035-B942A4FA51D6}"/>
+              </a:ext>
+            </a:extLst>
+          </p:cNvPr>
+          <p:cNvSpPr txBox="1"/>
+          <p:nvPr/>
+        </p:nvSpPr>
+        <p:spPr>
+          <a:xfrm>
+            <a:off x="690514" y="2202969"/>
+            <a:ext cx="6094428" cy="2462213"/>
+          </a:xfrm>
+          <a:prstGeom prst="rect">
+            <a:avLst/>
+          </a:prstGeom>
+          <a:noFill/>
+        </p:spPr>
+        <p:txBody>
+          <a:bodyPr wrap="square">
+            <a:spAutoFit/>
+          </a:bodyPr>
+          <a:lstStyle/>
+          <a:p>
+            <a:r>
+              <a:rPr lang="en-US" altLang="ko-KR" sz="1100" dirty="0">
+                <a:sym typeface="Wingdings" panose="05000000000000000000" pitchFamily="2" charset="2"/>
+              </a:rPr>
+              <a:t> </a:t>
+            </a:r>
+            <a:r>
+              <a:rPr lang="en-US" altLang="ko-KR" sz="1100" dirty="0" err="1"/>
+              <a:t>mcp.json</a:t>
+            </a:r>
+            <a:br>
+              <a:rPr lang="en-US" altLang="ko-KR" sz="1100" dirty="0"/>
+            </a:br>
+            <a:r>
+              <a:rPr lang="ko-KR" altLang="en-US" sz="1100" dirty="0"/>
+              <a:t>{</a:t>
+            </a:r>
+          </a:p>
+          <a:p>
+            <a:r>
+              <a:rPr lang="ko-KR" altLang="en-US" sz="1100" dirty="0"/>
+              <a:t>  "</a:t>
+            </a:r>
+            <a:r>
+              <a:rPr lang="ko-KR" altLang="en-US" sz="1100" dirty="0" err="1"/>
+              <a:t>mcpServers</a:t>
+            </a:r>
+            <a:r>
+              <a:rPr lang="ko-KR" altLang="en-US" sz="1100" dirty="0"/>
+              <a:t>": {</a:t>
+            </a:r>
+          </a:p>
+          <a:p>
+            <a:r>
+              <a:rPr lang="ko-KR" altLang="en-US" sz="1100" dirty="0"/>
+              <a:t>    "</a:t>
+            </a:r>
+            <a:r>
+              <a:rPr lang="ko-KR" altLang="en-US" sz="1100" dirty="0" err="1"/>
+              <a:t>shrimp-task-manager</a:t>
+            </a:r>
+            <a:r>
+              <a:rPr lang="ko-KR" altLang="en-US" sz="1100" dirty="0"/>
+              <a:t>": {</a:t>
+            </a:r>
+          </a:p>
+          <a:p>
+            <a:r>
+              <a:rPr lang="ko-KR" altLang="en-US" sz="1100" dirty="0"/>
+              <a:t>      "</a:t>
+            </a:r>
+            <a:r>
+              <a:rPr lang="ko-KR" altLang="en-US" sz="1100" dirty="0" err="1"/>
+              <a:t>command</a:t>
+            </a:r>
+            <a:r>
+              <a:rPr lang="ko-KR" altLang="en-US" sz="1100" dirty="0"/>
+              <a:t>": "</a:t>
+            </a:r>
+            <a:r>
+              <a:rPr lang="ko-KR" altLang="en-US" sz="1100" dirty="0" err="1"/>
+              <a:t>node</a:t>
+            </a:r>
+            <a:r>
+              <a:rPr lang="ko-KR" altLang="en-US" sz="1100" dirty="0"/>
+              <a:t>",</a:t>
+            </a:r>
+          </a:p>
+          <a:p>
+            <a:r>
+              <a:rPr lang="ko-KR" altLang="en-US" sz="1100" dirty="0"/>
+              <a:t>      "</a:t>
+            </a:r>
+            <a:r>
+              <a:rPr lang="ko-KR" altLang="en-US" sz="1100" dirty="0" err="1"/>
+              <a:t>args</a:t>
+            </a:r>
+            <a:r>
+              <a:rPr lang="ko-KR" altLang="en-US" sz="1100" dirty="0"/>
+              <a:t>": ["/</a:t>
+            </a:r>
+            <a:r>
+              <a:rPr lang="ko-KR" altLang="en-US" sz="1100" dirty="0" err="1"/>
+              <a:t>path</a:t>
+            </a:r>
+            <a:r>
+              <a:rPr lang="ko-KR" altLang="en-US" sz="1100" dirty="0"/>
+              <a:t>/</a:t>
+            </a:r>
+            <a:r>
+              <a:rPr lang="ko-KR" altLang="en-US" sz="1100" dirty="0" err="1"/>
+              <a:t>to</a:t>
+            </a:r>
+            <a:r>
+              <a:rPr lang="ko-KR" altLang="en-US" sz="1100" dirty="0"/>
+              <a:t>/</a:t>
+            </a:r>
+            <a:r>
+              <a:rPr lang="ko-KR" altLang="en-US" sz="1100" dirty="0" err="1"/>
+              <a:t>mcp-shrimp-task-manager</a:t>
+            </a:r>
+            <a:r>
+              <a:rPr lang="ko-KR" altLang="en-US" sz="1100" dirty="0"/>
+              <a:t>/</a:t>
+            </a:r>
+            <a:r>
+              <a:rPr lang="ko-KR" altLang="en-US" sz="1100" dirty="0" err="1"/>
+              <a:t>dist</a:t>
+            </a:r>
+            <a:r>
+              <a:rPr lang="ko-KR" altLang="en-US" sz="1100" dirty="0"/>
+              <a:t>/</a:t>
+            </a:r>
+            <a:r>
+              <a:rPr lang="ko-KR" altLang="en-US" sz="1100" dirty="0" err="1"/>
+              <a:t>index.js</a:t>
+            </a:r>
+            <a:r>
+              <a:rPr lang="ko-KR" altLang="en-US" sz="1100" dirty="0"/>
+              <a:t>"],</a:t>
+            </a:r>
+          </a:p>
+          <a:p>
+            <a:r>
+              <a:rPr lang="ko-KR" altLang="en-US" sz="1100" dirty="0"/>
+              <a:t>      "</a:t>
+            </a:r>
+            <a:r>
+              <a:rPr lang="ko-KR" altLang="en-US" sz="1100" dirty="0" err="1"/>
+              <a:t>env</a:t>
+            </a:r>
+            <a:r>
+              <a:rPr lang="ko-KR" altLang="en-US" sz="1100" dirty="0"/>
+              <a:t>": {</a:t>
+            </a:r>
+          </a:p>
+          <a:p>
+            <a:r>
+              <a:rPr lang="ko-KR" altLang="en-US" sz="1100" dirty="0"/>
+              <a:t>        "DATA_DIR": "/</a:t>
+            </a:r>
+            <a:r>
+              <a:rPr lang="ko-KR" altLang="en-US" sz="1100" dirty="0" err="1"/>
+              <a:t>path</a:t>
+            </a:r>
+            <a:r>
+              <a:rPr lang="ko-KR" altLang="en-US" sz="1100" dirty="0"/>
+              <a:t>/</a:t>
+            </a:r>
+            <a:r>
+              <a:rPr lang="ko-KR" altLang="en-US" sz="1100" dirty="0" err="1"/>
+              <a:t>to</a:t>
+            </a:r>
+            <a:r>
+              <a:rPr lang="ko-KR" altLang="en-US" sz="1100" dirty="0"/>
+              <a:t>/</a:t>
+            </a:r>
+            <a:r>
+              <a:rPr lang="ko-KR" altLang="en-US" sz="1100" dirty="0" err="1"/>
+              <a:t>your</a:t>
+            </a:r>
+            <a:r>
+              <a:rPr lang="ko-KR" altLang="en-US" sz="1100" dirty="0"/>
+              <a:t>/</a:t>
+            </a:r>
+            <a:r>
+              <a:rPr lang="ko-KR" altLang="en-US" sz="1100" dirty="0" err="1"/>
+              <a:t>shrimp_data</a:t>
+            </a:r>
+            <a:r>
+              <a:rPr lang="ko-KR" altLang="en-US" sz="1100" dirty="0"/>
+              <a:t>",</a:t>
+            </a:r>
+          </a:p>
+          <a:p>
+            <a:r>
+              <a:rPr lang="ko-KR" altLang="en-US" sz="1100" dirty="0"/>
+              <a:t>        "TEMPLATES_USE": "</a:t>
+            </a:r>
+            <a:r>
+              <a:rPr lang="ko-KR" altLang="en-US" sz="1100" dirty="0" err="1"/>
+              <a:t>en</a:t>
+            </a:r>
+            <a:r>
+              <a:rPr lang="ko-KR" altLang="en-US" sz="1100" dirty="0"/>
+              <a:t>",</a:t>
+            </a:r>
+          </a:p>
+          <a:p>
+            <a:r>
+              <a:rPr lang="ko-KR" altLang="en-US" sz="1100" dirty="0"/>
+              <a:t>        "ENABLE_GUI": "</a:t>
+            </a:r>
+            <a:r>
+              <a:rPr lang="ko-KR" altLang="en-US" sz="1100" dirty="0" err="1"/>
+              <a:t>false</a:t>
+            </a:r>
+            <a:r>
+              <a:rPr lang="ko-KR" altLang="en-US" sz="1100" dirty="0"/>
+              <a:t>"</a:t>
+            </a:r>
+          </a:p>
+          <a:p>
+            <a:r>
+              <a:rPr lang="ko-KR" altLang="en-US" sz="1100" dirty="0"/>
+              <a:t>      }</a:t>
+            </a:r>
+          </a:p>
+          <a:p>
+            <a:r>
+              <a:rPr lang="ko-KR" altLang="en-US" sz="1100" dirty="0"/>
+              <a:t>    }</a:t>
+            </a:r>
+          </a:p>
+          <a:p>
+            <a:r>
+              <a:rPr lang="ko-KR" altLang="en-US" sz="1100" dirty="0"/>
+              <a:t>  }</a:t>
+            </a:r>
+          </a:p>
+          <a:p>
+            <a:r>
+              <a:rPr lang="ko-KR" altLang="en-US" sz="1100" dirty="0"/>
+              <a:t>}</a:t>
+            </a:r>
+          </a:p>
+        </p:txBody>
+      </p:sp>
+      <p:sp>
+        <p:nvSpPr>
+          <p:cNvPr id="7" name="TextBox 6">
+            <a:extLst>
+              <a:ext uri="{FF2B5EF4-FFF2-40B4-BE49-F238E27FC236}">
+                <a16:creationId xmlns:a16="http://schemas.microsoft.com/office/drawing/2014/main" id="{A9B74653-FE1A-9DBF-F553-C223D5938517}"/>
+              </a:ext>
+            </a:extLst>
+          </p:cNvPr>
+          <p:cNvSpPr txBox="1"/>
+          <p:nvPr/>
+        </p:nvSpPr>
+        <p:spPr>
+          <a:xfrm>
+            <a:off x="5705573" y="2202968"/>
+            <a:ext cx="5700859" cy="2462213"/>
+          </a:xfrm>
+          <a:prstGeom prst="rect">
+            <a:avLst/>
+          </a:prstGeom>
+          <a:noFill/>
+        </p:spPr>
+        <p:txBody>
+          <a:bodyPr wrap="square">
+            <a:spAutoFit/>
+          </a:bodyPr>
+          <a:lstStyle/>
+          <a:p>
+            <a:pPr algn="l" latinLnBrk="0">
+              <a:buNone/>
+            </a:pPr>
+            <a:r>
+              <a:rPr lang="en-US" altLang="ko-KR" sz="1100" b="1" dirty="0">
+                <a:solidFill>
+                  <a:srgbClr val="1F2328"/>
+                </a:solidFill>
+                <a:latin typeface="Monaspace Neon"/>
+              </a:rPr>
+              <a:t>※ Sample Config </a:t>
+            </a:r>
+            <a:br>
+              <a:rPr lang="en-US" altLang="ko-KR" sz="1100" b="0" i="0" dirty="0">
+                <a:solidFill>
+                  <a:srgbClr val="1F2328"/>
+                </a:solidFill>
+                <a:effectLst/>
+                <a:latin typeface="Monaspace Neon"/>
+              </a:rPr>
+            </a:br>
+            <a:r>
+              <a:rPr lang="en-US" altLang="ko-KR" sz="1100" b="0" i="0" dirty="0">
+                <a:solidFill>
+                  <a:srgbClr val="1F2328"/>
+                </a:solidFill>
+                <a:effectLst/>
+                <a:latin typeface="Monaspace Neon"/>
+              </a:rPr>
+              <a:t>{</a:t>
+            </a:r>
+          </a:p>
+          <a:p>
+            <a:pPr algn="l" latinLnBrk="0">
+              <a:buNone/>
+            </a:pPr>
+            <a:r>
+              <a:rPr lang="en-US" altLang="ko-KR" sz="1100" b="0" i="0" dirty="0">
+                <a:solidFill>
+                  <a:srgbClr val="1F2328"/>
+                </a:solidFill>
+                <a:effectLst/>
+                <a:latin typeface="Monaspace Neon"/>
+              </a:rPr>
+              <a:t>  </a:t>
+            </a:r>
+            <a:r>
+              <a:rPr lang="en-US" altLang="ko-KR" sz="1100" b="0" i="0" dirty="0">
+                <a:solidFill>
+                  <a:srgbClr val="0550AE"/>
+                </a:solidFill>
+                <a:effectLst/>
+                <a:latin typeface="Monaspace Neon"/>
+              </a:rPr>
+              <a:t>"</a:t>
+            </a:r>
+            <a:r>
+              <a:rPr lang="en-US" altLang="ko-KR" sz="1100" b="0" i="0" dirty="0" err="1">
+                <a:solidFill>
+                  <a:srgbClr val="0550AE"/>
+                </a:solidFill>
+                <a:effectLst/>
+                <a:latin typeface="Monaspace Neon"/>
+              </a:rPr>
+              <a:t>mcpServers</a:t>
+            </a:r>
+            <a:r>
+              <a:rPr lang="en-US" altLang="ko-KR" sz="1100" b="0" i="0" dirty="0">
+                <a:solidFill>
+                  <a:srgbClr val="0550AE"/>
+                </a:solidFill>
+                <a:effectLst/>
+                <a:latin typeface="Monaspace Neon"/>
+              </a:rPr>
+              <a:t>"</a:t>
+            </a:r>
+            <a:r>
+              <a:rPr lang="en-US" altLang="ko-KR" sz="1100" b="0" i="0" dirty="0">
+                <a:solidFill>
+                  <a:srgbClr val="1F2328"/>
+                </a:solidFill>
+                <a:effectLst/>
+                <a:latin typeface="Monaspace Neon"/>
+              </a:rPr>
+              <a:t>: {</a:t>
+            </a:r>
+          </a:p>
+          <a:p>
+            <a:pPr algn="l" latinLnBrk="0">
+              <a:buNone/>
+            </a:pPr>
+            <a:r>
+              <a:rPr lang="en-US" altLang="ko-KR" sz="1100" b="0" i="0" dirty="0">
+                <a:solidFill>
+                  <a:srgbClr val="1F2328"/>
+                </a:solidFill>
+                <a:effectLst/>
+                <a:latin typeface="Monaspace Neon"/>
+              </a:rPr>
+              <a:t>    </a:t>
+            </a:r>
+            <a:r>
+              <a:rPr lang="en-US" altLang="ko-KR" sz="1100" b="0" i="0" dirty="0">
+                <a:solidFill>
+                  <a:srgbClr val="0550AE"/>
+                </a:solidFill>
+                <a:effectLst/>
+                <a:latin typeface="Monaspace Neon"/>
+              </a:rPr>
+              <a:t>"shrimp-task-manager"</a:t>
+            </a:r>
+            <a:r>
+              <a:rPr lang="en-US" altLang="ko-KR" sz="1100" b="0" i="0" dirty="0">
+                <a:solidFill>
+                  <a:srgbClr val="1F2328"/>
+                </a:solidFill>
+                <a:effectLst/>
+                <a:latin typeface="Monaspace Neon"/>
+              </a:rPr>
+              <a:t>: {</a:t>
+            </a:r>
+          </a:p>
+          <a:p>
+            <a:pPr algn="l" latinLnBrk="0">
+              <a:buNone/>
+            </a:pPr>
+            <a:r>
+              <a:rPr lang="en-US" altLang="ko-KR" sz="1100" b="0" i="0" dirty="0">
+                <a:solidFill>
+                  <a:srgbClr val="1F2328"/>
+                </a:solidFill>
+                <a:effectLst/>
+                <a:latin typeface="Monaspace Neon"/>
+              </a:rPr>
+              <a:t>      </a:t>
+            </a:r>
+            <a:r>
+              <a:rPr lang="en-US" altLang="ko-KR" sz="1100" b="0" i="0" dirty="0">
+                <a:solidFill>
+                  <a:srgbClr val="0550AE"/>
+                </a:solidFill>
+                <a:effectLst/>
+                <a:latin typeface="Monaspace Neon"/>
+              </a:rPr>
+              <a:t>"command"</a:t>
+            </a:r>
+            <a:r>
+              <a:rPr lang="en-US" altLang="ko-KR" sz="1100" b="0" i="0" dirty="0">
+                <a:solidFill>
+                  <a:srgbClr val="1F2328"/>
+                </a:solidFill>
+                <a:effectLst/>
+                <a:latin typeface="Monaspace Neon"/>
+              </a:rPr>
+              <a:t>: </a:t>
+            </a:r>
+            <a:r>
+              <a:rPr lang="en-US" altLang="ko-KR" sz="1100" b="0" i="0" dirty="0">
+                <a:solidFill>
+                  <a:srgbClr val="0A3069"/>
+                </a:solidFill>
+                <a:effectLst/>
+                <a:latin typeface="Monaspace Neon"/>
+              </a:rPr>
+              <a:t>"node"</a:t>
+            </a:r>
+            <a:r>
+              <a:rPr lang="en-US" altLang="ko-KR" sz="1100" b="0" i="0" dirty="0">
+                <a:solidFill>
+                  <a:srgbClr val="1F2328"/>
+                </a:solidFill>
+                <a:effectLst/>
+                <a:latin typeface="Monaspace Neon"/>
+              </a:rPr>
+              <a:t>,</a:t>
+            </a:r>
+          </a:p>
+          <a:p>
+            <a:pPr algn="l" latinLnBrk="0">
+              <a:buNone/>
+            </a:pPr>
+            <a:r>
+              <a:rPr lang="en-US" altLang="ko-KR" sz="1100" b="0" i="0" dirty="0">
+                <a:solidFill>
+                  <a:srgbClr val="1F2328"/>
+                </a:solidFill>
+                <a:effectLst/>
+                <a:latin typeface="Monaspace Neon"/>
+              </a:rPr>
+              <a:t>      </a:t>
+            </a:r>
+            <a:r>
+              <a:rPr lang="en-US" altLang="ko-KR" sz="1100" b="0" i="0" dirty="0">
+                <a:solidFill>
+                  <a:srgbClr val="0550AE"/>
+                </a:solidFill>
+                <a:effectLst/>
+                <a:latin typeface="Monaspace Neon"/>
+              </a:rPr>
+              <a:t>"</a:t>
+            </a:r>
+            <a:r>
+              <a:rPr lang="en-US" altLang="ko-KR" sz="1100" b="0" i="0" dirty="0" err="1">
+                <a:solidFill>
+                  <a:srgbClr val="0550AE"/>
+                </a:solidFill>
+                <a:effectLst/>
+                <a:latin typeface="Monaspace Neon"/>
+              </a:rPr>
+              <a:t>args</a:t>
+            </a:r>
+            <a:r>
+              <a:rPr lang="en-US" altLang="ko-KR" sz="1100" b="0" i="0" dirty="0">
+                <a:solidFill>
+                  <a:srgbClr val="0550AE"/>
+                </a:solidFill>
+                <a:effectLst/>
+                <a:latin typeface="Monaspace Neon"/>
+              </a:rPr>
+              <a:t>"</a:t>
+            </a:r>
+            <a:r>
+              <a:rPr lang="en-US" altLang="ko-KR" sz="1100" b="0" i="0" dirty="0">
+                <a:solidFill>
+                  <a:srgbClr val="1F2328"/>
+                </a:solidFill>
+                <a:effectLst/>
+                <a:latin typeface="Monaspace Neon"/>
+              </a:rPr>
+              <a:t>: [</a:t>
+            </a:r>
+            <a:r>
+              <a:rPr lang="en-US" altLang="ko-KR" sz="1100" b="0" i="0" dirty="0">
+                <a:solidFill>
+                  <a:srgbClr val="0A3069"/>
+                </a:solidFill>
+                <a:effectLst/>
+                <a:latin typeface="Monaspace Neon"/>
+              </a:rPr>
+              <a:t>"/home/fire/</a:t>
+            </a:r>
+            <a:r>
+              <a:rPr lang="en-US" altLang="ko-KR" sz="1100" b="0" i="0" dirty="0" err="1">
+                <a:solidFill>
+                  <a:srgbClr val="0A3069"/>
+                </a:solidFill>
+                <a:effectLst/>
+                <a:latin typeface="Monaspace Neon"/>
+              </a:rPr>
+              <a:t>claude</a:t>
+            </a:r>
+            <a:r>
+              <a:rPr lang="en-US" altLang="ko-KR" sz="1100" b="0" i="0" dirty="0">
+                <a:solidFill>
+                  <a:srgbClr val="0A3069"/>
+                </a:solidFill>
+                <a:effectLst/>
+                <a:latin typeface="Monaspace Neon"/>
+              </a:rPr>
+              <a:t>/</a:t>
+            </a:r>
+            <a:r>
+              <a:rPr lang="en-US" altLang="ko-KR" sz="1100" b="0" i="0" dirty="0" err="1">
+                <a:solidFill>
+                  <a:srgbClr val="0A3069"/>
+                </a:solidFill>
+                <a:effectLst/>
+                <a:latin typeface="Monaspace Neon"/>
+              </a:rPr>
+              <a:t>mcp</a:t>
+            </a:r>
+            <a:r>
+              <a:rPr lang="en-US" altLang="ko-KR" sz="1100" b="0" i="0" dirty="0">
+                <a:solidFill>
+                  <a:srgbClr val="0A3069"/>
+                </a:solidFill>
+                <a:effectLst/>
+                <a:latin typeface="Monaspace Neon"/>
+              </a:rPr>
+              <a:t>-shrimp-task-manager/</a:t>
+            </a:r>
+            <a:r>
+              <a:rPr lang="en-US" altLang="ko-KR" sz="1100" b="0" i="0" dirty="0" err="1">
+                <a:solidFill>
+                  <a:srgbClr val="0A3069"/>
+                </a:solidFill>
+                <a:effectLst/>
+                <a:latin typeface="Monaspace Neon"/>
+              </a:rPr>
+              <a:t>dist</a:t>
+            </a:r>
+            <a:r>
+              <a:rPr lang="en-US" altLang="ko-KR" sz="1100" b="0" i="0" dirty="0">
+                <a:solidFill>
+                  <a:srgbClr val="0A3069"/>
+                </a:solidFill>
+                <a:effectLst/>
+                <a:latin typeface="Monaspace Neon"/>
+              </a:rPr>
+              <a:t>/index.js"</a:t>
+            </a:r>
+            <a:r>
+              <a:rPr lang="en-US" altLang="ko-KR" sz="1100" b="0" i="0" dirty="0">
+                <a:solidFill>
+                  <a:srgbClr val="1F2328"/>
+                </a:solidFill>
+                <a:effectLst/>
+                <a:latin typeface="Monaspace Neon"/>
+              </a:rPr>
+              <a:t>],</a:t>
+            </a:r>
+          </a:p>
+          <a:p>
+            <a:pPr algn="l" latinLnBrk="0">
+              <a:buNone/>
+            </a:pPr>
+            <a:r>
+              <a:rPr lang="en-US" altLang="ko-KR" sz="1100" b="0" i="0" dirty="0">
+                <a:solidFill>
+                  <a:srgbClr val="1F2328"/>
+                </a:solidFill>
+                <a:effectLst/>
+                <a:latin typeface="Monaspace Neon"/>
+              </a:rPr>
+              <a:t>      </a:t>
+            </a:r>
+            <a:r>
+              <a:rPr lang="en-US" altLang="ko-KR" sz="1100" b="0" i="0" dirty="0">
+                <a:solidFill>
+                  <a:srgbClr val="0550AE"/>
+                </a:solidFill>
+                <a:effectLst/>
+                <a:latin typeface="Monaspace Neon"/>
+              </a:rPr>
+              <a:t>"env"</a:t>
+            </a:r>
+            <a:r>
+              <a:rPr lang="en-US" altLang="ko-KR" sz="1100" b="0" i="0" dirty="0">
+                <a:solidFill>
+                  <a:srgbClr val="1F2328"/>
+                </a:solidFill>
+                <a:effectLst/>
+                <a:latin typeface="Monaspace Neon"/>
+              </a:rPr>
+              <a:t>: {</a:t>
+            </a:r>
+          </a:p>
+          <a:p>
+            <a:pPr algn="l" latinLnBrk="0">
+              <a:buNone/>
+            </a:pPr>
+            <a:r>
+              <a:rPr lang="en-US" altLang="ko-KR" sz="1100" b="0" i="0" dirty="0">
+                <a:solidFill>
+                  <a:srgbClr val="1F2328"/>
+                </a:solidFill>
+                <a:effectLst/>
+                <a:latin typeface="Monaspace Neon"/>
+              </a:rPr>
+              <a:t>        </a:t>
+            </a:r>
+            <a:r>
+              <a:rPr lang="en-US" altLang="ko-KR" sz="1100" b="0" i="0" dirty="0">
+                <a:solidFill>
+                  <a:srgbClr val="0550AE"/>
+                </a:solidFill>
+                <a:effectLst/>
+                <a:latin typeface="Monaspace Neon"/>
+              </a:rPr>
+              <a:t>"DATA_DIR"</a:t>
+            </a:r>
+            <a:r>
+              <a:rPr lang="en-US" altLang="ko-KR" sz="1100" b="0" i="0" dirty="0">
+                <a:solidFill>
+                  <a:srgbClr val="1F2328"/>
+                </a:solidFill>
+                <a:effectLst/>
+                <a:latin typeface="Monaspace Neon"/>
+              </a:rPr>
+              <a:t>: </a:t>
+            </a:r>
+            <a:r>
+              <a:rPr lang="en-US" altLang="ko-KR" sz="1100" b="0" i="0" dirty="0">
+                <a:solidFill>
+                  <a:srgbClr val="0A3069"/>
+                </a:solidFill>
+                <a:effectLst/>
+                <a:latin typeface="Monaspace Neon"/>
+              </a:rPr>
+              <a:t>"/home/fire/</a:t>
+            </a:r>
+            <a:r>
+              <a:rPr lang="en-US" altLang="ko-KR" sz="1100" b="0" i="0" dirty="0" err="1">
+                <a:solidFill>
+                  <a:srgbClr val="0A3069"/>
+                </a:solidFill>
+                <a:effectLst/>
+                <a:latin typeface="Monaspace Neon"/>
+              </a:rPr>
+              <a:t>claude</a:t>
+            </a:r>
+            <a:r>
+              <a:rPr lang="en-US" altLang="ko-KR" sz="1100" b="0" i="0" dirty="0">
+                <a:solidFill>
+                  <a:srgbClr val="0A3069"/>
+                </a:solidFill>
+                <a:effectLst/>
+                <a:latin typeface="Monaspace Neon"/>
+              </a:rPr>
+              <a:t>/project/</a:t>
+            </a:r>
+            <a:r>
+              <a:rPr lang="en-US" altLang="ko-KR" sz="1100" b="0" i="0" dirty="0" err="1">
+                <a:solidFill>
+                  <a:srgbClr val="0A3069"/>
+                </a:solidFill>
+                <a:effectLst/>
+                <a:latin typeface="Monaspace Neon"/>
+              </a:rPr>
+              <a:t>shrimp_data</a:t>
+            </a:r>
+            <a:r>
+              <a:rPr lang="en-US" altLang="ko-KR" sz="1100" b="0" i="0" dirty="0">
+                <a:solidFill>
+                  <a:srgbClr val="0A3069"/>
+                </a:solidFill>
+                <a:effectLst/>
+                <a:latin typeface="Monaspace Neon"/>
+              </a:rPr>
+              <a:t>"</a:t>
+            </a:r>
+            <a:r>
+              <a:rPr lang="en-US" altLang="ko-KR" sz="1100" b="0" i="0" dirty="0">
+                <a:solidFill>
+                  <a:srgbClr val="1F2328"/>
+                </a:solidFill>
+                <a:effectLst/>
+                <a:latin typeface="Monaspace Neon"/>
+              </a:rPr>
+              <a:t>,</a:t>
+            </a:r>
+          </a:p>
+          <a:p>
+            <a:pPr algn="l" latinLnBrk="0">
+              <a:buNone/>
+            </a:pPr>
+            <a:r>
+              <a:rPr lang="en-US" altLang="ko-KR" sz="1100" b="0" i="0" dirty="0">
+                <a:solidFill>
+                  <a:srgbClr val="1F2328"/>
+                </a:solidFill>
+                <a:effectLst/>
+                <a:latin typeface="Monaspace Neon"/>
+              </a:rPr>
+              <a:t>        </a:t>
+            </a:r>
+            <a:r>
+              <a:rPr lang="en-US" altLang="ko-KR" sz="1100" b="0" i="0" dirty="0">
+                <a:solidFill>
+                  <a:srgbClr val="0550AE"/>
+                </a:solidFill>
+                <a:effectLst/>
+                <a:latin typeface="Monaspace Neon"/>
+              </a:rPr>
+              <a:t>"TEMPLATES_USE"</a:t>
+            </a:r>
+            <a:r>
+              <a:rPr lang="en-US" altLang="ko-KR" sz="1100" b="0" i="0" dirty="0">
+                <a:solidFill>
+                  <a:srgbClr val="1F2328"/>
+                </a:solidFill>
+                <a:effectLst/>
+                <a:latin typeface="Monaspace Neon"/>
+              </a:rPr>
+              <a:t>: </a:t>
+            </a:r>
+            <a:r>
+              <a:rPr lang="en-US" altLang="ko-KR" sz="1100" b="0" i="0" dirty="0">
+                <a:solidFill>
+                  <a:srgbClr val="0A3069"/>
+                </a:solidFill>
+                <a:effectLst/>
+                <a:latin typeface="Monaspace Neon"/>
+              </a:rPr>
+              <a:t>"</a:t>
+            </a:r>
+            <a:r>
+              <a:rPr lang="en-US" altLang="ko-KR" sz="1100" b="0" i="0" dirty="0" err="1">
+                <a:solidFill>
+                  <a:srgbClr val="0A3069"/>
+                </a:solidFill>
+                <a:effectLst/>
+                <a:latin typeface="Monaspace Neon"/>
+              </a:rPr>
+              <a:t>en</a:t>
+            </a:r>
+            <a:r>
+              <a:rPr lang="en-US" altLang="ko-KR" sz="1100" b="0" i="0" dirty="0">
+                <a:solidFill>
+                  <a:srgbClr val="0A3069"/>
+                </a:solidFill>
+                <a:effectLst/>
+                <a:latin typeface="Monaspace Neon"/>
+              </a:rPr>
+              <a:t>"</a:t>
+            </a:r>
+            <a:r>
+              <a:rPr lang="en-US" altLang="ko-KR" sz="1100" b="0" i="0" dirty="0">
+                <a:solidFill>
+                  <a:srgbClr val="1F2328"/>
+                </a:solidFill>
+                <a:effectLst/>
+                <a:latin typeface="Monaspace Neon"/>
+              </a:rPr>
+              <a:t>,</a:t>
+            </a:r>
+          </a:p>
+          <a:p>
+            <a:pPr algn="l" latinLnBrk="0">
+              <a:buNone/>
+            </a:pPr>
+            <a:r>
+              <a:rPr lang="en-US" altLang="ko-KR" sz="1100" b="0" i="0" dirty="0">
+                <a:solidFill>
+                  <a:srgbClr val="1F2328"/>
+                </a:solidFill>
+                <a:effectLst/>
+                <a:latin typeface="Monaspace Neon"/>
+              </a:rPr>
+              <a:t>        </a:t>
+            </a:r>
+            <a:r>
+              <a:rPr lang="en-US" altLang="ko-KR" sz="1100" b="0" i="0" dirty="0">
+                <a:solidFill>
+                  <a:srgbClr val="0550AE"/>
+                </a:solidFill>
+                <a:effectLst/>
+                <a:latin typeface="Monaspace Neon"/>
+              </a:rPr>
+              <a:t>"ENABLE_GUI"</a:t>
+            </a:r>
+            <a:r>
+              <a:rPr lang="en-US" altLang="ko-KR" sz="1100" b="0" i="0" dirty="0">
+                <a:solidFill>
+                  <a:srgbClr val="1F2328"/>
+                </a:solidFill>
+                <a:effectLst/>
+                <a:latin typeface="Monaspace Neon"/>
+              </a:rPr>
+              <a:t>: </a:t>
+            </a:r>
+            <a:r>
+              <a:rPr lang="en-US" altLang="ko-KR" sz="1100" b="0" i="0" dirty="0">
+                <a:solidFill>
+                  <a:srgbClr val="0A3069"/>
+                </a:solidFill>
+                <a:effectLst/>
+                <a:latin typeface="Monaspace Neon"/>
+              </a:rPr>
+              <a:t>"false"</a:t>
+            </a:r>
+            <a:endParaRPr lang="en-US" altLang="ko-KR" sz="1100" b="0" i="0" dirty="0">
+              <a:solidFill>
+                <a:srgbClr val="1F2328"/>
+              </a:solidFill>
+              <a:effectLst/>
+              <a:latin typeface="Monaspace Neon"/>
+            </a:endParaRPr>
+          </a:p>
+          <a:p>
+            <a:pPr algn="l" latinLnBrk="0">
+              <a:buNone/>
+            </a:pPr>
+            <a:r>
+              <a:rPr lang="en-US" altLang="ko-KR" sz="1100" b="0" i="0" dirty="0">
+                <a:solidFill>
+                  <a:srgbClr val="1F2328"/>
+                </a:solidFill>
+                <a:effectLst/>
+                <a:latin typeface="Monaspace Neon"/>
+              </a:rPr>
+              <a:t>      }</a:t>
+            </a:r>
+          </a:p>
+          <a:p>
+            <a:pPr algn="l" latinLnBrk="0">
+              <a:buNone/>
+            </a:pPr>
+            <a:r>
+              <a:rPr lang="en-US" altLang="ko-KR" sz="1100" b="0" i="0" dirty="0">
+                <a:solidFill>
+                  <a:srgbClr val="1F2328"/>
+                </a:solidFill>
+                <a:effectLst/>
+                <a:latin typeface="Monaspace Neon"/>
+              </a:rPr>
+              <a:t>    }</a:t>
+            </a:r>
+          </a:p>
+          <a:p>
+            <a:pPr algn="l" latinLnBrk="0">
+              <a:buNone/>
+            </a:pPr>
+            <a:r>
+              <a:rPr lang="en-US" altLang="ko-KR" sz="1100" b="0" i="0" dirty="0">
+                <a:solidFill>
+                  <a:srgbClr val="1F2328"/>
+                </a:solidFill>
+                <a:effectLst/>
+                <a:latin typeface="Monaspace Neon"/>
+              </a:rPr>
+              <a:t>  }</a:t>
+            </a:r>
+          </a:p>
+          <a:p>
+            <a:pPr algn="l" latinLnBrk="0">
+              <a:buNone/>
+            </a:pPr>
+            <a:r>
+              <a:rPr lang="en-US" altLang="ko-KR" sz="1100" b="0" i="0" dirty="0">
+                <a:solidFill>
+                  <a:srgbClr val="1F2328"/>
+                </a:solidFill>
+                <a:effectLst/>
+                <a:latin typeface="Monaspace Neon"/>
+              </a:rPr>
+              <a:t>}</a:t>
+            </a:r>
+          </a:p>
+        </p:txBody>
+      </p:sp>
+    </p:spTree>
+    <p:extLst>
+      <p:ext uri="{BB962C8B-B14F-4D97-AF65-F5344CB8AC3E}">
+        <p14:creationId xmlns:p14="http://schemas.microsoft.com/office/powerpoint/2010/main" val="2689324279"/>
+      </p:ext>
+    </p:extLst>
+  </p:cSld>
+  <p:clrMapOvr>
+    <a:masterClrMapping/>
+  </p:clrMapOvr>
+</p:sld>
+</file>
+
+<file path=ppt/slides/slide5.xml><?xml version="1.0" encoding="utf-8"?>
+<p:sld xmlns:a="http://schemas.openxmlformats.org/drawingml/2006/main" xmlns:r="http://schemas.openxmlformats.org/officeDocument/2006/relationships" xmlns:p="http://schemas.openxmlformats.org/presentationml/2006/main">
+  <p:cSld>
+    <p:spTree>
+      <p:nvGrpSpPr>
+        <p:cNvPr id="1" name=""/>
+        <p:cNvGrpSpPr/>
+        <p:nvPr/>
+      </p:nvGrpSpPr>
+      <p:grpSpPr>
+        <a:xfrm>
+          <a:off x="0" y="0"/>
+          <a:ext cx="0" cy="0"/>
+          <a:chOff x="0" y="0"/>
+          <a:chExt cx="0" cy="0"/>
+        </a:xfrm>
+      </p:grpSpPr>
+      <p:sp>
+        <p:nvSpPr>
+          <p:cNvPr id="2" name="제목 1">
+            <a:extLst>
+              <a:ext uri="{FF2B5EF4-FFF2-40B4-BE49-F238E27FC236}">
+                <a16:creationId xmlns:a16="http://schemas.microsoft.com/office/drawing/2014/main" id="{5F596BCE-C16E-16DD-F2FD-1C7D3231CD7C}"/>
+              </a:ext>
+            </a:extLst>
+          </p:cNvPr>
+          <p:cNvSpPr>
+            <a:spLocks noGrp="1"/>
+          </p:cNvSpPr>
+          <p:nvPr>
+            <p:ph type="title"/>
+          </p:nvPr>
+        </p:nvSpPr>
+        <p:spPr/>
+        <p:txBody>
+          <a:bodyPr>
+            <a:normAutofit/>
+          </a:bodyPr>
+          <a:lstStyle/>
+          <a:p>
+            <a:r>
+              <a:rPr lang="en-US" altLang="ko-KR" sz="4000" dirty="0"/>
+              <a:t>Shrimp Task Manager </a:t>
+            </a:r>
+            <a:r>
+              <a:rPr lang="ko-KR" altLang="en-US" sz="4000" dirty="0"/>
+              <a:t>기능 살펴보기</a:t>
+            </a:r>
+            <a:r>
+              <a:rPr lang="en-US" altLang="ko-KR" sz="4000" dirty="0"/>
+              <a:t>-1</a:t>
+            </a:r>
+            <a:endParaRPr lang="ko-KR" altLang="en-US" sz="4000" dirty="0"/>
           </a:p>
         </p:txBody>
       </p:sp>
@@ -4067,7 +6401,7 @@
           <p:cNvPr id="4" name="그림 3">
             <a:extLst>
               <a:ext uri="{FF2B5EF4-FFF2-40B4-BE49-F238E27FC236}">
-                <a16:creationId xmlns:a16="http://schemas.microsoft.com/office/drawing/2014/main" id="{4E9D19E0-4E9D-C826-95E9-4862CA2C3888}"/>
+                <a16:creationId xmlns:a16="http://schemas.microsoft.com/office/drawing/2014/main" id="{F1A92A99-DC7A-04B5-1B5B-2CCD14BEA0C9}"/>
               </a:ext>
             </a:extLst>
           </p:cNvPr>
@@ -4084,25 +6418,20 @@
         </p:blipFill>
         <p:spPr>
           <a:xfrm>
-            <a:off x="476033" y="1829065"/>
-            <a:ext cx="5029221" cy="4377955"/>
+            <a:off x="455999" y="1952419"/>
+            <a:ext cx="4502500" cy="1118409"/>
           </a:xfrm>
           <a:prstGeom prst="rect">
             <a:avLst/>
           </a:prstGeom>
-          <a:ln>
-            <a:solidFill>
-              <a:schemeClr val="tx1"/>
-            </a:solidFill>
-          </a:ln>
         </p:spPr>
       </p:pic>
       <p:sp>
         <p:nvSpPr>
-          <p:cNvPr id="6" name="TextBox 5">
+          <p:cNvPr id="5" name="TextBox 4">
             <a:extLst>
               <a:ext uri="{FF2B5EF4-FFF2-40B4-BE49-F238E27FC236}">
-                <a16:creationId xmlns:a16="http://schemas.microsoft.com/office/drawing/2014/main" id="{DA651613-B32F-1636-B1BC-52B9C688EC18}"/>
+                <a16:creationId xmlns:a16="http://schemas.microsoft.com/office/drawing/2014/main" id="{206A5B07-2539-B375-D20E-6CE9615D77E7}"/>
               </a:ext>
             </a:extLst>
           </p:cNvPr>
@@ -4111,8 +6440,8 @@
         </p:nvSpPr>
         <p:spPr>
           <a:xfrm>
-            <a:off x="5621539" y="1737360"/>
-            <a:ext cx="6094428" cy="3323987"/>
+            <a:off x="5090474" y="1952419"/>
+            <a:ext cx="6268825" cy="600164"/>
           </a:xfrm>
           <a:prstGeom prst="rect">
             <a:avLst/>
@@ -4120,267 +6449,85 @@
           <a:noFill/>
         </p:spPr>
         <p:txBody>
-          <a:bodyPr wrap="square">
+          <a:bodyPr wrap="square" rtlCol="0">
             <a:spAutoFit/>
           </a:bodyPr>
           <a:lstStyle/>
           <a:p>
-            <a:r>
-              <a:rPr lang="ko-KR" altLang="en-US" dirty="0"/>
-              <a:t># </a:t>
-            </a:r>
-            <a:r>
-              <a:rPr lang="ko-KR" altLang="en-US" dirty="0" err="1"/>
-              <a:t>Install</a:t>
-            </a:r>
-            <a:r>
-              <a:rPr lang="ko-KR" altLang="en-US" dirty="0"/>
-              <a:t> </a:t>
-            </a:r>
-            <a:r>
-              <a:rPr lang="ko-KR" altLang="en-US" dirty="0" err="1"/>
-              <a:t>globally</a:t>
-            </a:r>
-            <a:endParaRPr lang="ko-KR" altLang="en-US" dirty="0"/>
-          </a:p>
-          <a:p>
-            <a:r>
-              <a:rPr lang="ko-KR" altLang="en-US" sz="1200" dirty="0" err="1"/>
-              <a:t>npm</a:t>
-            </a:r>
-            <a:r>
-              <a:rPr lang="ko-KR" altLang="en-US" sz="1200" dirty="0"/>
-              <a:t> </a:t>
-            </a:r>
-            <a:r>
-              <a:rPr lang="ko-KR" altLang="en-US" sz="1200" dirty="0" err="1"/>
-              <a:t>install</a:t>
-            </a:r>
-            <a:r>
-              <a:rPr lang="ko-KR" altLang="en-US" sz="1200" dirty="0"/>
-              <a:t> -</a:t>
-            </a:r>
-            <a:r>
-              <a:rPr lang="ko-KR" altLang="en-US" sz="1200" dirty="0" err="1"/>
-              <a:t>g</a:t>
-            </a:r>
-            <a:r>
-              <a:rPr lang="ko-KR" altLang="en-US" sz="1200" dirty="0"/>
-              <a:t> </a:t>
-            </a:r>
-            <a:r>
-              <a:rPr lang="ko-KR" altLang="en-US" sz="1200" dirty="0" err="1"/>
-              <a:t>task-master-ai</a:t>
-            </a:r>
-            <a:endParaRPr lang="ko-KR" altLang="en-US" sz="1200" dirty="0"/>
-          </a:p>
-          <a:p>
-            <a:endParaRPr lang="ko-KR" altLang="en-US" sz="1200" dirty="0"/>
-          </a:p>
-          <a:p>
-            <a:r>
-              <a:rPr lang="ko-KR" altLang="en-US" sz="1200" dirty="0"/>
-              <a:t># OR </a:t>
-            </a:r>
-            <a:r>
-              <a:rPr lang="ko-KR" altLang="en-US" sz="1200" dirty="0" err="1"/>
-              <a:t>install</a:t>
-            </a:r>
-            <a:r>
-              <a:rPr lang="ko-KR" altLang="en-US" sz="1200" dirty="0"/>
-              <a:t> </a:t>
-            </a:r>
-            <a:r>
-              <a:rPr lang="ko-KR" altLang="en-US" sz="1200" dirty="0" err="1"/>
-              <a:t>locally</a:t>
-            </a:r>
-            <a:r>
-              <a:rPr lang="ko-KR" altLang="en-US" sz="1200" dirty="0"/>
-              <a:t> </a:t>
-            </a:r>
-            <a:r>
-              <a:rPr lang="ko-KR" altLang="en-US" sz="1200" dirty="0" err="1"/>
-              <a:t>within</a:t>
-            </a:r>
-            <a:r>
-              <a:rPr lang="ko-KR" altLang="en-US" sz="1200" dirty="0"/>
-              <a:t> </a:t>
-            </a:r>
-            <a:r>
-              <a:rPr lang="ko-KR" altLang="en-US" sz="1200" dirty="0" err="1"/>
-              <a:t>your</a:t>
-            </a:r>
-            <a:r>
-              <a:rPr lang="ko-KR" altLang="en-US" sz="1200" dirty="0"/>
-              <a:t> </a:t>
-            </a:r>
-            <a:r>
-              <a:rPr lang="ko-KR" altLang="en-US" sz="1200" dirty="0" err="1"/>
-              <a:t>project</a:t>
-            </a:r>
-            <a:endParaRPr lang="ko-KR" altLang="en-US" sz="1200" dirty="0"/>
-          </a:p>
-          <a:p>
-            <a:r>
-              <a:rPr lang="ko-KR" altLang="en-US" sz="1200" dirty="0" err="1"/>
-              <a:t>npm</a:t>
-            </a:r>
-            <a:r>
-              <a:rPr lang="ko-KR" altLang="en-US" sz="1200" dirty="0"/>
-              <a:t> </a:t>
-            </a:r>
-            <a:r>
-              <a:rPr lang="ko-KR" altLang="en-US" sz="1200" dirty="0" err="1"/>
-              <a:t>install</a:t>
-            </a:r>
-            <a:r>
-              <a:rPr lang="ko-KR" altLang="en-US" sz="1200" dirty="0"/>
-              <a:t> </a:t>
-            </a:r>
-            <a:r>
-              <a:rPr lang="ko-KR" altLang="en-US" sz="1200" dirty="0" err="1"/>
-              <a:t>task-master-ai</a:t>
+            <a:endParaRPr lang="en-US" altLang="ko-KR" sz="1100" dirty="0"/>
+          </a:p>
+          <a:p>
+            <a:r>
+              <a:rPr lang="en-US" altLang="ko-KR" sz="1100" dirty="0">
+                <a:sym typeface="Wingdings" panose="05000000000000000000" pitchFamily="2" charset="2"/>
+              </a:rPr>
+              <a:t> </a:t>
+            </a:r>
+            <a:r>
+              <a:rPr lang="ko-KR" altLang="en-US" sz="1100" dirty="0"/>
+              <a:t>어떠한 </a:t>
+            </a:r>
+            <a:r>
+              <a:rPr lang="ko-KR" altLang="en-US" sz="1100" dirty="0" err="1"/>
+              <a:t>기술스택</a:t>
+            </a:r>
+            <a:r>
+              <a:rPr lang="ko-KR" altLang="en-US" sz="1100" dirty="0"/>
+              <a:t> 또는 어떠한 프로젝트 구조를 </a:t>
+            </a:r>
+            <a:r>
+              <a:rPr lang="ko-KR" altLang="en-US" sz="1100" dirty="0" err="1"/>
+              <a:t>가져갈껀지</a:t>
+            </a:r>
+            <a:r>
+              <a:rPr lang="ko-KR" altLang="en-US" sz="1100" dirty="0"/>
+              <a:t> 초기화를 해주는 기능</a:t>
             </a:r>
             <a:br>
-              <a:rPr lang="en-US" altLang="ko-KR" dirty="0"/>
+              <a:rPr lang="en-US" altLang="ko-KR" sz="1100" dirty="0"/>
             </a:br>
-            <a:br>
-              <a:rPr lang="en-US" altLang="ko-KR" dirty="0"/>
-            </a:br>
-            <a:r>
-              <a:rPr lang="en-US" altLang="ko-KR" dirty="0"/>
-              <a:t># Initialize a new project</a:t>
-            </a:r>
-            <a:br>
-              <a:rPr lang="en-US" altLang="ko-KR" dirty="0"/>
-            </a:br>
-            <a:r>
-              <a:rPr lang="en-US" altLang="ko-KR" sz="1200" dirty="0"/>
-              <a:t># If installed globally</a:t>
-            </a:r>
-          </a:p>
-          <a:p>
-            <a:r>
-              <a:rPr lang="en-US" altLang="ko-KR" sz="1200" dirty="0"/>
-              <a:t>task-master </a:t>
-            </a:r>
-            <a:r>
-              <a:rPr lang="en-US" altLang="ko-KR" sz="1200" dirty="0" err="1"/>
-              <a:t>init</a:t>
-            </a:r>
-            <a:endParaRPr lang="en-US" altLang="ko-KR" sz="1200" dirty="0"/>
-          </a:p>
-          <a:p>
-            <a:endParaRPr lang="en-US" altLang="ko-KR" sz="1200" dirty="0"/>
-          </a:p>
-          <a:p>
-            <a:r>
-              <a:rPr lang="en-US" altLang="ko-KR" sz="1200" dirty="0"/>
-              <a:t># If installed locally</a:t>
-            </a:r>
-          </a:p>
-          <a:p>
-            <a:r>
-              <a:rPr lang="en-US" altLang="ko-KR" sz="1200" dirty="0" err="1"/>
-              <a:t>npx</a:t>
-            </a:r>
-            <a:r>
-              <a:rPr lang="en-US" altLang="ko-KR" sz="1200" dirty="0"/>
-              <a:t> task-master </a:t>
-            </a:r>
-            <a:r>
-              <a:rPr lang="en-US" altLang="ko-KR" sz="1200" dirty="0" err="1"/>
-              <a:t>init</a:t>
-            </a:r>
-            <a:endParaRPr lang="en-US" altLang="ko-KR" sz="1200" dirty="0"/>
-          </a:p>
-          <a:p>
-            <a:endParaRPr lang="en-US" altLang="ko-KR" sz="1200" dirty="0"/>
-          </a:p>
-          <a:p>
-            <a:r>
-              <a:rPr lang="en-US" altLang="ko-KR" sz="1200" dirty="0"/>
-              <a:t># Initialize project with specific rules</a:t>
-            </a:r>
-          </a:p>
-          <a:p>
-            <a:r>
-              <a:rPr lang="en-US" altLang="ko-KR" sz="1200" dirty="0"/>
-              <a:t>task-master </a:t>
-            </a:r>
-            <a:r>
-              <a:rPr lang="en-US" altLang="ko-KR" sz="1200" dirty="0" err="1"/>
-              <a:t>init</a:t>
-            </a:r>
-            <a:r>
-              <a:rPr lang="en-US" altLang="ko-KR" sz="1200" dirty="0"/>
-              <a:t> --rules </a:t>
-            </a:r>
-            <a:r>
-              <a:rPr lang="en-US" altLang="ko-KR" sz="1200" dirty="0" err="1"/>
-              <a:t>cursor,windsurf,vscode</a:t>
-            </a:r>
-            <a:br>
-              <a:rPr lang="en-US" altLang="ko-KR" sz="1200" dirty="0"/>
-            </a:br>
-            <a:r>
-              <a:rPr lang="en-US" altLang="ko-KR" sz="1200" dirty="0">
-                <a:sym typeface="Wingdings" panose="05000000000000000000" pitchFamily="2" charset="2"/>
-              </a:rPr>
-              <a:t> </a:t>
-            </a:r>
-            <a:r>
-              <a:rPr lang="ko-KR" altLang="en-US" sz="1200" dirty="0">
-                <a:sym typeface="Wingdings" panose="05000000000000000000" pitchFamily="2" charset="2"/>
-              </a:rPr>
-              <a:t>설치는 </a:t>
-            </a:r>
-            <a:r>
-              <a:rPr lang="en-US" altLang="ko-KR" sz="1200" dirty="0">
-                <a:sym typeface="Wingdings" panose="05000000000000000000" pitchFamily="2" charset="2"/>
-              </a:rPr>
-              <a:t>cli </a:t>
-            </a:r>
-            <a:r>
-              <a:rPr lang="ko-KR" altLang="en-US" sz="1200" dirty="0">
-                <a:sym typeface="Wingdings" panose="05000000000000000000" pitchFamily="2" charset="2"/>
-              </a:rPr>
-              <a:t>글로벌로 실행은 </a:t>
-            </a:r>
-            <a:r>
-              <a:rPr lang="en-US" altLang="ko-KR" sz="1200" dirty="0">
-                <a:sym typeface="Wingdings" panose="05000000000000000000" pitchFamily="2" charset="2"/>
-              </a:rPr>
-              <a:t>Claude Code </a:t>
-            </a:r>
-            <a:r>
-              <a:rPr lang="ko-KR" altLang="en-US" sz="1200" dirty="0">
-                <a:sym typeface="Wingdings" panose="05000000000000000000" pitchFamily="2" charset="2"/>
-              </a:rPr>
-              <a:t>의 </a:t>
-            </a:r>
-            <a:r>
-              <a:rPr lang="en-US" altLang="ko-KR" sz="1200" dirty="0">
-                <a:sym typeface="Wingdings" panose="05000000000000000000" pitchFamily="2" charset="2"/>
-              </a:rPr>
-              <a:t>MCP</a:t>
-            </a:r>
-            <a:r>
-              <a:rPr lang="ko-KR" altLang="en-US" sz="1200" dirty="0">
-                <a:sym typeface="Wingdings" panose="05000000000000000000" pitchFamily="2" charset="2"/>
-              </a:rPr>
-              <a:t>로 진행</a:t>
-            </a:r>
-            <a:endParaRPr lang="ko-KR" altLang="en-US" sz="1200" dirty="0"/>
+            <a:r>
+              <a:rPr lang="en-US" altLang="ko-KR" sz="1100" dirty="0"/>
+              <a:t>     (</a:t>
+            </a:r>
+            <a:r>
+              <a:rPr lang="ko-KR" altLang="en-US" sz="1100" dirty="0"/>
+              <a:t>예시 </a:t>
+            </a:r>
+            <a:r>
+              <a:rPr lang="en-US" altLang="ko-KR" sz="1100" dirty="0"/>
+              <a:t>: </a:t>
+            </a:r>
+            <a:r>
+              <a:rPr lang="ko-KR" altLang="en-US" sz="1100" dirty="0" err="1"/>
+              <a:t>스도쿠</a:t>
+            </a:r>
+            <a:r>
+              <a:rPr lang="ko-KR" altLang="en-US" sz="1100" dirty="0"/>
+              <a:t> 게임을 만들고 싶어</a:t>
+            </a:r>
+            <a:r>
+              <a:rPr lang="en-US" altLang="ko-KR" sz="1100" dirty="0"/>
+              <a:t>,</a:t>
+            </a:r>
+            <a:r>
+              <a:rPr lang="ko-KR" altLang="en-US" sz="1100" dirty="0"/>
+              <a:t> 필요한 기술과  절차에 대하여 초기화 룰을 구성해줘</a:t>
+            </a:r>
+            <a:r>
+              <a:rPr lang="en-US" altLang="ko-KR" sz="1100" dirty="0"/>
+              <a:t>)</a:t>
+            </a:r>
+            <a:endParaRPr lang="ko-KR" altLang="en-US" sz="1100" dirty="0"/>
           </a:p>
         </p:txBody>
       </p:sp>
       <p:pic>
         <p:nvPicPr>
-          <p:cNvPr id="8" name="그림 7">
+          <p:cNvPr id="7" name="그림 6">
             <a:extLst>
               <a:ext uri="{FF2B5EF4-FFF2-40B4-BE49-F238E27FC236}">
-                <a16:creationId xmlns:a16="http://schemas.microsoft.com/office/drawing/2014/main" id="{BAE38190-01D1-9FD5-E717-D3326DB4EBAA}"/>
+                <a16:creationId xmlns:a16="http://schemas.microsoft.com/office/drawing/2014/main" id="{AB865AF6-80F5-62C4-6551-F338F27E1789}"/>
               </a:ext>
             </a:extLst>
           </p:cNvPr>
@@ -4397,18 +6544,154 @@
         </p:blipFill>
         <p:spPr>
           <a:xfrm>
-            <a:off x="5621539" y="5100511"/>
-            <a:ext cx="4757372" cy="1701877"/>
+            <a:off x="456000" y="3282278"/>
+            <a:ext cx="4502500" cy="988126"/>
           </a:xfrm>
           <a:prstGeom prst="rect">
             <a:avLst/>
           </a:prstGeom>
         </p:spPr>
       </p:pic>
+      <p:sp>
+        <p:nvSpPr>
+          <p:cNvPr id="8" name="TextBox 7">
+            <a:extLst>
+              <a:ext uri="{FF2B5EF4-FFF2-40B4-BE49-F238E27FC236}">
+                <a16:creationId xmlns:a16="http://schemas.microsoft.com/office/drawing/2014/main" id="{6CF01B2A-8DC8-410C-EFC7-3CBD20957407}"/>
+              </a:ext>
+            </a:extLst>
+          </p:cNvPr>
+          <p:cNvSpPr txBox="1"/>
+          <p:nvPr/>
+        </p:nvSpPr>
+        <p:spPr>
+          <a:xfrm>
+            <a:off x="5090474" y="3176177"/>
+            <a:ext cx="6268825" cy="430887"/>
+          </a:xfrm>
+          <a:prstGeom prst="rect">
+            <a:avLst/>
+          </a:prstGeom>
+          <a:noFill/>
+        </p:spPr>
+        <p:txBody>
+          <a:bodyPr wrap="square" rtlCol="0">
+            <a:spAutoFit/>
+          </a:bodyPr>
+          <a:lstStyle/>
+          <a:p>
+            <a:endParaRPr lang="en-US" altLang="ko-KR" sz="1100" dirty="0"/>
+          </a:p>
+          <a:p>
+            <a:r>
+              <a:rPr lang="en-US" altLang="ko-KR" sz="1100" dirty="0">
+                <a:sym typeface="Wingdings" panose="05000000000000000000" pitchFamily="2" charset="2"/>
+              </a:rPr>
+              <a:t> </a:t>
+            </a:r>
+            <a:r>
+              <a:rPr lang="ko-KR" altLang="en-US" sz="1100" dirty="0">
+                <a:sym typeface="Wingdings" panose="05000000000000000000" pitchFamily="2" charset="2"/>
+              </a:rPr>
+              <a:t>큰 요청을 실행 가능한 작은 단계별 계획으로 나눠주는 기능</a:t>
+            </a:r>
+            <a:r>
+              <a:rPr lang="en-US" altLang="ko-KR" sz="1100" dirty="0">
+                <a:sym typeface="Wingdings" panose="05000000000000000000" pitchFamily="2" charset="2"/>
+              </a:rPr>
+              <a:t>.</a:t>
+            </a:r>
+            <a:r>
+              <a:rPr lang="ko-KR" altLang="en-US" sz="1100" dirty="0">
+                <a:sym typeface="Wingdings" panose="05000000000000000000" pitchFamily="2" charset="2"/>
+              </a:rPr>
+              <a:t> </a:t>
+            </a:r>
+            <a:endParaRPr lang="ko-KR" altLang="en-US" sz="1100" dirty="0"/>
+          </a:p>
+        </p:txBody>
+      </p:sp>
+      <p:pic>
+        <p:nvPicPr>
+          <p:cNvPr id="10" name="그림 9">
+            <a:extLst>
+              <a:ext uri="{FF2B5EF4-FFF2-40B4-BE49-F238E27FC236}">
+                <a16:creationId xmlns:a16="http://schemas.microsoft.com/office/drawing/2014/main" id="{68A34881-8B62-43A2-BAAE-6B36694237E9}"/>
+              </a:ext>
+            </a:extLst>
+          </p:cNvPr>
+          <p:cNvPicPr>
+            <a:picLocks noChangeAspect="1"/>
+          </p:cNvPicPr>
+          <p:nvPr/>
+        </p:nvPicPr>
+        <p:blipFill>
+          <a:blip r:embed="rId4"/>
+          <a:stretch>
+            <a:fillRect/>
+          </a:stretch>
+        </p:blipFill>
+        <p:spPr>
+          <a:xfrm>
+            <a:off x="455999" y="4481855"/>
+            <a:ext cx="4502500" cy="810914"/>
+          </a:xfrm>
+          <a:prstGeom prst="rect">
+            <a:avLst/>
+          </a:prstGeom>
+        </p:spPr>
+      </p:pic>
+      <p:sp>
+        <p:nvSpPr>
+          <p:cNvPr id="11" name="TextBox 10">
+            <a:extLst>
+              <a:ext uri="{FF2B5EF4-FFF2-40B4-BE49-F238E27FC236}">
+                <a16:creationId xmlns:a16="http://schemas.microsoft.com/office/drawing/2014/main" id="{13789645-1AFE-4108-DDFD-F72E7E737CAF}"/>
+              </a:ext>
+            </a:extLst>
+          </p:cNvPr>
+          <p:cNvSpPr txBox="1"/>
+          <p:nvPr/>
+        </p:nvSpPr>
+        <p:spPr>
+          <a:xfrm>
+            <a:off x="5090474" y="4380832"/>
+            <a:ext cx="6268825" cy="430887"/>
+          </a:xfrm>
+          <a:prstGeom prst="rect">
+            <a:avLst/>
+          </a:prstGeom>
+          <a:noFill/>
+        </p:spPr>
+        <p:txBody>
+          <a:bodyPr wrap="square" rtlCol="0">
+            <a:spAutoFit/>
+          </a:bodyPr>
+          <a:lstStyle/>
+          <a:p>
+            <a:endParaRPr lang="en-US" altLang="ko-KR" sz="1100" dirty="0"/>
+          </a:p>
+          <a:p>
+            <a:r>
+              <a:rPr lang="en-US" altLang="ko-KR" sz="1100" dirty="0">
+                <a:sym typeface="Wingdings" panose="05000000000000000000" pitchFamily="2" charset="2"/>
+              </a:rPr>
+              <a:t> </a:t>
+            </a:r>
+            <a:r>
+              <a:rPr lang="ko-KR" altLang="en-US" sz="1100" dirty="0">
+                <a:sym typeface="Wingdings" panose="05000000000000000000" pitchFamily="2" charset="2"/>
+              </a:rPr>
+              <a:t>나뉘어진 계획을 단계별로 수행하는 기능</a:t>
+            </a:r>
+            <a:endParaRPr lang="ko-KR" altLang="en-US" sz="1100" dirty="0"/>
+          </a:p>
+        </p:txBody>
+      </p:sp>
     </p:spTree>
     <p:extLst>
       <p:ext uri="{BB962C8B-B14F-4D97-AF65-F5344CB8AC3E}">
-        <p14:creationId xmlns:p14="http://schemas.microsoft.com/office/powerpoint/2010/main" val="3347502540"/>
+        <p14:creationId xmlns:p14="http://schemas.microsoft.com/office/powerpoint/2010/main" val="604985657"/>
       </p:ext>
     </p:extLst>
   </p:cSld>
@@ -4418,7 +6701,7 @@
 </p:sld>
 </file>
 
-<file path=ppt/slides/slide4.xml><?xml version="1.0" encoding="utf-8"?>
+<file path=ppt/slides/slide6.xml><?xml version="1.0" encoding="utf-8"?>
 <p:sld xmlns:a="http://schemas.openxmlformats.org/drawingml/2006/main" xmlns:r="http://schemas.openxmlformats.org/officeDocument/2006/relationships" xmlns:p="http://schemas.openxmlformats.org/presentationml/2006/main">
   <p:cSld>
     <p:spTree>
@@ -4440,7 +6723,7 @@
           <p:cNvPr id="2" name="제목 1">
             <a:extLst>
               <a:ext uri="{FF2B5EF4-FFF2-40B4-BE49-F238E27FC236}">
-                <a16:creationId xmlns:a16="http://schemas.microsoft.com/office/drawing/2014/main" id="{5F596BCE-C16E-16DD-F2FD-1C7D3231CD7C}"/>
+                <a16:creationId xmlns:a16="http://schemas.microsoft.com/office/drawing/2014/main" id="{F4F8E2A5-EDF6-E09A-79C9-6751DF3530A0}"/>
               </a:ext>
             </a:extLst>
           </p:cNvPr>
@@ -4457,25 +6740,862 @@
           <a:lstStyle/>
           <a:p>
             <a:r>
+              <a:rPr lang="en-US" altLang="ko-KR" dirty="0" err="1"/>
+              <a:t>Init_project_rules</a:t>
+            </a:r>
+            <a:r>
               <a:rPr lang="en-US" altLang="ko-KR" dirty="0"/>
-              <a:t>MCP</a:t>
-            </a:r>
-            <a:r>
-              <a:rPr lang="ko-KR" altLang="en-US" dirty="0"/>
+              <a:t> -1</a:t>
+            </a:r>
+            <a:endParaRPr lang="ko-KR" altLang="en-US" dirty="0"/>
+          </a:p>
+        </p:txBody>
+      </p:sp>
+      <p:pic>
+        <p:nvPicPr>
+          <p:cNvPr id="4" name="그림 3">
+            <a:extLst>
+              <a:ext uri="{FF2B5EF4-FFF2-40B4-BE49-F238E27FC236}">
+                <a16:creationId xmlns:a16="http://schemas.microsoft.com/office/drawing/2014/main" id="{9C93EC59-4BC7-1B15-67CC-E0B8403C5263}"/>
+              </a:ext>
+            </a:extLst>
+          </p:cNvPr>
+          <p:cNvPicPr>
+            <a:picLocks noChangeAspect="1"/>
+          </p:cNvPicPr>
+          <p:nvPr/>
+        </p:nvPicPr>
+        <p:blipFill>
+          <a:blip r:embed="rId2"/>
+          <a:stretch>
+            <a:fillRect/>
+          </a:stretch>
+        </p:blipFill>
+        <p:spPr>
+          <a:xfrm>
+            <a:off x="391418" y="1887228"/>
+            <a:ext cx="3982619" cy="2337106"/>
+          </a:xfrm>
+          <a:prstGeom prst="rect">
+            <a:avLst/>
+          </a:prstGeom>
+        </p:spPr>
+      </p:pic>
+      <p:pic>
+        <p:nvPicPr>
+          <p:cNvPr id="6" name="그림 5">
+            <a:extLst>
+              <a:ext uri="{FF2B5EF4-FFF2-40B4-BE49-F238E27FC236}">
+                <a16:creationId xmlns:a16="http://schemas.microsoft.com/office/drawing/2014/main" id="{77F3C062-E9AC-27FD-3993-AF1CF89F0973}"/>
+              </a:ext>
+            </a:extLst>
+          </p:cNvPr>
+          <p:cNvPicPr>
+            <a:picLocks noChangeAspect="1"/>
+          </p:cNvPicPr>
+          <p:nvPr/>
+        </p:nvPicPr>
+        <p:blipFill>
+          <a:blip r:embed="rId3"/>
+          <a:stretch>
+            <a:fillRect/>
+          </a:stretch>
+        </p:blipFill>
+        <p:spPr>
+          <a:xfrm>
+            <a:off x="4571040" y="1887228"/>
+            <a:ext cx="5539611" cy="4852937"/>
+          </a:xfrm>
+          <a:prstGeom prst="rect">
+            <a:avLst/>
+          </a:prstGeom>
+        </p:spPr>
+      </p:pic>
+      <p:sp>
+        <p:nvSpPr>
+          <p:cNvPr id="7" name="TextBox 6">
+            <a:extLst>
+              <a:ext uri="{FF2B5EF4-FFF2-40B4-BE49-F238E27FC236}">
+                <a16:creationId xmlns:a16="http://schemas.microsoft.com/office/drawing/2014/main" id="{F343A2C9-9504-C44E-B980-784B87A6C22A}"/>
+              </a:ext>
+            </a:extLst>
+          </p:cNvPr>
+          <p:cNvSpPr txBox="1"/>
+          <p:nvPr/>
+        </p:nvSpPr>
+        <p:spPr>
+          <a:xfrm>
+            <a:off x="391418" y="4345757"/>
+            <a:ext cx="3982619" cy="1354217"/>
+          </a:xfrm>
+          <a:prstGeom prst="rect">
+            <a:avLst/>
+          </a:prstGeom>
+          <a:noFill/>
+        </p:spPr>
+        <p:txBody>
+          <a:bodyPr wrap="square" rtlCol="0">
+            <a:spAutoFit/>
+          </a:bodyPr>
+          <a:lstStyle/>
+          <a:p>
+            <a:r>
+              <a:rPr lang="en-US" altLang="ko-KR" sz="1200" dirty="0"/>
+              <a:t>※ </a:t>
+            </a:r>
+            <a:r>
+              <a:rPr lang="ko-KR" altLang="en-US" sz="1200" dirty="0"/>
+              <a:t>요청</a:t>
+            </a:r>
+            <a:br>
+              <a:rPr lang="en-US" altLang="ko-KR" sz="1200" dirty="0"/>
+            </a:br>
+            <a:br>
+              <a:rPr lang="en-US" altLang="ko-KR" sz="1200" dirty="0"/>
+            </a:br>
+            <a:r>
+              <a:rPr lang="en-US" altLang="ko-KR" sz="1200" dirty="0">
+                <a:sym typeface="Wingdings" panose="05000000000000000000" pitchFamily="2" charset="2"/>
+              </a:rPr>
+              <a:t> Claude Code MCP </a:t>
+            </a:r>
+            <a:r>
+              <a:rPr lang="ko-KR" altLang="en-US" sz="1200" dirty="0">
+                <a:sym typeface="Wingdings" panose="05000000000000000000" pitchFamily="2" charset="2"/>
+              </a:rPr>
+              <a:t>의 경우</a:t>
+            </a:r>
+            <a:br>
+              <a:rPr lang="en-US" altLang="ko-KR" sz="1200" dirty="0">
+                <a:sym typeface="Wingdings" panose="05000000000000000000" pitchFamily="2" charset="2"/>
+              </a:rPr>
+            </a:br>
+            <a:r>
+              <a:rPr lang="en-US" altLang="ko-KR" sz="1200" dirty="0">
+                <a:sym typeface="Wingdings" panose="05000000000000000000" pitchFamily="2" charset="2"/>
+              </a:rPr>
+              <a:t>    </a:t>
+            </a:r>
+            <a:r>
+              <a:rPr lang="ko-KR" altLang="en-US" sz="1200" dirty="0"/>
               <a:t> </a:t>
             </a:r>
             <a:r>
-              <a:rPr lang="en-US" altLang="ko-KR"/>
-              <a:t>– Install</a:t>
-            </a:r>
-            <a:endParaRPr lang="ko-KR" altLang="en-US" dirty="0"/>
+              <a:rPr lang="en-US" altLang="ko-KR" sz="1100" dirty="0"/>
+              <a:t>@shrimp-task-manager MCP</a:t>
+            </a:r>
+            <a:r>
+              <a:rPr lang="ko-KR" altLang="en-US" sz="1100" dirty="0"/>
+              <a:t>를 사용하여 </a:t>
+            </a:r>
+            <a:br>
+              <a:rPr lang="en-US" altLang="ko-KR" sz="1100" dirty="0"/>
+            </a:br>
+            <a:r>
+              <a:rPr lang="en-US" altLang="ko-KR" sz="1100" dirty="0"/>
+              <a:t>      </a:t>
+            </a:r>
+            <a:r>
+              <a:rPr lang="en-US" altLang="ko-KR" sz="1100" dirty="0" err="1"/>
+              <a:t>init_project_rules</a:t>
+            </a:r>
+            <a:br>
+              <a:rPr lang="en-US" altLang="ko-KR" sz="1100" dirty="0"/>
+            </a:br>
+            <a:r>
+              <a:rPr lang="en-US" altLang="ko-KR" sz="1100" dirty="0"/>
+              <a:t>      </a:t>
+            </a:r>
+            <a:r>
+              <a:rPr lang="ko-KR" altLang="en-US" sz="1100" dirty="0"/>
+              <a:t>수영 스타일을 </a:t>
+            </a:r>
+            <a:r>
+              <a:rPr lang="en-US" altLang="ko-KR" sz="1100" dirty="0"/>
+              <a:t>…</a:t>
+            </a:r>
+            <a:r>
+              <a:rPr lang="ko-KR" altLang="en-US" sz="1100" dirty="0"/>
+              <a:t> </a:t>
+            </a:r>
+            <a:endParaRPr lang="en-US" altLang="ko-KR" sz="1100" dirty="0"/>
+          </a:p>
+          <a:p>
+            <a:endParaRPr lang="ko-KR" altLang="en-US" sz="1200" dirty="0"/>
           </a:p>
         </p:txBody>
       </p:sp>
     </p:spTree>
     <p:extLst>
       <p:ext uri="{BB962C8B-B14F-4D97-AF65-F5344CB8AC3E}">
-        <p14:creationId xmlns:p14="http://schemas.microsoft.com/office/powerpoint/2010/main" val="604985657"/>
+        <p14:creationId xmlns:p14="http://schemas.microsoft.com/office/powerpoint/2010/main" val="812039856"/>
+      </p:ext>
+    </p:extLst>
+  </p:cSld>
+  <p:clrMapOvr>
+    <a:masterClrMapping/>
+  </p:clrMapOvr>
+</p:sld>
+</file>
+
+<file path=ppt/slides/slide7.xml><?xml version="1.0" encoding="utf-8"?>
+<p:sld xmlns:a="http://schemas.openxmlformats.org/drawingml/2006/main" xmlns:r="http://schemas.openxmlformats.org/officeDocument/2006/relationships" xmlns:p="http://schemas.openxmlformats.org/presentationml/2006/main">
+  <p:cSld>
+    <p:spTree>
+      <p:nvGrpSpPr>
+        <p:cNvPr id="1" name="">
+          <a:extLst>
+            <a:ext uri="{FF2B5EF4-FFF2-40B4-BE49-F238E27FC236}">
+              <a16:creationId xmlns:a16="http://schemas.microsoft.com/office/drawing/2014/main" id="{5DC43573-E0C5-E50E-294A-2C0C4E6D70C2}"/>
+            </a:ext>
+          </a:extLst>
+        </p:cNvPr>
+        <p:cNvGrpSpPr/>
+        <p:nvPr/>
+      </p:nvGrpSpPr>
+      <p:grpSpPr>
+        <a:xfrm>
+          <a:off x="0" y="0"/>
+          <a:ext cx="0" cy="0"/>
+          <a:chOff x="0" y="0"/>
+          <a:chExt cx="0" cy="0"/>
+        </a:xfrm>
+      </p:grpSpPr>
+      <p:sp>
+        <p:nvSpPr>
+          <p:cNvPr id="2" name="제목 1">
+            <a:extLst>
+              <a:ext uri="{FF2B5EF4-FFF2-40B4-BE49-F238E27FC236}">
+                <a16:creationId xmlns:a16="http://schemas.microsoft.com/office/drawing/2014/main" id="{AEBAB4C0-3F0D-F393-F591-771BF7445A46}"/>
+              </a:ext>
+            </a:extLst>
+          </p:cNvPr>
+          <p:cNvSpPr>
+            <a:spLocks noGrp="1"/>
+          </p:cNvSpPr>
+          <p:nvPr>
+            <p:ph type="title"/>
+          </p:nvPr>
+        </p:nvSpPr>
+        <p:spPr/>
+        <p:txBody>
+          <a:bodyPr/>
+          <a:lstStyle/>
+          <a:p>
+            <a:r>
+              <a:rPr lang="en-US" altLang="ko-KR" dirty="0" err="1"/>
+              <a:t>Init_project_rules</a:t>
+            </a:r>
+            <a:r>
+              <a:rPr lang="en-US" altLang="ko-KR" dirty="0"/>
+              <a:t> -2 [</a:t>
+            </a:r>
+            <a:r>
+              <a:rPr lang="en-US" altLang="ko-KR" dirty="0" err="1"/>
+              <a:t>reseach_mode</a:t>
+            </a:r>
+            <a:r>
+              <a:rPr lang="en-US" altLang="ko-KR" dirty="0"/>
+              <a:t>]</a:t>
+            </a:r>
+            <a:endParaRPr lang="ko-KR" altLang="en-US" dirty="0"/>
+          </a:p>
+        </p:txBody>
+      </p:sp>
+      <p:pic>
+        <p:nvPicPr>
+          <p:cNvPr id="6" name="그림 5">
+            <a:extLst>
+              <a:ext uri="{FF2B5EF4-FFF2-40B4-BE49-F238E27FC236}">
+                <a16:creationId xmlns:a16="http://schemas.microsoft.com/office/drawing/2014/main" id="{11E6A5CA-BA7A-2342-8A5A-335FD8C6558F}"/>
+              </a:ext>
+            </a:extLst>
+          </p:cNvPr>
+          <p:cNvPicPr>
+            <a:picLocks noChangeAspect="1"/>
+          </p:cNvPicPr>
+          <p:nvPr/>
+        </p:nvPicPr>
+        <p:blipFill>
+          <a:blip r:embed="rId2"/>
+          <a:stretch>
+            <a:fillRect/>
+          </a:stretch>
+        </p:blipFill>
+        <p:spPr>
+          <a:xfrm>
+            <a:off x="351934" y="1821240"/>
+            <a:ext cx="5539611" cy="4852937"/>
+          </a:xfrm>
+          <a:prstGeom prst="rect">
+            <a:avLst/>
+          </a:prstGeom>
+        </p:spPr>
+      </p:pic>
+      <p:grpSp>
+        <p:nvGrpSpPr>
+          <p:cNvPr id="8" name="그룹 7">
+            <a:extLst>
+              <a:ext uri="{FF2B5EF4-FFF2-40B4-BE49-F238E27FC236}">
+                <a16:creationId xmlns:a16="http://schemas.microsoft.com/office/drawing/2014/main" id="{BB80CAB1-5176-2FA2-526A-84F7F1D434E3}"/>
+              </a:ext>
+            </a:extLst>
+          </p:cNvPr>
+          <p:cNvGrpSpPr/>
+          <p:nvPr/>
+        </p:nvGrpSpPr>
+        <p:grpSpPr>
+          <a:xfrm>
+            <a:off x="6012838" y="1821240"/>
+            <a:ext cx="4634232" cy="2307700"/>
+            <a:chOff x="6012838" y="1821240"/>
+            <a:chExt cx="4634232" cy="2307700"/>
+          </a:xfrm>
+        </p:grpSpPr>
+        <p:pic>
+          <p:nvPicPr>
+            <p:cNvPr id="5" name="그림 4">
+              <a:extLst>
+                <a:ext uri="{FF2B5EF4-FFF2-40B4-BE49-F238E27FC236}">
+                  <a16:creationId xmlns:a16="http://schemas.microsoft.com/office/drawing/2014/main" id="{44660B60-12A2-DCFB-27AE-41304DB82482}"/>
+                </a:ext>
+              </a:extLst>
+            </p:cNvPr>
+            <p:cNvPicPr>
+              <a:picLocks noChangeAspect="1"/>
+            </p:cNvPicPr>
+            <p:nvPr/>
+          </p:nvPicPr>
+          <p:blipFill>
+            <a:blip r:embed="rId3"/>
+            <a:srcRect b="44449"/>
+            <a:stretch>
+              <a:fillRect/>
+            </a:stretch>
+          </p:blipFill>
+          <p:spPr>
+            <a:xfrm>
+              <a:off x="6012838" y="1821240"/>
+              <a:ext cx="4634232" cy="2307700"/>
+            </a:xfrm>
+            <a:prstGeom prst="rect">
+              <a:avLst/>
+            </a:prstGeom>
+          </p:spPr>
+        </p:pic>
+        <p:sp>
+          <p:nvSpPr>
+            <p:cNvPr id="7" name="직사각형 6">
+              <a:extLst>
+                <a:ext uri="{FF2B5EF4-FFF2-40B4-BE49-F238E27FC236}">
+                  <a16:creationId xmlns:a16="http://schemas.microsoft.com/office/drawing/2014/main" id="{C6A00F48-7DC7-C524-5ADD-814D143D1052}"/>
+                </a:ext>
+              </a:extLst>
+            </p:cNvPr>
+            <p:cNvSpPr/>
+            <p:nvPr/>
+          </p:nvSpPr>
+          <p:spPr>
+            <a:xfrm>
+              <a:off x="6096000" y="3544478"/>
+              <a:ext cx="3679596" cy="311085"/>
+            </a:xfrm>
+            <a:prstGeom prst="rect">
+              <a:avLst/>
+            </a:prstGeom>
+            <a:noFill/>
+            <a:ln>
+              <a:solidFill>
+                <a:srgbClr val="FF0000"/>
+              </a:solidFill>
+            </a:ln>
+          </p:spPr>
+          <p:style>
+            <a:lnRef idx="2">
+              <a:schemeClr val="accent1">
+                <a:shade val="15000"/>
+              </a:schemeClr>
+            </a:lnRef>
+            <a:fillRef idx="1">
+              <a:schemeClr val="accent1"/>
+            </a:fillRef>
+            <a:effectRef idx="0">
+              <a:schemeClr val="accent1"/>
+            </a:effectRef>
+            <a:fontRef idx="minor">
+              <a:schemeClr val="lt1"/>
+            </a:fontRef>
+          </p:style>
+          <p:txBody>
+            <a:bodyPr rtlCol="0" anchor="ctr"/>
+            <a:lstStyle/>
+            <a:p>
+              <a:pPr algn="ctr"/>
+              <a:endParaRPr lang="ko-KR" altLang="en-US"/>
+            </a:p>
+          </p:txBody>
+        </p:sp>
+      </p:grpSp>
+      <p:sp>
+        <p:nvSpPr>
+          <p:cNvPr id="9" name="TextBox 8">
+            <a:extLst>
+              <a:ext uri="{FF2B5EF4-FFF2-40B4-BE49-F238E27FC236}">
+                <a16:creationId xmlns:a16="http://schemas.microsoft.com/office/drawing/2014/main" id="{899748EC-45FF-4D9A-997E-F2D7B57B38CE}"/>
+              </a:ext>
+            </a:extLst>
+          </p:cNvPr>
+          <p:cNvSpPr txBox="1"/>
+          <p:nvPr/>
+        </p:nvSpPr>
+        <p:spPr>
+          <a:xfrm>
+            <a:off x="5986021" y="4336330"/>
+            <a:ext cx="5854045" cy="646331"/>
+          </a:xfrm>
+          <a:prstGeom prst="rect">
+            <a:avLst/>
+          </a:prstGeom>
+          <a:noFill/>
+        </p:spPr>
+        <p:txBody>
+          <a:bodyPr wrap="square" rtlCol="0">
+            <a:spAutoFit/>
+          </a:bodyPr>
+          <a:lstStyle/>
+          <a:p>
+            <a:r>
+              <a:rPr lang="ko-KR" altLang="en-US" sz="1200" dirty="0"/>
+              <a:t>초기화 룰을 읽어보다가 마음에 들지 않아 기술적인 부분에서 더 자세한 조사가 필요하다</a:t>
+            </a:r>
+            <a:r>
+              <a:rPr lang="en-US" altLang="ko-KR" sz="1200" dirty="0"/>
+              <a:t> </a:t>
+            </a:r>
+            <a:r>
+              <a:rPr lang="ko-KR" altLang="en-US" sz="1200" dirty="0"/>
+              <a:t>판단되면 </a:t>
+            </a:r>
+            <a:r>
+              <a:rPr lang="en-US" altLang="ko-KR" sz="1200" dirty="0" err="1"/>
+              <a:t>research_mode</a:t>
+            </a:r>
+            <a:r>
+              <a:rPr lang="en-US" altLang="ko-KR" sz="1200" dirty="0"/>
+              <a:t> </a:t>
+            </a:r>
+            <a:r>
+              <a:rPr lang="ko-KR" altLang="en-US" sz="1200" dirty="0"/>
+              <a:t>로 </a:t>
+            </a:r>
+            <a:br>
+              <a:rPr lang="en-US" altLang="ko-KR" sz="1200" dirty="0"/>
+            </a:br>
+            <a:r>
+              <a:rPr lang="ko-KR" altLang="en-US" sz="1200" dirty="0"/>
+              <a:t>조사가 필요한 부분을 더 심층적으로 연구 조사 할 수 있다</a:t>
+            </a:r>
+            <a:r>
+              <a:rPr lang="en-US" altLang="ko-KR" sz="1200" dirty="0"/>
+              <a:t>.</a:t>
+            </a:r>
+            <a:endParaRPr lang="ko-KR" altLang="en-US" sz="1200" dirty="0"/>
+          </a:p>
+        </p:txBody>
+      </p:sp>
+    </p:spTree>
+    <p:extLst>
+      <p:ext uri="{BB962C8B-B14F-4D97-AF65-F5344CB8AC3E}">
+        <p14:creationId xmlns:p14="http://schemas.microsoft.com/office/powerpoint/2010/main" val="377350782"/>
+      </p:ext>
+    </p:extLst>
+  </p:cSld>
+  <p:clrMapOvr>
+    <a:masterClrMapping/>
+  </p:clrMapOvr>
+</p:sld>
+</file>
+
+<file path=ppt/slides/slide8.xml><?xml version="1.0" encoding="utf-8"?>
+<p:sld xmlns:a="http://schemas.openxmlformats.org/drawingml/2006/main" xmlns:r="http://schemas.openxmlformats.org/officeDocument/2006/relationships" xmlns:p="http://schemas.openxmlformats.org/presentationml/2006/main">
+  <p:cSld>
+    <p:spTree>
+      <p:nvGrpSpPr>
+        <p:cNvPr id="1" name=""/>
+        <p:cNvGrpSpPr/>
+        <p:nvPr/>
+      </p:nvGrpSpPr>
+      <p:grpSpPr>
+        <a:xfrm>
+          <a:off x="0" y="0"/>
+          <a:ext cx="0" cy="0"/>
+          <a:chOff x="0" y="0"/>
+          <a:chExt cx="0" cy="0"/>
+        </a:xfrm>
+      </p:grpSpPr>
+      <p:sp>
+        <p:nvSpPr>
+          <p:cNvPr id="2" name="제목 1">
+            <a:extLst>
+              <a:ext uri="{FF2B5EF4-FFF2-40B4-BE49-F238E27FC236}">
+                <a16:creationId xmlns:a16="http://schemas.microsoft.com/office/drawing/2014/main" id="{15AC5E2E-9825-558B-AD91-28F979A66DC4}"/>
+              </a:ext>
+            </a:extLst>
+          </p:cNvPr>
+          <p:cNvSpPr>
+            <a:spLocks noGrp="1"/>
+          </p:cNvSpPr>
+          <p:nvPr>
+            <p:ph type="title"/>
+          </p:nvPr>
+        </p:nvSpPr>
+        <p:spPr/>
+        <p:txBody>
+          <a:bodyPr/>
+          <a:lstStyle/>
+          <a:p>
+            <a:r>
+              <a:rPr lang="en-US" altLang="ko-KR" dirty="0" err="1"/>
+              <a:t>Plan_task</a:t>
+            </a:r>
+            <a:endParaRPr lang="ko-KR" altLang="en-US" dirty="0"/>
+          </a:p>
+        </p:txBody>
+      </p:sp>
+      <p:pic>
+        <p:nvPicPr>
+          <p:cNvPr id="4" name="그림 3">
+            <a:extLst>
+              <a:ext uri="{FF2B5EF4-FFF2-40B4-BE49-F238E27FC236}">
+                <a16:creationId xmlns:a16="http://schemas.microsoft.com/office/drawing/2014/main" id="{4B17CF49-0026-3A32-FCE9-E9B2744B205E}"/>
+              </a:ext>
+            </a:extLst>
+          </p:cNvPr>
+          <p:cNvPicPr>
+            <a:picLocks noChangeAspect="1"/>
+          </p:cNvPicPr>
+          <p:nvPr/>
+        </p:nvPicPr>
+        <p:blipFill>
+          <a:blip r:embed="rId2"/>
+          <a:stretch>
+            <a:fillRect/>
+          </a:stretch>
+        </p:blipFill>
+        <p:spPr>
+          <a:xfrm>
+            <a:off x="6096000" y="1875541"/>
+            <a:ext cx="2397551" cy="982602"/>
+          </a:xfrm>
+          <a:prstGeom prst="rect">
+            <a:avLst/>
+          </a:prstGeom>
+        </p:spPr>
+      </p:pic>
+      <p:pic>
+        <p:nvPicPr>
+          <p:cNvPr id="5" name="그림 4">
+            <a:extLst>
+              <a:ext uri="{FF2B5EF4-FFF2-40B4-BE49-F238E27FC236}">
+                <a16:creationId xmlns:a16="http://schemas.microsoft.com/office/drawing/2014/main" id="{2F3E1275-53C1-952C-EEFA-575CF5A4B093}"/>
+              </a:ext>
+            </a:extLst>
+          </p:cNvPr>
+          <p:cNvPicPr>
+            <a:picLocks noChangeAspect="1"/>
+          </p:cNvPicPr>
+          <p:nvPr/>
+        </p:nvPicPr>
+        <p:blipFill>
+          <a:blip r:embed="rId3"/>
+          <a:stretch>
+            <a:fillRect/>
+          </a:stretch>
+        </p:blipFill>
+        <p:spPr>
+          <a:xfrm>
+            <a:off x="399068" y="1875540"/>
+            <a:ext cx="5539611" cy="4852937"/>
+          </a:xfrm>
+          <a:prstGeom prst="rect">
+            <a:avLst/>
+          </a:prstGeom>
+        </p:spPr>
+      </p:pic>
+      <p:sp>
+        <p:nvSpPr>
+          <p:cNvPr id="6" name="TextBox 5">
+            <a:extLst>
+              <a:ext uri="{FF2B5EF4-FFF2-40B4-BE49-F238E27FC236}">
+                <a16:creationId xmlns:a16="http://schemas.microsoft.com/office/drawing/2014/main" id="{1B52CE1E-FF17-1232-CEE2-A52994EBA2CB}"/>
+              </a:ext>
+            </a:extLst>
+          </p:cNvPr>
+          <p:cNvSpPr txBox="1"/>
+          <p:nvPr/>
+        </p:nvSpPr>
+        <p:spPr>
+          <a:xfrm>
+            <a:off x="6096000" y="2858143"/>
+            <a:ext cx="5894895" cy="430887"/>
+          </a:xfrm>
+          <a:prstGeom prst="rect">
+            <a:avLst/>
+          </a:prstGeom>
+          <a:noFill/>
+        </p:spPr>
+        <p:txBody>
+          <a:bodyPr wrap="square" rtlCol="0">
+            <a:spAutoFit/>
+          </a:bodyPr>
+          <a:lstStyle/>
+          <a:p>
+            <a:r>
+              <a:rPr lang="ko-KR" altLang="en-US" sz="1100" dirty="0"/>
+              <a:t>프로젝트 룰을 통해 </a:t>
+            </a:r>
+            <a:r>
+              <a:rPr lang="en-US" altLang="ko-KR" sz="1100" dirty="0"/>
+              <a:t>Plan</a:t>
+            </a:r>
+            <a:r>
+              <a:rPr lang="ko-KR" altLang="en-US" sz="1100" dirty="0"/>
+              <a:t>을 세우고 싶을 때 사용하는 명령어</a:t>
+            </a:r>
+            <a:r>
+              <a:rPr lang="en-US" altLang="ko-KR" sz="1100" dirty="0"/>
+              <a:t>.</a:t>
+            </a:r>
+            <a:br>
+              <a:rPr lang="en-US" altLang="ko-KR" sz="1100" dirty="0"/>
+            </a:br>
+            <a:endParaRPr lang="ko-KR" altLang="en-US" sz="1100" dirty="0"/>
+          </a:p>
+        </p:txBody>
+      </p:sp>
+      <p:pic>
+        <p:nvPicPr>
+          <p:cNvPr id="8" name="그림 7">
+            <a:extLst>
+              <a:ext uri="{FF2B5EF4-FFF2-40B4-BE49-F238E27FC236}">
+                <a16:creationId xmlns:a16="http://schemas.microsoft.com/office/drawing/2014/main" id="{5678FDE4-4D56-05C4-376A-BB57555FDB12}"/>
+              </a:ext>
+            </a:extLst>
+          </p:cNvPr>
+          <p:cNvPicPr>
+            <a:picLocks noChangeAspect="1"/>
+          </p:cNvPicPr>
+          <p:nvPr/>
+        </p:nvPicPr>
+        <p:blipFill>
+          <a:blip r:embed="rId4"/>
+          <a:stretch>
+            <a:fillRect/>
+          </a:stretch>
+        </p:blipFill>
+        <p:spPr>
+          <a:xfrm>
+            <a:off x="6096000" y="3355669"/>
+            <a:ext cx="5195948" cy="3372808"/>
+          </a:xfrm>
+          <a:prstGeom prst="rect">
+            <a:avLst/>
+          </a:prstGeom>
+        </p:spPr>
+      </p:pic>
+    </p:spTree>
+    <p:extLst>
+      <p:ext uri="{BB962C8B-B14F-4D97-AF65-F5344CB8AC3E}">
+        <p14:creationId xmlns:p14="http://schemas.microsoft.com/office/powerpoint/2010/main" val="1020397168"/>
+      </p:ext>
+    </p:extLst>
+  </p:cSld>
+  <p:clrMapOvr>
+    <a:masterClrMapping/>
+  </p:clrMapOvr>
+</p:sld>
+</file>
+
+<file path=ppt/slides/slide9.xml><?xml version="1.0" encoding="utf-8"?>
+<p:sld xmlns:a="http://schemas.openxmlformats.org/drawingml/2006/main" xmlns:r="http://schemas.openxmlformats.org/officeDocument/2006/relationships" xmlns:p="http://schemas.openxmlformats.org/presentationml/2006/main">
+  <p:cSld>
+    <p:spTree>
+      <p:nvGrpSpPr>
+        <p:cNvPr id="1" name=""/>
+        <p:cNvGrpSpPr/>
+        <p:nvPr/>
+      </p:nvGrpSpPr>
+      <p:grpSpPr>
+        <a:xfrm>
+          <a:off x="0" y="0"/>
+          <a:ext cx="0" cy="0"/>
+          <a:chOff x="0" y="0"/>
+          <a:chExt cx="0" cy="0"/>
+        </a:xfrm>
+      </p:grpSpPr>
+      <p:sp>
+        <p:nvSpPr>
+          <p:cNvPr id="2" name="제목 1">
+            <a:extLst>
+              <a:ext uri="{FF2B5EF4-FFF2-40B4-BE49-F238E27FC236}">
+                <a16:creationId xmlns:a16="http://schemas.microsoft.com/office/drawing/2014/main" id="{EE4AD1B9-E4BD-CE0B-4F94-7F5692E2E8AF}"/>
+              </a:ext>
+            </a:extLst>
+          </p:cNvPr>
+          <p:cNvSpPr>
+            <a:spLocks noGrp="1"/>
+          </p:cNvSpPr>
+          <p:nvPr>
+            <p:ph type="title"/>
+          </p:nvPr>
+        </p:nvSpPr>
+        <p:spPr/>
+        <p:txBody>
+          <a:bodyPr/>
+          <a:lstStyle/>
+          <a:p>
+            <a:r>
+              <a:rPr lang="en-US" altLang="ko-KR" dirty="0" err="1"/>
+              <a:t>Plan_task</a:t>
+            </a:r>
+            <a:r>
+              <a:rPr lang="en-US" altLang="ko-KR" dirty="0"/>
+              <a:t> -2 [</a:t>
+            </a:r>
+            <a:r>
+              <a:rPr lang="en-US" altLang="ko-KR" dirty="0" err="1"/>
+              <a:t>list_tasks</a:t>
+            </a:r>
+            <a:r>
+              <a:rPr lang="en-US" altLang="ko-KR" dirty="0"/>
+              <a:t>]</a:t>
+            </a:r>
+            <a:endParaRPr lang="ko-KR" altLang="en-US" dirty="0"/>
+          </a:p>
+        </p:txBody>
+      </p:sp>
+      <p:pic>
+        <p:nvPicPr>
+          <p:cNvPr id="4" name="그림 3">
+            <a:extLst>
+              <a:ext uri="{FF2B5EF4-FFF2-40B4-BE49-F238E27FC236}">
+                <a16:creationId xmlns:a16="http://schemas.microsoft.com/office/drawing/2014/main" id="{43736846-A781-C48D-D8DE-3D91F1A91064}"/>
+              </a:ext>
+            </a:extLst>
+          </p:cNvPr>
+          <p:cNvPicPr>
+            <a:picLocks noChangeAspect="1"/>
+          </p:cNvPicPr>
+          <p:nvPr/>
+        </p:nvPicPr>
+        <p:blipFill>
+          <a:blip r:embed="rId2"/>
+          <a:stretch>
+            <a:fillRect/>
+          </a:stretch>
+        </p:blipFill>
+        <p:spPr>
+          <a:xfrm>
+            <a:off x="1185275" y="1961376"/>
+            <a:ext cx="2547739" cy="904935"/>
+          </a:xfrm>
+          <a:prstGeom prst="rect">
+            <a:avLst/>
+          </a:prstGeom>
+        </p:spPr>
+      </p:pic>
+      <p:pic>
+        <p:nvPicPr>
+          <p:cNvPr id="6" name="그림 5">
+            <a:extLst>
+              <a:ext uri="{FF2B5EF4-FFF2-40B4-BE49-F238E27FC236}">
+                <a16:creationId xmlns:a16="http://schemas.microsoft.com/office/drawing/2014/main" id="{F06BA195-F50F-4854-F19E-664DDCB05B82}"/>
+              </a:ext>
+            </a:extLst>
+          </p:cNvPr>
+          <p:cNvPicPr>
+            <a:picLocks noChangeAspect="1"/>
+          </p:cNvPicPr>
+          <p:nvPr/>
+        </p:nvPicPr>
+        <p:blipFill>
+          <a:blip r:embed="rId3"/>
+          <a:stretch>
+            <a:fillRect/>
+          </a:stretch>
+        </p:blipFill>
+        <p:spPr>
+          <a:xfrm>
+            <a:off x="1185275" y="2967950"/>
+            <a:ext cx="3358445" cy="3748162"/>
+          </a:xfrm>
+          <a:prstGeom prst="rect">
+            <a:avLst/>
+          </a:prstGeom>
+        </p:spPr>
+      </p:pic>
+      <p:sp>
+        <p:nvSpPr>
+          <p:cNvPr id="7" name="TextBox 6">
+            <a:extLst>
+              <a:ext uri="{FF2B5EF4-FFF2-40B4-BE49-F238E27FC236}">
+                <a16:creationId xmlns:a16="http://schemas.microsoft.com/office/drawing/2014/main" id="{790450A5-6854-83EC-9EE0-63D36BFC54DB}"/>
+              </a:ext>
+            </a:extLst>
+          </p:cNvPr>
+          <p:cNvSpPr txBox="1"/>
+          <p:nvPr/>
+        </p:nvSpPr>
+        <p:spPr>
+          <a:xfrm>
+            <a:off x="4901938" y="1961376"/>
+            <a:ext cx="6104787" cy="307777"/>
+          </a:xfrm>
+          <a:prstGeom prst="rect">
+            <a:avLst/>
+          </a:prstGeom>
+          <a:noFill/>
+        </p:spPr>
+        <p:txBody>
+          <a:bodyPr wrap="square" rtlCol="0">
+            <a:spAutoFit/>
+          </a:bodyPr>
+          <a:lstStyle/>
+          <a:p>
+            <a:r>
+              <a:rPr lang="en-US" altLang="ko-KR" sz="1400" dirty="0" err="1"/>
+              <a:t>list_tasks</a:t>
+            </a:r>
+            <a:r>
+              <a:rPr lang="en-US" altLang="ko-KR" sz="1400" dirty="0"/>
+              <a:t> </a:t>
+            </a:r>
+            <a:r>
+              <a:rPr lang="en-US" altLang="ko-KR" sz="1400" dirty="0">
+                <a:sym typeface="Wingdings" panose="05000000000000000000" pitchFamily="2" charset="2"/>
+              </a:rPr>
+              <a:t> </a:t>
+            </a:r>
+            <a:r>
+              <a:rPr lang="ko-KR" altLang="en-US" sz="1400" dirty="0">
+                <a:sym typeface="Wingdings" panose="05000000000000000000" pitchFamily="2" charset="2"/>
+              </a:rPr>
+              <a:t>세워진 계획 중 진행 상태 확인 명령어</a:t>
+            </a:r>
+            <a:r>
+              <a:rPr lang="en-US" altLang="ko-KR" sz="1400" dirty="0">
+                <a:sym typeface="Wingdings" panose="05000000000000000000" pitchFamily="2" charset="2"/>
+              </a:rPr>
+              <a:t>.</a:t>
+            </a:r>
+            <a:endParaRPr lang="ko-KR" altLang="en-US" sz="1400" dirty="0"/>
+          </a:p>
+        </p:txBody>
+      </p:sp>
+    </p:spTree>
+    <p:extLst>
+      <p:ext uri="{BB962C8B-B14F-4D97-AF65-F5344CB8AC3E}">
+        <p14:creationId xmlns:p14="http://schemas.microsoft.com/office/powerpoint/2010/main" val="1328418983"/>
       </p:ext>
     </p:extLst>
   </p:cSld>

</xml_diff>

<commit_message>
shrimp-task manager 설치 (공식)
</commit_message>
<xml_diff>
--- a/PPT정리/28. Shrimp Task Master AI.pptx
+++ b/PPT정리/28. Shrimp Task Master AI.pptx
@@ -9,19 +9,21 @@
     <p:sldId id="261" r:id="rId3"/>
     <p:sldId id="258" r:id="rId4"/>
     <p:sldId id="262" r:id="rId5"/>
-    <p:sldId id="260" r:id="rId6"/>
-    <p:sldId id="263" r:id="rId7"/>
-    <p:sldId id="264" r:id="rId8"/>
-    <p:sldId id="265" r:id="rId9"/>
-    <p:sldId id="266" r:id="rId10"/>
-    <p:sldId id="267" r:id="rId11"/>
-    <p:sldId id="268" r:id="rId12"/>
-    <p:sldId id="269" r:id="rId13"/>
-    <p:sldId id="274" r:id="rId14"/>
-    <p:sldId id="270" r:id="rId15"/>
-    <p:sldId id="271" r:id="rId16"/>
-    <p:sldId id="272" r:id="rId17"/>
-    <p:sldId id="273" r:id="rId18"/>
+    <p:sldId id="275" r:id="rId6"/>
+    <p:sldId id="277" r:id="rId7"/>
+    <p:sldId id="260" r:id="rId8"/>
+    <p:sldId id="263" r:id="rId9"/>
+    <p:sldId id="264" r:id="rId10"/>
+    <p:sldId id="265" r:id="rId11"/>
+    <p:sldId id="266" r:id="rId12"/>
+    <p:sldId id="267" r:id="rId13"/>
+    <p:sldId id="268" r:id="rId14"/>
+    <p:sldId id="269" r:id="rId15"/>
+    <p:sldId id="274" r:id="rId16"/>
+    <p:sldId id="270" r:id="rId17"/>
+    <p:sldId id="271" r:id="rId18"/>
+    <p:sldId id="272" r:id="rId19"/>
+    <p:sldId id="273" r:id="rId20"/>
   </p:sldIdLst>
   <p:sldSz cx="12192000" cy="6858000"/>
   <p:notesSz cx="6858000" cy="9144000"/>
@@ -354,7 +356,7 @@
           <a:p>
             <a:fld id="{FDCCB462-B40D-428D-8FC4-842D104849FE}" type="datetimeFigureOut">
               <a:rPr lang="ko-KR" altLang="en-US" smtClean="0"/>
-              <a:t>2026-07-01</a:t>
+              <a:t>2026-07-02</a:t>
             </a:fld>
             <a:endParaRPr lang="ko-KR" altLang="en-US"/>
           </a:p>
@@ -562,7 +564,7 @@
           <a:p>
             <a:fld id="{FDCCB462-B40D-428D-8FC4-842D104849FE}" type="datetimeFigureOut">
               <a:rPr lang="ko-KR" altLang="en-US" smtClean="0"/>
-              <a:t>2026-07-01</a:t>
+              <a:t>2026-07-02</a:t>
             </a:fld>
             <a:endParaRPr lang="ko-KR" altLang="en-US"/>
           </a:p>
@@ -818,7 +820,7 @@
           <a:p>
             <a:fld id="{FDCCB462-B40D-428D-8FC4-842D104849FE}" type="datetimeFigureOut">
               <a:rPr lang="ko-KR" altLang="en-US" smtClean="0"/>
-              <a:t>2026-07-01</a:t>
+              <a:t>2026-07-02</a:t>
             </a:fld>
             <a:endParaRPr lang="ko-KR" altLang="en-US"/>
           </a:p>
@@ -992,7 +994,7 @@
           <a:p>
             <a:fld id="{FDCCB462-B40D-428D-8FC4-842D104849FE}" type="datetimeFigureOut">
               <a:rPr lang="ko-KR" altLang="en-US" smtClean="0"/>
-              <a:t>2026-07-01</a:t>
+              <a:t>2026-07-02</a:t>
             </a:fld>
             <a:endParaRPr lang="ko-KR" altLang="en-US"/>
           </a:p>
@@ -1335,7 +1337,7 @@
           <a:p>
             <a:fld id="{FDCCB462-B40D-428D-8FC4-842D104849FE}" type="datetimeFigureOut">
               <a:rPr lang="ko-KR" altLang="en-US" smtClean="0"/>
-              <a:t>2026-07-01</a:t>
+              <a:t>2026-07-02</a:t>
             </a:fld>
             <a:endParaRPr lang="ko-KR" altLang="en-US"/>
           </a:p>
@@ -1610,7 +1612,7 @@
           <a:p>
             <a:fld id="{FDCCB462-B40D-428D-8FC4-842D104849FE}" type="datetimeFigureOut">
               <a:rPr lang="ko-KR" altLang="en-US" smtClean="0"/>
-              <a:t>2026-07-01</a:t>
+              <a:t>2026-07-02</a:t>
             </a:fld>
             <a:endParaRPr lang="ko-KR" altLang="en-US"/>
           </a:p>
@@ -1989,7 +1991,7 @@
           <a:p>
             <a:fld id="{FDCCB462-B40D-428D-8FC4-842D104849FE}" type="datetimeFigureOut">
               <a:rPr lang="ko-KR" altLang="en-US" smtClean="0"/>
-              <a:t>2026-07-01</a:t>
+              <a:t>2026-07-02</a:t>
             </a:fld>
             <a:endParaRPr lang="ko-KR" altLang="en-US"/>
           </a:p>
@@ -2107,7 +2109,7 @@
           <a:p>
             <a:fld id="{FDCCB462-B40D-428D-8FC4-842D104849FE}" type="datetimeFigureOut">
               <a:rPr lang="ko-KR" altLang="en-US" smtClean="0"/>
-              <a:t>2026-07-01</a:t>
+              <a:t>2026-07-02</a:t>
             </a:fld>
             <a:endParaRPr lang="ko-KR" altLang="en-US"/>
           </a:p>
@@ -2278,7 +2280,7 @@
           <a:p>
             <a:fld id="{FDCCB462-B40D-428D-8FC4-842D104849FE}" type="datetimeFigureOut">
               <a:rPr lang="ko-KR" altLang="en-US" smtClean="0"/>
-              <a:t>2026-07-01</a:t>
+              <a:t>2026-07-02</a:t>
             </a:fld>
             <a:endParaRPr lang="ko-KR" altLang="en-US"/>
           </a:p>
@@ -2632,7 +2634,7 @@
           <a:p>
             <a:fld id="{FDCCB462-B40D-428D-8FC4-842D104849FE}" type="datetimeFigureOut">
               <a:rPr lang="ko-KR" altLang="en-US" smtClean="0"/>
-              <a:t>2026-07-01</a:t>
+              <a:t>2026-07-02</a:t>
             </a:fld>
             <a:endParaRPr lang="ko-KR" altLang="en-US"/>
           </a:p>
@@ -3014,7 +3016,7 @@
           <a:p>
             <a:fld id="{FDCCB462-B40D-428D-8FC4-842D104849FE}" type="datetimeFigureOut">
               <a:rPr lang="ko-KR" altLang="en-US" smtClean="0"/>
-              <a:t>2026-07-01</a:t>
+              <a:t>2026-07-02</a:t>
             </a:fld>
             <a:endParaRPr lang="ko-KR" altLang="en-US"/>
           </a:p>
@@ -3301,7 +3303,7 @@
           <a:p>
             <a:fld id="{FDCCB462-B40D-428D-8FC4-842D104849FE}" type="datetimeFigureOut">
               <a:rPr lang="ko-KR" altLang="en-US" smtClean="0"/>
-              <a:t>2026-07-01</a:t>
+              <a:t>2026-07-02</a:t>
             </a:fld>
             <a:endParaRPr lang="ko-KR" altLang="en-US"/>
           </a:p>
@@ -3916,6 +3918,395 @@
           <p:cNvPr id="2" name="제목 1">
             <a:extLst>
               <a:ext uri="{FF2B5EF4-FFF2-40B4-BE49-F238E27FC236}">
+                <a16:creationId xmlns:a16="http://schemas.microsoft.com/office/drawing/2014/main" id="{15AC5E2E-9825-558B-AD91-28F979A66DC4}"/>
+              </a:ext>
+            </a:extLst>
+          </p:cNvPr>
+          <p:cNvSpPr>
+            <a:spLocks noGrp="1"/>
+          </p:cNvSpPr>
+          <p:nvPr>
+            <p:ph type="title"/>
+          </p:nvPr>
+        </p:nvSpPr>
+        <p:spPr/>
+        <p:txBody>
+          <a:bodyPr/>
+          <a:lstStyle/>
+          <a:p>
+            <a:r>
+              <a:rPr lang="en-US" altLang="ko-KR" dirty="0" err="1"/>
+              <a:t>Plan_task</a:t>
+            </a:r>
+            <a:endParaRPr lang="ko-KR" altLang="en-US" dirty="0"/>
+          </a:p>
+        </p:txBody>
+      </p:sp>
+      <p:pic>
+        <p:nvPicPr>
+          <p:cNvPr id="4" name="그림 3">
+            <a:extLst>
+              <a:ext uri="{FF2B5EF4-FFF2-40B4-BE49-F238E27FC236}">
+                <a16:creationId xmlns:a16="http://schemas.microsoft.com/office/drawing/2014/main" id="{4B17CF49-0026-3A32-FCE9-E9B2744B205E}"/>
+              </a:ext>
+            </a:extLst>
+          </p:cNvPr>
+          <p:cNvPicPr>
+            <a:picLocks noChangeAspect="1"/>
+          </p:cNvPicPr>
+          <p:nvPr/>
+        </p:nvPicPr>
+        <p:blipFill>
+          <a:blip r:embed="rId2"/>
+          <a:stretch>
+            <a:fillRect/>
+          </a:stretch>
+        </p:blipFill>
+        <p:spPr>
+          <a:xfrm>
+            <a:off x="6096000" y="1875541"/>
+            <a:ext cx="2397551" cy="982602"/>
+          </a:xfrm>
+          <a:prstGeom prst="rect">
+            <a:avLst/>
+          </a:prstGeom>
+        </p:spPr>
+      </p:pic>
+      <p:pic>
+        <p:nvPicPr>
+          <p:cNvPr id="5" name="그림 4">
+            <a:extLst>
+              <a:ext uri="{FF2B5EF4-FFF2-40B4-BE49-F238E27FC236}">
+                <a16:creationId xmlns:a16="http://schemas.microsoft.com/office/drawing/2014/main" id="{2F3E1275-53C1-952C-EEFA-575CF5A4B093}"/>
+              </a:ext>
+            </a:extLst>
+          </p:cNvPr>
+          <p:cNvPicPr>
+            <a:picLocks noChangeAspect="1"/>
+          </p:cNvPicPr>
+          <p:nvPr/>
+        </p:nvPicPr>
+        <p:blipFill>
+          <a:blip r:embed="rId3"/>
+          <a:stretch>
+            <a:fillRect/>
+          </a:stretch>
+        </p:blipFill>
+        <p:spPr>
+          <a:xfrm>
+            <a:off x="399068" y="1875540"/>
+            <a:ext cx="5539611" cy="4852937"/>
+          </a:xfrm>
+          <a:prstGeom prst="rect">
+            <a:avLst/>
+          </a:prstGeom>
+        </p:spPr>
+      </p:pic>
+      <p:sp>
+        <p:nvSpPr>
+          <p:cNvPr id="6" name="TextBox 5">
+            <a:extLst>
+              <a:ext uri="{FF2B5EF4-FFF2-40B4-BE49-F238E27FC236}">
+                <a16:creationId xmlns:a16="http://schemas.microsoft.com/office/drawing/2014/main" id="{1B52CE1E-FF17-1232-CEE2-A52994EBA2CB}"/>
+              </a:ext>
+            </a:extLst>
+          </p:cNvPr>
+          <p:cNvSpPr txBox="1"/>
+          <p:nvPr/>
+        </p:nvSpPr>
+        <p:spPr>
+          <a:xfrm>
+            <a:off x="6096000" y="2858143"/>
+            <a:ext cx="5894895" cy="430887"/>
+          </a:xfrm>
+          <a:prstGeom prst="rect">
+            <a:avLst/>
+          </a:prstGeom>
+          <a:noFill/>
+        </p:spPr>
+        <p:txBody>
+          <a:bodyPr wrap="square" rtlCol="0">
+            <a:spAutoFit/>
+          </a:bodyPr>
+          <a:lstStyle/>
+          <a:p>
+            <a:r>
+              <a:rPr lang="ko-KR" altLang="en-US" sz="1100" dirty="0"/>
+              <a:t>프로젝트 룰을 통해 </a:t>
+            </a:r>
+            <a:r>
+              <a:rPr lang="en-US" altLang="ko-KR" sz="1100" dirty="0"/>
+              <a:t>Plan</a:t>
+            </a:r>
+            <a:r>
+              <a:rPr lang="ko-KR" altLang="en-US" sz="1100" dirty="0"/>
+              <a:t>을 세우고 싶을 때 사용하는 명령어</a:t>
+            </a:r>
+            <a:r>
+              <a:rPr lang="en-US" altLang="ko-KR" sz="1100" dirty="0"/>
+              <a:t>.</a:t>
+            </a:r>
+            <a:br>
+              <a:rPr lang="en-US" altLang="ko-KR" sz="1100" dirty="0"/>
+            </a:br>
+            <a:endParaRPr lang="ko-KR" altLang="en-US" sz="1100" dirty="0"/>
+          </a:p>
+        </p:txBody>
+      </p:sp>
+      <p:pic>
+        <p:nvPicPr>
+          <p:cNvPr id="8" name="그림 7">
+            <a:extLst>
+              <a:ext uri="{FF2B5EF4-FFF2-40B4-BE49-F238E27FC236}">
+                <a16:creationId xmlns:a16="http://schemas.microsoft.com/office/drawing/2014/main" id="{5678FDE4-4D56-05C4-376A-BB57555FDB12}"/>
+              </a:ext>
+            </a:extLst>
+          </p:cNvPr>
+          <p:cNvPicPr>
+            <a:picLocks noChangeAspect="1"/>
+          </p:cNvPicPr>
+          <p:nvPr/>
+        </p:nvPicPr>
+        <p:blipFill>
+          <a:blip r:embed="rId4"/>
+          <a:stretch>
+            <a:fillRect/>
+          </a:stretch>
+        </p:blipFill>
+        <p:spPr>
+          <a:xfrm>
+            <a:off x="6096000" y="3355669"/>
+            <a:ext cx="5195948" cy="3372808"/>
+          </a:xfrm>
+          <a:prstGeom prst="rect">
+            <a:avLst/>
+          </a:prstGeom>
+        </p:spPr>
+      </p:pic>
+    </p:spTree>
+    <p:extLst>
+      <p:ext uri="{BB962C8B-B14F-4D97-AF65-F5344CB8AC3E}">
+        <p14:creationId xmlns:p14="http://schemas.microsoft.com/office/powerpoint/2010/main" val="1020397168"/>
+      </p:ext>
+    </p:extLst>
+  </p:cSld>
+  <p:clrMapOvr>
+    <a:masterClrMapping/>
+  </p:clrMapOvr>
+</p:sld>
+</file>
+
+<file path=ppt/slides/slide11.xml><?xml version="1.0" encoding="utf-8"?>
+<p:sld xmlns:a="http://schemas.openxmlformats.org/drawingml/2006/main" xmlns:r="http://schemas.openxmlformats.org/officeDocument/2006/relationships" xmlns:p="http://schemas.openxmlformats.org/presentationml/2006/main">
+  <p:cSld>
+    <p:spTree>
+      <p:nvGrpSpPr>
+        <p:cNvPr id="1" name=""/>
+        <p:cNvGrpSpPr/>
+        <p:nvPr/>
+      </p:nvGrpSpPr>
+      <p:grpSpPr>
+        <a:xfrm>
+          <a:off x="0" y="0"/>
+          <a:ext cx="0" cy="0"/>
+          <a:chOff x="0" y="0"/>
+          <a:chExt cx="0" cy="0"/>
+        </a:xfrm>
+      </p:grpSpPr>
+      <p:sp>
+        <p:nvSpPr>
+          <p:cNvPr id="2" name="제목 1">
+            <a:extLst>
+              <a:ext uri="{FF2B5EF4-FFF2-40B4-BE49-F238E27FC236}">
+                <a16:creationId xmlns:a16="http://schemas.microsoft.com/office/drawing/2014/main" id="{EE4AD1B9-E4BD-CE0B-4F94-7F5692E2E8AF}"/>
+              </a:ext>
+            </a:extLst>
+          </p:cNvPr>
+          <p:cNvSpPr>
+            <a:spLocks noGrp="1"/>
+          </p:cNvSpPr>
+          <p:nvPr>
+            <p:ph type="title"/>
+          </p:nvPr>
+        </p:nvSpPr>
+        <p:spPr/>
+        <p:txBody>
+          <a:bodyPr/>
+          <a:lstStyle/>
+          <a:p>
+            <a:r>
+              <a:rPr lang="en-US" altLang="ko-KR" dirty="0" err="1"/>
+              <a:t>Plan_task</a:t>
+            </a:r>
+            <a:r>
+              <a:rPr lang="en-US" altLang="ko-KR" dirty="0"/>
+              <a:t> -2 [</a:t>
+            </a:r>
+            <a:r>
+              <a:rPr lang="en-US" altLang="ko-KR" dirty="0" err="1"/>
+              <a:t>list_tasks</a:t>
+            </a:r>
+            <a:r>
+              <a:rPr lang="en-US" altLang="ko-KR" dirty="0"/>
+              <a:t>]</a:t>
+            </a:r>
+            <a:endParaRPr lang="ko-KR" altLang="en-US" dirty="0"/>
+          </a:p>
+        </p:txBody>
+      </p:sp>
+      <p:pic>
+        <p:nvPicPr>
+          <p:cNvPr id="4" name="그림 3">
+            <a:extLst>
+              <a:ext uri="{FF2B5EF4-FFF2-40B4-BE49-F238E27FC236}">
+                <a16:creationId xmlns:a16="http://schemas.microsoft.com/office/drawing/2014/main" id="{43736846-A781-C48D-D8DE-3D91F1A91064}"/>
+              </a:ext>
+            </a:extLst>
+          </p:cNvPr>
+          <p:cNvPicPr>
+            <a:picLocks noChangeAspect="1"/>
+          </p:cNvPicPr>
+          <p:nvPr/>
+        </p:nvPicPr>
+        <p:blipFill>
+          <a:blip r:embed="rId2"/>
+          <a:stretch>
+            <a:fillRect/>
+          </a:stretch>
+        </p:blipFill>
+        <p:spPr>
+          <a:xfrm>
+            <a:off x="1185275" y="1961376"/>
+            <a:ext cx="2547739" cy="904935"/>
+          </a:xfrm>
+          <a:prstGeom prst="rect">
+            <a:avLst/>
+          </a:prstGeom>
+        </p:spPr>
+      </p:pic>
+      <p:pic>
+        <p:nvPicPr>
+          <p:cNvPr id="6" name="그림 5">
+            <a:extLst>
+              <a:ext uri="{FF2B5EF4-FFF2-40B4-BE49-F238E27FC236}">
+                <a16:creationId xmlns:a16="http://schemas.microsoft.com/office/drawing/2014/main" id="{F06BA195-F50F-4854-F19E-664DDCB05B82}"/>
+              </a:ext>
+            </a:extLst>
+          </p:cNvPr>
+          <p:cNvPicPr>
+            <a:picLocks noChangeAspect="1"/>
+          </p:cNvPicPr>
+          <p:nvPr/>
+        </p:nvPicPr>
+        <p:blipFill>
+          <a:blip r:embed="rId3"/>
+          <a:stretch>
+            <a:fillRect/>
+          </a:stretch>
+        </p:blipFill>
+        <p:spPr>
+          <a:xfrm>
+            <a:off x="1185275" y="2967950"/>
+            <a:ext cx="3358445" cy="3748162"/>
+          </a:xfrm>
+          <a:prstGeom prst="rect">
+            <a:avLst/>
+          </a:prstGeom>
+        </p:spPr>
+      </p:pic>
+      <p:sp>
+        <p:nvSpPr>
+          <p:cNvPr id="7" name="TextBox 6">
+            <a:extLst>
+              <a:ext uri="{FF2B5EF4-FFF2-40B4-BE49-F238E27FC236}">
+                <a16:creationId xmlns:a16="http://schemas.microsoft.com/office/drawing/2014/main" id="{790450A5-6854-83EC-9EE0-63D36BFC54DB}"/>
+              </a:ext>
+            </a:extLst>
+          </p:cNvPr>
+          <p:cNvSpPr txBox="1"/>
+          <p:nvPr/>
+        </p:nvSpPr>
+        <p:spPr>
+          <a:xfrm>
+            <a:off x="4901938" y="1961376"/>
+            <a:ext cx="6104787" cy="307777"/>
+          </a:xfrm>
+          <a:prstGeom prst="rect">
+            <a:avLst/>
+          </a:prstGeom>
+          <a:noFill/>
+        </p:spPr>
+        <p:txBody>
+          <a:bodyPr wrap="square" rtlCol="0">
+            <a:spAutoFit/>
+          </a:bodyPr>
+          <a:lstStyle/>
+          <a:p>
+            <a:r>
+              <a:rPr lang="en-US" altLang="ko-KR" sz="1400" dirty="0" err="1"/>
+              <a:t>list_tasks</a:t>
+            </a:r>
+            <a:r>
+              <a:rPr lang="en-US" altLang="ko-KR" sz="1400" dirty="0"/>
+              <a:t> </a:t>
+            </a:r>
+            <a:r>
+              <a:rPr lang="en-US" altLang="ko-KR" sz="1400" dirty="0">
+                <a:sym typeface="Wingdings" panose="05000000000000000000" pitchFamily="2" charset="2"/>
+              </a:rPr>
+              <a:t> </a:t>
+            </a:r>
+            <a:r>
+              <a:rPr lang="ko-KR" altLang="en-US" sz="1400" dirty="0">
+                <a:sym typeface="Wingdings" panose="05000000000000000000" pitchFamily="2" charset="2"/>
+              </a:rPr>
+              <a:t>세워진 계획 중 진행 상태 확인 명령어</a:t>
+            </a:r>
+            <a:r>
+              <a:rPr lang="en-US" altLang="ko-KR" sz="1400" dirty="0">
+                <a:sym typeface="Wingdings" panose="05000000000000000000" pitchFamily="2" charset="2"/>
+              </a:rPr>
+              <a:t>.</a:t>
+            </a:r>
+            <a:endParaRPr lang="ko-KR" altLang="en-US" sz="1400" dirty="0"/>
+          </a:p>
+        </p:txBody>
+      </p:sp>
+    </p:spTree>
+    <p:extLst>
+      <p:ext uri="{BB962C8B-B14F-4D97-AF65-F5344CB8AC3E}">
+        <p14:creationId xmlns:p14="http://schemas.microsoft.com/office/powerpoint/2010/main" val="1328418983"/>
+      </p:ext>
+    </p:extLst>
+  </p:cSld>
+  <p:clrMapOvr>
+    <a:masterClrMapping/>
+  </p:clrMapOvr>
+</p:sld>
+</file>
+
+<file path=ppt/slides/slide12.xml><?xml version="1.0" encoding="utf-8"?>
+<p:sld xmlns:a="http://schemas.openxmlformats.org/drawingml/2006/main" xmlns:r="http://schemas.openxmlformats.org/officeDocument/2006/relationships" xmlns:p="http://schemas.openxmlformats.org/presentationml/2006/main">
+  <p:cSld>
+    <p:spTree>
+      <p:nvGrpSpPr>
+        <p:cNvPr id="1" name=""/>
+        <p:cNvGrpSpPr/>
+        <p:nvPr/>
+      </p:nvGrpSpPr>
+      <p:grpSpPr>
+        <a:xfrm>
+          <a:off x="0" y="0"/>
+          <a:ext cx="0" cy="0"/>
+          <a:chOff x="0" y="0"/>
+          <a:chExt cx="0" cy="0"/>
+        </a:xfrm>
+      </p:grpSpPr>
+      <p:sp>
+        <p:nvSpPr>
+          <p:cNvPr id="2" name="제목 1">
+            <a:extLst>
+              <a:ext uri="{FF2B5EF4-FFF2-40B4-BE49-F238E27FC236}">
                 <a16:creationId xmlns:a16="http://schemas.microsoft.com/office/drawing/2014/main" id="{4518BC66-C47F-C02A-C95A-403AD85281BF}"/>
               </a:ext>
             </a:extLst>
@@ -4300,203 +4691,6 @@
 </p:sld>
 </file>
 
-<file path=ppt/slides/slide11.xml><?xml version="1.0" encoding="utf-8"?>
-<p:sld xmlns:a="http://schemas.openxmlformats.org/drawingml/2006/main" xmlns:r="http://schemas.openxmlformats.org/officeDocument/2006/relationships" xmlns:p="http://schemas.openxmlformats.org/presentationml/2006/main">
-  <p:cSld>
-    <p:spTree>
-      <p:nvGrpSpPr>
-        <p:cNvPr id="1" name=""/>
-        <p:cNvGrpSpPr/>
-        <p:nvPr/>
-      </p:nvGrpSpPr>
-      <p:grpSpPr>
-        <a:xfrm>
-          <a:off x="0" y="0"/>
-          <a:ext cx="0" cy="0"/>
-          <a:chOff x="0" y="0"/>
-          <a:chExt cx="0" cy="0"/>
-        </a:xfrm>
-      </p:grpSpPr>
-      <p:sp>
-        <p:nvSpPr>
-          <p:cNvPr id="2" name="제목 1">
-            <a:extLst>
-              <a:ext uri="{FF2B5EF4-FFF2-40B4-BE49-F238E27FC236}">
-                <a16:creationId xmlns:a16="http://schemas.microsoft.com/office/drawing/2014/main" id="{DDA31E90-21C5-8B68-16E9-D64492775604}"/>
-              </a:ext>
-            </a:extLst>
-          </p:cNvPr>
-          <p:cNvSpPr>
-            <a:spLocks noGrp="1"/>
-          </p:cNvSpPr>
-          <p:nvPr>
-            <p:ph type="title"/>
-          </p:nvPr>
-        </p:nvSpPr>
-        <p:spPr/>
-        <p:txBody>
-          <a:bodyPr/>
-          <a:lstStyle/>
-          <a:p>
-            <a:r>
-              <a:rPr lang="en-US" altLang="ko-KR" dirty="0" err="1"/>
-              <a:t>Delete_task</a:t>
-            </a:r>
-            <a:endParaRPr lang="ko-KR" altLang="en-US" dirty="0"/>
-          </a:p>
-        </p:txBody>
-      </p:sp>
-      <p:sp>
-        <p:nvSpPr>
-          <p:cNvPr id="3" name="TextBox 2">
-            <a:extLst>
-              <a:ext uri="{FF2B5EF4-FFF2-40B4-BE49-F238E27FC236}">
-                <a16:creationId xmlns:a16="http://schemas.microsoft.com/office/drawing/2014/main" id="{53858F7B-A5B7-6FE9-56B2-B947669D91FD}"/>
-              </a:ext>
-            </a:extLst>
-          </p:cNvPr>
-          <p:cNvSpPr txBox="1"/>
-          <p:nvPr/>
-        </p:nvSpPr>
-        <p:spPr>
-          <a:xfrm>
-            <a:off x="1084082" y="1847654"/>
-            <a:ext cx="10105534" cy="369332"/>
-          </a:xfrm>
-          <a:prstGeom prst="rect">
-            <a:avLst/>
-          </a:prstGeom>
-          <a:noFill/>
-        </p:spPr>
-        <p:txBody>
-          <a:bodyPr wrap="square" rtlCol="0">
-            <a:spAutoFit/>
-          </a:bodyPr>
-          <a:lstStyle/>
-          <a:p>
-            <a:r>
-              <a:rPr lang="en-US" altLang="ko-KR" dirty="0"/>
-              <a:t>Task</a:t>
-            </a:r>
-            <a:r>
-              <a:rPr lang="ko-KR" altLang="en-US" dirty="0"/>
-              <a:t>가 마음에 들지 않을 때 사용함</a:t>
-            </a:r>
-            <a:r>
-              <a:rPr lang="en-US" altLang="ko-KR" dirty="0"/>
-              <a:t>.</a:t>
-            </a:r>
-            <a:endParaRPr lang="ko-KR" altLang="en-US" dirty="0"/>
-          </a:p>
-        </p:txBody>
-      </p:sp>
-    </p:spTree>
-    <p:extLst>
-      <p:ext uri="{BB962C8B-B14F-4D97-AF65-F5344CB8AC3E}">
-        <p14:creationId xmlns:p14="http://schemas.microsoft.com/office/powerpoint/2010/main" val="4105197519"/>
-      </p:ext>
-    </p:extLst>
-  </p:cSld>
-  <p:clrMapOvr>
-    <a:masterClrMapping/>
-  </p:clrMapOvr>
-</p:sld>
-</file>
-
-<file path=ppt/slides/slide12.xml><?xml version="1.0" encoding="utf-8"?>
-<p:sld xmlns:a="http://schemas.openxmlformats.org/drawingml/2006/main" xmlns:r="http://schemas.openxmlformats.org/officeDocument/2006/relationships" xmlns:p="http://schemas.openxmlformats.org/presentationml/2006/main">
-  <p:cSld>
-    <p:spTree>
-      <p:nvGrpSpPr>
-        <p:cNvPr id="1" name=""/>
-        <p:cNvGrpSpPr/>
-        <p:nvPr/>
-      </p:nvGrpSpPr>
-      <p:grpSpPr>
-        <a:xfrm>
-          <a:off x="0" y="0"/>
-          <a:ext cx="0" cy="0"/>
-          <a:chOff x="0" y="0"/>
-          <a:chExt cx="0" cy="0"/>
-        </a:xfrm>
-      </p:grpSpPr>
-      <p:sp>
-        <p:nvSpPr>
-          <p:cNvPr id="2" name="제목 1">
-            <a:extLst>
-              <a:ext uri="{FF2B5EF4-FFF2-40B4-BE49-F238E27FC236}">
-                <a16:creationId xmlns:a16="http://schemas.microsoft.com/office/drawing/2014/main" id="{7CC38293-911E-EA5E-FF24-2AE15CB45267}"/>
-              </a:ext>
-            </a:extLst>
-          </p:cNvPr>
-          <p:cNvSpPr>
-            <a:spLocks noGrp="1"/>
-          </p:cNvSpPr>
-          <p:nvPr>
-            <p:ph type="title"/>
-          </p:nvPr>
-        </p:nvSpPr>
-        <p:spPr/>
-        <p:txBody>
-          <a:bodyPr/>
-          <a:lstStyle/>
-          <a:p>
-            <a:r>
-              <a:rPr lang="en-US" altLang="ko-KR" dirty="0" err="1"/>
-              <a:t>Update_task</a:t>
-            </a:r>
-            <a:endParaRPr lang="ko-KR" altLang="en-US" dirty="0"/>
-          </a:p>
-        </p:txBody>
-      </p:sp>
-      <p:sp>
-        <p:nvSpPr>
-          <p:cNvPr id="3" name="TextBox 2">
-            <a:extLst>
-              <a:ext uri="{FF2B5EF4-FFF2-40B4-BE49-F238E27FC236}">
-                <a16:creationId xmlns:a16="http://schemas.microsoft.com/office/drawing/2014/main" id="{DBBE976C-57AA-621C-2A96-9D59DF4375E6}"/>
-              </a:ext>
-            </a:extLst>
-          </p:cNvPr>
-          <p:cNvSpPr txBox="1"/>
-          <p:nvPr/>
-        </p:nvSpPr>
-        <p:spPr>
-          <a:xfrm>
-            <a:off x="1102936" y="1828800"/>
-            <a:ext cx="10077254" cy="369332"/>
-          </a:xfrm>
-          <a:prstGeom prst="rect">
-            <a:avLst/>
-          </a:prstGeom>
-          <a:noFill/>
-        </p:spPr>
-        <p:txBody>
-          <a:bodyPr wrap="square" rtlCol="0">
-            <a:spAutoFit/>
-          </a:bodyPr>
-          <a:lstStyle/>
-          <a:p>
-            <a:r>
-              <a:rPr lang="ko-KR" altLang="en-US" dirty="0"/>
-              <a:t>작업계획의 세부내용을 조정할 때 사용</a:t>
-            </a:r>
-          </a:p>
-        </p:txBody>
-      </p:sp>
-    </p:spTree>
-    <p:extLst>
-      <p:ext uri="{BB962C8B-B14F-4D97-AF65-F5344CB8AC3E}">
-        <p14:creationId xmlns:p14="http://schemas.microsoft.com/office/powerpoint/2010/main" val="3659205008"/>
-      </p:ext>
-    </p:extLst>
-  </p:cSld>
-  <p:clrMapOvr>
-    <a:masterClrMapping/>
-  </p:clrMapOvr>
-</p:sld>
-</file>
-
 <file path=ppt/slides/slide13.xml><?xml version="1.0" encoding="utf-8"?>
 <p:sld xmlns:a="http://schemas.openxmlformats.org/drawingml/2006/main" xmlns:r="http://schemas.openxmlformats.org/officeDocument/2006/relationships" xmlns:p="http://schemas.openxmlformats.org/presentationml/2006/main">
   <p:cSld>
@@ -4519,7 +4713,7 @@
           <p:cNvPr id="2" name="제목 1">
             <a:extLst>
               <a:ext uri="{FF2B5EF4-FFF2-40B4-BE49-F238E27FC236}">
-                <a16:creationId xmlns:a16="http://schemas.microsoft.com/office/drawing/2014/main" id="{1B9B4DEB-78B2-1327-2C16-E96638843393}"/>
+                <a16:creationId xmlns:a16="http://schemas.microsoft.com/office/drawing/2014/main" id="{DDA31E90-21C5-8B68-16E9-D64492775604}"/>
               </a:ext>
             </a:extLst>
           </p:cNvPr>
@@ -4537,7 +4731,7 @@
           <a:p>
             <a:r>
               <a:rPr lang="en-US" altLang="ko-KR" dirty="0" err="1"/>
-              <a:t>Analyze_task</a:t>
+              <a:t>Delete_task</a:t>
             </a:r>
             <a:endParaRPr lang="ko-KR" altLang="en-US" dirty="0"/>
           </a:p>
@@ -4548,7 +4742,7 @@
           <p:cNvPr id="3" name="TextBox 2">
             <a:extLst>
               <a:ext uri="{FF2B5EF4-FFF2-40B4-BE49-F238E27FC236}">
-                <a16:creationId xmlns:a16="http://schemas.microsoft.com/office/drawing/2014/main" id="{6C92F768-9667-FA2C-B612-B28035BA5ECB}"/>
+                <a16:creationId xmlns:a16="http://schemas.microsoft.com/office/drawing/2014/main" id="{53858F7B-A5B7-6FE9-56B2-B947669D91FD}"/>
               </a:ext>
             </a:extLst>
           </p:cNvPr>
@@ -4557,8 +4751,8 @@
         </p:nvSpPr>
         <p:spPr>
           <a:xfrm>
-            <a:off x="1102936" y="1828800"/>
-            <a:ext cx="10077254" cy="369332"/>
+            <a:off x="1084082" y="1847654"/>
+            <a:ext cx="10105534" cy="369332"/>
           </a:xfrm>
           <a:prstGeom prst="rect">
             <a:avLst/>
@@ -4572,24 +4766,25 @@
           <a:lstStyle/>
           <a:p>
             <a:r>
+              <a:rPr lang="en-US" altLang="ko-KR" dirty="0"/>
+              <a:t>Task</a:t>
+            </a:r>
+            <a:r>
               <a:rPr lang="ko-KR" altLang="en-US" dirty="0"/>
-              <a:t>계획을 쪼개거나 </a:t>
-            </a:r>
-            <a:r>
-              <a:rPr lang="ko-KR" altLang="en-US" dirty="0" err="1"/>
-              <a:t>실행전</a:t>
-            </a:r>
-            <a:r>
-              <a:rPr lang="ko-KR" altLang="en-US" dirty="0"/>
-              <a:t> 기술적으로 타당한지 검토하는 명령어</a:t>
-            </a:r>
+              <a:t>가 마음에 들지 않을 때 사용함</a:t>
+            </a:r>
+            <a:r>
+              <a:rPr lang="en-US" altLang="ko-KR" dirty="0"/>
+              <a:t>.</a:t>
+            </a:r>
+            <a:endParaRPr lang="ko-KR" altLang="en-US" dirty="0"/>
           </a:p>
         </p:txBody>
       </p:sp>
     </p:spTree>
     <p:extLst>
       <p:ext uri="{BB962C8B-B14F-4D97-AF65-F5344CB8AC3E}">
-        <p14:creationId xmlns:p14="http://schemas.microsoft.com/office/powerpoint/2010/main" val="4073534036"/>
+        <p14:creationId xmlns:p14="http://schemas.microsoft.com/office/powerpoint/2010/main" val="4105197519"/>
       </p:ext>
     </p:extLst>
   </p:cSld>
@@ -4621,7 +4816,7 @@
           <p:cNvPr id="2" name="제목 1">
             <a:extLst>
               <a:ext uri="{FF2B5EF4-FFF2-40B4-BE49-F238E27FC236}">
-                <a16:creationId xmlns:a16="http://schemas.microsoft.com/office/drawing/2014/main" id="{3FB53422-BB29-EC12-4E78-5867CEB5F7E2}"/>
+                <a16:creationId xmlns:a16="http://schemas.microsoft.com/office/drawing/2014/main" id="{7CC38293-911E-EA5E-FF24-2AE15CB45267}"/>
               </a:ext>
             </a:extLst>
           </p:cNvPr>
@@ -4638,8 +4833,8 @@
           <a:lstStyle/>
           <a:p>
             <a:r>
-              <a:rPr lang="en-US" altLang="ko-KR" b="1" dirty="0" err="1"/>
-              <a:t>split_tasks</a:t>
+              <a:rPr lang="en-US" altLang="ko-KR" dirty="0" err="1"/>
+              <a:t>Update_task</a:t>
             </a:r>
             <a:endParaRPr lang="ko-KR" altLang="en-US" dirty="0"/>
           </a:p>
@@ -4650,7 +4845,7 @@
           <p:cNvPr id="3" name="TextBox 2">
             <a:extLst>
               <a:ext uri="{FF2B5EF4-FFF2-40B4-BE49-F238E27FC236}">
-                <a16:creationId xmlns:a16="http://schemas.microsoft.com/office/drawing/2014/main" id="{7DF82DDD-E27A-5AE3-A330-EF6D5BCEC506}"/>
+                <a16:creationId xmlns:a16="http://schemas.microsoft.com/office/drawing/2014/main" id="{DBBE976C-57AA-621C-2A96-9D59DF4375E6}"/>
               </a:ext>
             </a:extLst>
           </p:cNvPr>
@@ -4675,15 +4870,7 @@
           <a:p>
             <a:r>
               <a:rPr lang="ko-KR" altLang="en-US" dirty="0"/>
-              <a:t>복잡한 계획을 더 작은 단위의 </a:t>
-            </a:r>
-            <a:r>
-              <a:rPr lang="en-US" altLang="ko-KR" dirty="0"/>
-              <a:t>task</a:t>
-            </a:r>
-            <a:r>
-              <a:rPr lang="ko-KR" altLang="en-US" dirty="0"/>
-              <a:t>로 쪼개는 명령어</a:t>
+              <a:t>작업계획의 세부내용을 조정할 때 사용</a:t>
             </a:r>
           </a:p>
         </p:txBody>
@@ -4691,7 +4878,7 @@
     </p:spTree>
     <p:extLst>
       <p:ext uri="{BB962C8B-B14F-4D97-AF65-F5344CB8AC3E}">
-        <p14:creationId xmlns:p14="http://schemas.microsoft.com/office/powerpoint/2010/main" val="1716866700"/>
+        <p14:creationId xmlns:p14="http://schemas.microsoft.com/office/powerpoint/2010/main" val="3659205008"/>
       </p:ext>
     </p:extLst>
   </p:cSld>
@@ -4723,7 +4910,7 @@
           <p:cNvPr id="2" name="제목 1">
             <a:extLst>
               <a:ext uri="{FF2B5EF4-FFF2-40B4-BE49-F238E27FC236}">
-                <a16:creationId xmlns:a16="http://schemas.microsoft.com/office/drawing/2014/main" id="{F8205E9A-B512-F3A3-FF0C-1777FF901961}"/>
+                <a16:creationId xmlns:a16="http://schemas.microsoft.com/office/drawing/2014/main" id="{1B9B4DEB-78B2-1327-2C16-E96638843393}"/>
               </a:ext>
             </a:extLst>
           </p:cNvPr>
@@ -4740,8 +4927,8 @@
           <a:lstStyle/>
           <a:p>
             <a:r>
-              <a:rPr lang="en-US" altLang="ko-KR" dirty="0"/>
-              <a:t>Reflect task</a:t>
+              <a:rPr lang="en-US" altLang="ko-KR" dirty="0" err="1"/>
+              <a:t>Analyze_task</a:t>
             </a:r>
             <a:endParaRPr lang="ko-KR" altLang="en-US" dirty="0"/>
           </a:p>
@@ -4752,7 +4939,7 @@
           <p:cNvPr id="3" name="TextBox 2">
             <a:extLst>
               <a:ext uri="{FF2B5EF4-FFF2-40B4-BE49-F238E27FC236}">
-                <a16:creationId xmlns:a16="http://schemas.microsoft.com/office/drawing/2014/main" id="{854AECFE-4326-81D1-B3EC-D68D9AC89F32}"/>
+                <a16:creationId xmlns:a16="http://schemas.microsoft.com/office/drawing/2014/main" id="{6C92F768-9667-FA2C-B612-B28035BA5ECB}"/>
               </a:ext>
             </a:extLst>
           </p:cNvPr>
@@ -4777,7 +4964,15 @@
           <a:p>
             <a:r>
               <a:rPr lang="ko-KR" altLang="en-US" dirty="0"/>
-              <a:t>작업을 한번 더 검토하고 개선</a:t>
+              <a:t>계획을 쪼개거나 </a:t>
+            </a:r>
+            <a:r>
+              <a:rPr lang="ko-KR" altLang="en-US" dirty="0" err="1"/>
+              <a:t>실행전</a:t>
+            </a:r>
+            <a:r>
+              <a:rPr lang="ko-KR" altLang="en-US" dirty="0"/>
+              <a:t> 기술적으로 타당한지 검토하는 명령어</a:t>
             </a:r>
           </a:p>
         </p:txBody>
@@ -4785,7 +4980,7 @@
     </p:spTree>
     <p:extLst>
       <p:ext uri="{BB962C8B-B14F-4D97-AF65-F5344CB8AC3E}">
-        <p14:creationId xmlns:p14="http://schemas.microsoft.com/office/powerpoint/2010/main" val="3582645582"/>
+        <p14:creationId xmlns:p14="http://schemas.microsoft.com/office/powerpoint/2010/main" val="4073534036"/>
       </p:ext>
     </p:extLst>
   </p:cSld>
@@ -4817,6 +5012,202 @@
           <p:cNvPr id="2" name="제목 1">
             <a:extLst>
               <a:ext uri="{FF2B5EF4-FFF2-40B4-BE49-F238E27FC236}">
+                <a16:creationId xmlns:a16="http://schemas.microsoft.com/office/drawing/2014/main" id="{3FB53422-BB29-EC12-4E78-5867CEB5F7E2}"/>
+              </a:ext>
+            </a:extLst>
+          </p:cNvPr>
+          <p:cNvSpPr>
+            <a:spLocks noGrp="1"/>
+          </p:cNvSpPr>
+          <p:nvPr>
+            <p:ph type="title"/>
+          </p:nvPr>
+        </p:nvSpPr>
+        <p:spPr/>
+        <p:txBody>
+          <a:bodyPr/>
+          <a:lstStyle/>
+          <a:p>
+            <a:r>
+              <a:rPr lang="en-US" altLang="ko-KR" b="1" dirty="0" err="1"/>
+              <a:t>split_tasks</a:t>
+            </a:r>
+            <a:endParaRPr lang="ko-KR" altLang="en-US" dirty="0"/>
+          </a:p>
+        </p:txBody>
+      </p:sp>
+      <p:sp>
+        <p:nvSpPr>
+          <p:cNvPr id="3" name="TextBox 2">
+            <a:extLst>
+              <a:ext uri="{FF2B5EF4-FFF2-40B4-BE49-F238E27FC236}">
+                <a16:creationId xmlns:a16="http://schemas.microsoft.com/office/drawing/2014/main" id="{7DF82DDD-E27A-5AE3-A330-EF6D5BCEC506}"/>
+              </a:ext>
+            </a:extLst>
+          </p:cNvPr>
+          <p:cNvSpPr txBox="1"/>
+          <p:nvPr/>
+        </p:nvSpPr>
+        <p:spPr>
+          <a:xfrm>
+            <a:off x="1102936" y="1828800"/>
+            <a:ext cx="10077254" cy="369332"/>
+          </a:xfrm>
+          <a:prstGeom prst="rect">
+            <a:avLst/>
+          </a:prstGeom>
+          <a:noFill/>
+        </p:spPr>
+        <p:txBody>
+          <a:bodyPr wrap="square" rtlCol="0">
+            <a:spAutoFit/>
+          </a:bodyPr>
+          <a:lstStyle/>
+          <a:p>
+            <a:r>
+              <a:rPr lang="ko-KR" altLang="en-US" dirty="0"/>
+              <a:t>복잡한 계획을 더 작은 단위의 </a:t>
+            </a:r>
+            <a:r>
+              <a:rPr lang="en-US" altLang="ko-KR" dirty="0"/>
+              <a:t>task</a:t>
+            </a:r>
+            <a:r>
+              <a:rPr lang="ko-KR" altLang="en-US" dirty="0"/>
+              <a:t>로 쪼개는 명령어</a:t>
+            </a:r>
+          </a:p>
+        </p:txBody>
+      </p:sp>
+    </p:spTree>
+    <p:extLst>
+      <p:ext uri="{BB962C8B-B14F-4D97-AF65-F5344CB8AC3E}">
+        <p14:creationId xmlns:p14="http://schemas.microsoft.com/office/powerpoint/2010/main" val="1716866700"/>
+      </p:ext>
+    </p:extLst>
+  </p:cSld>
+  <p:clrMapOvr>
+    <a:masterClrMapping/>
+  </p:clrMapOvr>
+</p:sld>
+</file>
+
+<file path=ppt/slides/slide17.xml><?xml version="1.0" encoding="utf-8"?>
+<p:sld xmlns:a="http://schemas.openxmlformats.org/drawingml/2006/main" xmlns:r="http://schemas.openxmlformats.org/officeDocument/2006/relationships" xmlns:p="http://schemas.openxmlformats.org/presentationml/2006/main">
+  <p:cSld>
+    <p:spTree>
+      <p:nvGrpSpPr>
+        <p:cNvPr id="1" name=""/>
+        <p:cNvGrpSpPr/>
+        <p:nvPr/>
+      </p:nvGrpSpPr>
+      <p:grpSpPr>
+        <a:xfrm>
+          <a:off x="0" y="0"/>
+          <a:ext cx="0" cy="0"/>
+          <a:chOff x="0" y="0"/>
+          <a:chExt cx="0" cy="0"/>
+        </a:xfrm>
+      </p:grpSpPr>
+      <p:sp>
+        <p:nvSpPr>
+          <p:cNvPr id="2" name="제목 1">
+            <a:extLst>
+              <a:ext uri="{FF2B5EF4-FFF2-40B4-BE49-F238E27FC236}">
+                <a16:creationId xmlns:a16="http://schemas.microsoft.com/office/drawing/2014/main" id="{F8205E9A-B512-F3A3-FF0C-1777FF901961}"/>
+              </a:ext>
+            </a:extLst>
+          </p:cNvPr>
+          <p:cNvSpPr>
+            <a:spLocks noGrp="1"/>
+          </p:cNvSpPr>
+          <p:nvPr>
+            <p:ph type="title"/>
+          </p:nvPr>
+        </p:nvSpPr>
+        <p:spPr/>
+        <p:txBody>
+          <a:bodyPr/>
+          <a:lstStyle/>
+          <a:p>
+            <a:r>
+              <a:rPr lang="en-US" altLang="ko-KR" dirty="0"/>
+              <a:t>Reflect task</a:t>
+            </a:r>
+            <a:endParaRPr lang="ko-KR" altLang="en-US" dirty="0"/>
+          </a:p>
+        </p:txBody>
+      </p:sp>
+      <p:sp>
+        <p:nvSpPr>
+          <p:cNvPr id="3" name="TextBox 2">
+            <a:extLst>
+              <a:ext uri="{FF2B5EF4-FFF2-40B4-BE49-F238E27FC236}">
+                <a16:creationId xmlns:a16="http://schemas.microsoft.com/office/drawing/2014/main" id="{854AECFE-4326-81D1-B3EC-D68D9AC89F32}"/>
+              </a:ext>
+            </a:extLst>
+          </p:cNvPr>
+          <p:cNvSpPr txBox="1"/>
+          <p:nvPr/>
+        </p:nvSpPr>
+        <p:spPr>
+          <a:xfrm>
+            <a:off x="1102936" y="1828800"/>
+            <a:ext cx="10077254" cy="369332"/>
+          </a:xfrm>
+          <a:prstGeom prst="rect">
+            <a:avLst/>
+          </a:prstGeom>
+          <a:noFill/>
+        </p:spPr>
+        <p:txBody>
+          <a:bodyPr wrap="square" rtlCol="0">
+            <a:spAutoFit/>
+          </a:bodyPr>
+          <a:lstStyle/>
+          <a:p>
+            <a:r>
+              <a:rPr lang="ko-KR" altLang="en-US" dirty="0"/>
+              <a:t>작업을 한번 더 검토하고 개선</a:t>
+            </a:r>
+          </a:p>
+        </p:txBody>
+      </p:sp>
+    </p:spTree>
+    <p:extLst>
+      <p:ext uri="{BB962C8B-B14F-4D97-AF65-F5344CB8AC3E}">
+        <p14:creationId xmlns:p14="http://schemas.microsoft.com/office/powerpoint/2010/main" val="3582645582"/>
+      </p:ext>
+    </p:extLst>
+  </p:cSld>
+  <p:clrMapOvr>
+    <a:masterClrMapping/>
+  </p:clrMapOvr>
+</p:sld>
+</file>
+
+<file path=ppt/slides/slide18.xml><?xml version="1.0" encoding="utf-8"?>
+<p:sld xmlns:a="http://schemas.openxmlformats.org/drawingml/2006/main" xmlns:r="http://schemas.openxmlformats.org/officeDocument/2006/relationships" xmlns:p="http://schemas.openxmlformats.org/presentationml/2006/main">
+  <p:cSld>
+    <p:spTree>
+      <p:nvGrpSpPr>
+        <p:cNvPr id="1" name=""/>
+        <p:cNvGrpSpPr/>
+        <p:nvPr/>
+      </p:nvGrpSpPr>
+      <p:grpSpPr>
+        <a:xfrm>
+          <a:off x="0" y="0"/>
+          <a:ext cx="0" cy="0"/>
+          <a:chOff x="0" y="0"/>
+          <a:chExt cx="0" cy="0"/>
+        </a:xfrm>
+      </p:grpSpPr>
+      <p:sp>
+        <p:nvSpPr>
+          <p:cNvPr id="2" name="제목 1">
+            <a:extLst>
+              <a:ext uri="{FF2B5EF4-FFF2-40B4-BE49-F238E27FC236}">
                 <a16:creationId xmlns:a16="http://schemas.microsoft.com/office/drawing/2014/main" id="{7F66CF5A-F335-6FEB-61AC-A1B475503E79}"/>
               </a:ext>
             </a:extLst>
@@ -4854,7 +5245,7 @@
 </p:sld>
 </file>
 
-<file path=ppt/slides/slide17.xml><?xml version="1.0" encoding="utf-8"?>
+<file path=ppt/slides/slide19.xml><?xml version="1.0" encoding="utf-8"?>
 <p:sld xmlns:a="http://schemas.openxmlformats.org/drawingml/2006/main" xmlns:r="http://schemas.openxmlformats.org/officeDocument/2006/relationships" xmlns:p="http://schemas.openxmlformats.org/presentationml/2006/main">
   <p:cSld>
     <p:spTree>
@@ -6345,6 +6736,1216 @@
   <p:cSld>
     <p:spTree>
       <p:nvGrpSpPr>
+        <p:cNvPr id="1" name="">
+          <a:extLst>
+            <a:ext uri="{FF2B5EF4-FFF2-40B4-BE49-F238E27FC236}">
+              <a16:creationId xmlns:a16="http://schemas.microsoft.com/office/drawing/2014/main" id="{349485CC-2913-1AC3-7AAF-FB5A01E8AA56}"/>
+            </a:ext>
+          </a:extLst>
+        </p:cNvPr>
+        <p:cNvGrpSpPr/>
+        <p:nvPr/>
+      </p:nvGrpSpPr>
+      <p:grpSpPr>
+        <a:xfrm>
+          <a:off x="0" y="0"/>
+          <a:ext cx="0" cy="0"/>
+          <a:chOff x="0" y="0"/>
+          <a:chExt cx="0" cy="0"/>
+        </a:xfrm>
+      </p:grpSpPr>
+      <p:sp>
+        <p:nvSpPr>
+          <p:cNvPr id="2" name="제목 1">
+            <a:extLst>
+              <a:ext uri="{FF2B5EF4-FFF2-40B4-BE49-F238E27FC236}">
+                <a16:creationId xmlns:a16="http://schemas.microsoft.com/office/drawing/2014/main" id="{2BC7190A-EDB0-07F1-77E4-71A47786CE35}"/>
+              </a:ext>
+            </a:extLst>
+          </p:cNvPr>
+          <p:cNvSpPr>
+            <a:spLocks noGrp="1"/>
+          </p:cNvSpPr>
+          <p:nvPr>
+            <p:ph type="title"/>
+          </p:nvPr>
+        </p:nvSpPr>
+        <p:spPr/>
+        <p:txBody>
+          <a:bodyPr/>
+          <a:lstStyle/>
+          <a:p>
+            <a:r>
+              <a:rPr lang="en-US" altLang="ko-KR" dirty="0"/>
+              <a:t>Shrimp Task </a:t>
+            </a:r>
+            <a:r>
+              <a:rPr lang="en-US" altLang="ko-KR" dirty="0" err="1"/>
+              <a:t>Mananger</a:t>
+            </a:r>
+            <a:r>
+              <a:rPr lang="en-US" altLang="ko-KR" dirty="0"/>
+              <a:t> </a:t>
+            </a:r>
+            <a:r>
+              <a:rPr lang="ko-KR" altLang="en-US"/>
+              <a:t>설치</a:t>
+            </a:r>
+            <a:r>
+              <a:rPr lang="en-US" altLang="ko-KR"/>
+              <a:t>-3</a:t>
+            </a:r>
+            <a:endParaRPr lang="ko-KR" altLang="en-US" dirty="0"/>
+          </a:p>
+        </p:txBody>
+      </p:sp>
+      <p:sp>
+        <p:nvSpPr>
+          <p:cNvPr id="5" name="TextBox 4">
+            <a:extLst>
+              <a:ext uri="{FF2B5EF4-FFF2-40B4-BE49-F238E27FC236}">
+                <a16:creationId xmlns:a16="http://schemas.microsoft.com/office/drawing/2014/main" id="{12E5DB95-62B0-9371-7EFA-E4040C598213}"/>
+              </a:ext>
+            </a:extLst>
+          </p:cNvPr>
+          <p:cNvSpPr txBox="1"/>
+          <p:nvPr/>
+        </p:nvSpPr>
+        <p:spPr>
+          <a:xfrm>
+            <a:off x="1097280" y="1816718"/>
+            <a:ext cx="7567366" cy="461665"/>
+          </a:xfrm>
+          <a:prstGeom prst="rect">
+            <a:avLst/>
+          </a:prstGeom>
+          <a:noFill/>
+        </p:spPr>
+        <p:txBody>
+          <a:bodyPr wrap="square">
+            <a:spAutoFit/>
+          </a:bodyPr>
+          <a:lstStyle/>
+          <a:p>
+            <a:r>
+              <a:rPr lang="ko-KR" altLang="en-US" sz="1200" dirty="0"/>
+              <a:t>참고 주소 </a:t>
+            </a:r>
+            <a:r>
+              <a:rPr lang="en-US" altLang="ko-KR" sz="1200" dirty="0"/>
+              <a:t>: </a:t>
+            </a:r>
+            <a:r>
+              <a:rPr lang="en-US" altLang="ko-KR" sz="1200" dirty="0">
+                <a:hlinkClick r:id="rId2"/>
+              </a:rPr>
+              <a:t>https://github.com/cjo4m06/mcp-shrimp-task-manager/tree/main#installation</a:t>
+            </a:r>
+            <a:r>
+              <a:rPr lang="en-US" altLang="ko-KR" sz="1200" dirty="0"/>
+              <a:t> </a:t>
+            </a:r>
+          </a:p>
+          <a:p>
+            <a:endParaRPr lang="ko-KR" altLang="en-US" sz="1200" dirty="0"/>
+          </a:p>
+        </p:txBody>
+      </p:sp>
+      <p:sp>
+        <p:nvSpPr>
+          <p:cNvPr id="4" name="TextBox 3">
+            <a:extLst>
+              <a:ext uri="{FF2B5EF4-FFF2-40B4-BE49-F238E27FC236}">
+                <a16:creationId xmlns:a16="http://schemas.microsoft.com/office/drawing/2014/main" id="{9AB43132-93FA-5BA6-9692-5E8B38D82714}"/>
+              </a:ext>
+            </a:extLst>
+          </p:cNvPr>
+          <p:cNvSpPr txBox="1"/>
+          <p:nvPr/>
+        </p:nvSpPr>
+        <p:spPr>
+          <a:xfrm>
+            <a:off x="690513" y="2202969"/>
+            <a:ext cx="8085841" cy="1107996"/>
+          </a:xfrm>
+          <a:prstGeom prst="rect">
+            <a:avLst/>
+          </a:prstGeom>
+          <a:noFill/>
+        </p:spPr>
+        <p:txBody>
+          <a:bodyPr wrap="square">
+            <a:spAutoFit/>
+          </a:bodyPr>
+          <a:lstStyle/>
+          <a:p>
+            <a:pPr marL="228600" indent="-228600">
+              <a:buAutoNum type="arabicPeriod"/>
+            </a:pPr>
+            <a:r>
+              <a:rPr lang="en-US" altLang="ko-KR" sz="1100">
+                <a:sym typeface="Wingdings" panose="05000000000000000000" pitchFamily="2" charset="2"/>
+              </a:rPr>
+              <a:t>D:\Study\ClaudeAI\workspace\invoice-web&gt; git clone </a:t>
+            </a:r>
+            <a:r>
+              <a:rPr lang="en-US" altLang="ko-KR" sz="1100">
+                <a:sym typeface="Wingdings" panose="05000000000000000000" pitchFamily="2" charset="2"/>
+                <a:hlinkClick r:id="rId3"/>
+              </a:rPr>
+              <a:t>https://github.com/cjo4m06/mcp-shrimp-task-manager.git</a:t>
+            </a:r>
+            <a:endParaRPr lang="en-US" altLang="ko-KR" sz="1100">
+              <a:sym typeface="Wingdings" panose="05000000000000000000" pitchFamily="2" charset="2"/>
+            </a:endParaRPr>
+          </a:p>
+          <a:p>
+            <a:pPr marL="228600" indent="-228600">
+              <a:buFontTx/>
+              <a:buAutoNum type="arabicPeriod"/>
+            </a:pPr>
+            <a:r>
+              <a:rPr lang="en-US" altLang="ko-KR" sz="1100"/>
+              <a:t>cd mcp-shrimp-task-manager</a:t>
+            </a:r>
+          </a:p>
+          <a:p>
+            <a:pPr marL="228600" indent="-228600">
+              <a:buFontTx/>
+              <a:buAutoNum type="arabicPeriod"/>
+            </a:pPr>
+            <a:r>
+              <a:rPr lang="en-US" altLang="ko-KR" sz="1100"/>
+              <a:t>npm i </a:t>
+            </a:r>
+          </a:p>
+          <a:p>
+            <a:pPr marL="228600" indent="-228600">
+              <a:buFontTx/>
+              <a:buAutoNum type="arabicPeriod"/>
+            </a:pPr>
+            <a:r>
+              <a:rPr lang="en-US" altLang="ko-KR" sz="1100"/>
+              <a:t>npm run build</a:t>
+            </a:r>
+            <a:br>
+              <a:rPr lang="en-US" altLang="ko-KR" sz="1100"/>
+            </a:br>
+            <a:endParaRPr lang="en-US" altLang="ko-KR" sz="1100"/>
+          </a:p>
+          <a:p>
+            <a:pPr marL="228600" indent="-228600">
+              <a:buAutoNum type="arabicPeriod"/>
+            </a:pPr>
+            <a:endParaRPr lang="ko-KR" altLang="en-US" sz="1100" dirty="0"/>
+          </a:p>
+        </p:txBody>
+      </p:sp>
+      <p:pic>
+        <p:nvPicPr>
+          <p:cNvPr id="9" name="그림 8">
+            <a:extLst>
+              <a:ext uri="{FF2B5EF4-FFF2-40B4-BE49-F238E27FC236}">
+                <a16:creationId xmlns:a16="http://schemas.microsoft.com/office/drawing/2014/main" id="{E93FDAD0-6706-3B3C-B6DA-C75F3FF86841}"/>
+              </a:ext>
+            </a:extLst>
+          </p:cNvPr>
+          <p:cNvPicPr>
+            <a:picLocks noChangeAspect="1"/>
+          </p:cNvPicPr>
+          <p:nvPr/>
+        </p:nvPicPr>
+        <p:blipFill>
+          <a:blip r:embed="rId4"/>
+          <a:stretch>
+            <a:fillRect/>
+          </a:stretch>
+        </p:blipFill>
+        <p:spPr>
+          <a:xfrm>
+            <a:off x="690513" y="3131616"/>
+            <a:ext cx="4277413" cy="1946607"/>
+          </a:xfrm>
+          <a:prstGeom prst="rect">
+            <a:avLst/>
+          </a:prstGeom>
+        </p:spPr>
+      </p:pic>
+      <p:sp>
+        <p:nvSpPr>
+          <p:cNvPr id="10" name="TextBox 9">
+            <a:extLst>
+              <a:ext uri="{FF2B5EF4-FFF2-40B4-BE49-F238E27FC236}">
+                <a16:creationId xmlns:a16="http://schemas.microsoft.com/office/drawing/2014/main" id="{8D9478C3-D8E7-547D-87A9-E53D7BCCFF47}"/>
+              </a:ext>
+            </a:extLst>
+          </p:cNvPr>
+          <p:cNvSpPr txBox="1"/>
+          <p:nvPr/>
+        </p:nvSpPr>
+        <p:spPr>
+          <a:xfrm>
+            <a:off x="690513" y="6061435"/>
+            <a:ext cx="6370163" cy="276999"/>
+          </a:xfrm>
+          <a:prstGeom prst="rect">
+            <a:avLst/>
+          </a:prstGeom>
+          <a:noFill/>
+        </p:spPr>
+        <p:txBody>
+          <a:bodyPr wrap="square" rtlCol="0">
+            <a:spAutoFit/>
+          </a:bodyPr>
+          <a:lstStyle/>
+          <a:p>
+            <a:r>
+              <a:rPr lang="en-US" altLang="ko-KR" sz="1200"/>
+              <a:t>(up to date ...) </a:t>
+            </a:r>
+            <a:r>
+              <a:rPr lang="en-US" altLang="ko-KR" sz="1200">
+                <a:sym typeface="Wingdings" panose="05000000000000000000" pitchFamily="2" charset="2"/>
+              </a:rPr>
+              <a:t> </a:t>
+            </a:r>
+            <a:r>
+              <a:rPr lang="ko-KR" altLang="en-US" sz="1200"/>
+              <a:t>이미 의존성이 다 업데이트 되어있다고 뜬다</a:t>
+            </a:r>
+            <a:r>
+              <a:rPr lang="en-US" altLang="ko-KR" sz="1200"/>
+              <a:t>.</a:t>
+            </a:r>
+            <a:endParaRPr lang="ko-KR" altLang="en-US" sz="1200"/>
+          </a:p>
+        </p:txBody>
+      </p:sp>
+      <p:pic>
+        <p:nvPicPr>
+          <p:cNvPr id="12" name="그림 11">
+            <a:extLst>
+              <a:ext uri="{FF2B5EF4-FFF2-40B4-BE49-F238E27FC236}">
+                <a16:creationId xmlns:a16="http://schemas.microsoft.com/office/drawing/2014/main" id="{6D04D087-5BE2-4127-D97D-4A4372DD035D}"/>
+              </a:ext>
+            </a:extLst>
+          </p:cNvPr>
+          <p:cNvPicPr>
+            <a:picLocks noChangeAspect="1"/>
+          </p:cNvPicPr>
+          <p:nvPr/>
+        </p:nvPicPr>
+        <p:blipFill>
+          <a:blip r:embed="rId5"/>
+          <a:stretch>
+            <a:fillRect/>
+          </a:stretch>
+        </p:blipFill>
+        <p:spPr>
+          <a:xfrm>
+            <a:off x="690513" y="5120641"/>
+            <a:ext cx="7020613" cy="916051"/>
+          </a:xfrm>
+          <a:prstGeom prst="rect">
+            <a:avLst/>
+          </a:prstGeom>
+        </p:spPr>
+      </p:pic>
+      <p:sp>
+        <p:nvSpPr>
+          <p:cNvPr id="13" name="직사각형 12">
+            <a:extLst>
+              <a:ext uri="{FF2B5EF4-FFF2-40B4-BE49-F238E27FC236}">
+                <a16:creationId xmlns:a16="http://schemas.microsoft.com/office/drawing/2014/main" id="{7D98A3B9-B5B2-A8B9-420E-AF80869B7D0A}"/>
+              </a:ext>
+            </a:extLst>
+          </p:cNvPr>
+          <p:cNvSpPr/>
+          <p:nvPr/>
+        </p:nvSpPr>
+        <p:spPr>
+          <a:xfrm>
+            <a:off x="4260915" y="3429000"/>
+            <a:ext cx="358219" cy="347574"/>
+          </a:xfrm>
+          <a:prstGeom prst="rect">
+            <a:avLst/>
+          </a:prstGeom>
+        </p:spPr>
+        <p:style>
+          <a:lnRef idx="2">
+            <a:schemeClr val="accent1">
+              <a:shade val="15000"/>
+            </a:schemeClr>
+          </a:lnRef>
+          <a:fillRef idx="1">
+            <a:schemeClr val="accent1"/>
+          </a:fillRef>
+          <a:effectRef idx="0">
+            <a:schemeClr val="accent1"/>
+          </a:effectRef>
+          <a:fontRef idx="minor">
+            <a:schemeClr val="lt1"/>
+          </a:fontRef>
+        </p:style>
+        <p:txBody>
+          <a:bodyPr rtlCol="0" anchor="ctr"/>
+          <a:lstStyle/>
+          <a:p>
+            <a:pPr algn="ctr"/>
+            <a:r>
+              <a:rPr lang="en-US" altLang="ko-KR"/>
+              <a:t>3</a:t>
+            </a:r>
+            <a:endParaRPr lang="ko-KR" altLang="en-US"/>
+          </a:p>
+        </p:txBody>
+      </p:sp>
+      <p:sp>
+        <p:nvSpPr>
+          <p:cNvPr id="14" name="직사각형 13">
+            <a:extLst>
+              <a:ext uri="{FF2B5EF4-FFF2-40B4-BE49-F238E27FC236}">
+                <a16:creationId xmlns:a16="http://schemas.microsoft.com/office/drawing/2014/main" id="{D8F7CD5C-9EF6-9A2A-E1F0-C05C158A5242}"/>
+              </a:ext>
+            </a:extLst>
+          </p:cNvPr>
+          <p:cNvSpPr/>
+          <p:nvPr/>
+        </p:nvSpPr>
+        <p:spPr>
+          <a:xfrm>
+            <a:off x="6702457" y="5159882"/>
+            <a:ext cx="358219" cy="347574"/>
+          </a:xfrm>
+          <a:prstGeom prst="rect">
+            <a:avLst/>
+          </a:prstGeom>
+        </p:spPr>
+        <p:style>
+          <a:lnRef idx="2">
+            <a:schemeClr val="accent1">
+              <a:shade val="15000"/>
+            </a:schemeClr>
+          </a:lnRef>
+          <a:fillRef idx="1">
+            <a:schemeClr val="accent1"/>
+          </a:fillRef>
+          <a:effectRef idx="0">
+            <a:schemeClr val="accent1"/>
+          </a:effectRef>
+          <a:fontRef idx="minor">
+            <a:schemeClr val="lt1"/>
+          </a:fontRef>
+        </p:style>
+        <p:txBody>
+          <a:bodyPr rtlCol="0" anchor="ctr"/>
+          <a:lstStyle/>
+          <a:p>
+            <a:pPr algn="ctr"/>
+            <a:r>
+              <a:rPr lang="en-US" altLang="ko-KR"/>
+              <a:t>4</a:t>
+            </a:r>
+            <a:endParaRPr lang="ko-KR" altLang="en-US"/>
+          </a:p>
+        </p:txBody>
+      </p:sp>
+    </p:spTree>
+    <p:extLst>
+      <p:ext uri="{BB962C8B-B14F-4D97-AF65-F5344CB8AC3E}">
+        <p14:creationId xmlns:p14="http://schemas.microsoft.com/office/powerpoint/2010/main" val="3915772664"/>
+      </p:ext>
+    </p:extLst>
+  </p:cSld>
+  <p:clrMapOvr>
+    <a:masterClrMapping/>
+  </p:clrMapOvr>
+</p:sld>
+</file>
+
+<file path=ppt/slides/slide6.xml><?xml version="1.0" encoding="utf-8"?>
+<p:sld xmlns:a="http://schemas.openxmlformats.org/drawingml/2006/main" xmlns:r="http://schemas.openxmlformats.org/officeDocument/2006/relationships" xmlns:p="http://schemas.openxmlformats.org/presentationml/2006/main">
+  <p:cSld>
+    <p:spTree>
+      <p:nvGrpSpPr>
+        <p:cNvPr id="1" name="">
+          <a:extLst>
+            <a:ext uri="{FF2B5EF4-FFF2-40B4-BE49-F238E27FC236}">
+              <a16:creationId xmlns:a16="http://schemas.microsoft.com/office/drawing/2014/main" id="{225D032D-B381-F6C1-10CB-A45961BDCD17}"/>
+            </a:ext>
+          </a:extLst>
+        </p:cNvPr>
+        <p:cNvGrpSpPr/>
+        <p:nvPr/>
+      </p:nvGrpSpPr>
+      <p:grpSpPr>
+        <a:xfrm>
+          <a:off x="0" y="0"/>
+          <a:ext cx="0" cy="0"/>
+          <a:chOff x="0" y="0"/>
+          <a:chExt cx="0" cy="0"/>
+        </a:xfrm>
+      </p:grpSpPr>
+      <p:sp>
+        <p:nvSpPr>
+          <p:cNvPr id="2" name="제목 1">
+            <a:extLst>
+              <a:ext uri="{FF2B5EF4-FFF2-40B4-BE49-F238E27FC236}">
+                <a16:creationId xmlns:a16="http://schemas.microsoft.com/office/drawing/2014/main" id="{9CA629FA-9F48-C4A6-7AE4-FF73FF7FA3BC}"/>
+              </a:ext>
+            </a:extLst>
+          </p:cNvPr>
+          <p:cNvSpPr>
+            <a:spLocks noGrp="1"/>
+          </p:cNvSpPr>
+          <p:nvPr>
+            <p:ph type="title"/>
+          </p:nvPr>
+        </p:nvSpPr>
+        <p:spPr/>
+        <p:txBody>
+          <a:bodyPr/>
+          <a:lstStyle/>
+          <a:p>
+            <a:r>
+              <a:rPr lang="en-US" altLang="ko-KR" dirty="0"/>
+              <a:t>Shrimp Task </a:t>
+            </a:r>
+            <a:r>
+              <a:rPr lang="en-US" altLang="ko-KR" dirty="0" err="1"/>
+              <a:t>Mananger</a:t>
+            </a:r>
+            <a:r>
+              <a:rPr lang="en-US" altLang="ko-KR" dirty="0"/>
+              <a:t> </a:t>
+            </a:r>
+            <a:r>
+              <a:rPr lang="ko-KR" altLang="en-US"/>
+              <a:t>설치</a:t>
+            </a:r>
+            <a:r>
+              <a:rPr lang="en-US" altLang="ko-KR"/>
+              <a:t>-4</a:t>
+            </a:r>
+            <a:endParaRPr lang="ko-KR" altLang="en-US" dirty="0"/>
+          </a:p>
+        </p:txBody>
+      </p:sp>
+      <p:sp>
+        <p:nvSpPr>
+          <p:cNvPr id="6" name="TextBox 5">
+            <a:extLst>
+              <a:ext uri="{FF2B5EF4-FFF2-40B4-BE49-F238E27FC236}">
+                <a16:creationId xmlns:a16="http://schemas.microsoft.com/office/drawing/2014/main" id="{0445EF4D-C6DA-3A70-6A52-7C40A4F9E360}"/>
+              </a:ext>
+            </a:extLst>
+          </p:cNvPr>
+          <p:cNvSpPr txBox="1"/>
+          <p:nvPr/>
+        </p:nvSpPr>
+        <p:spPr>
+          <a:xfrm>
+            <a:off x="690515" y="3999432"/>
+            <a:ext cx="5512322" cy="1938992"/>
+          </a:xfrm>
+          <a:prstGeom prst="rect">
+            <a:avLst/>
+          </a:prstGeom>
+          <a:noFill/>
+        </p:spPr>
+        <p:txBody>
+          <a:bodyPr wrap="square">
+            <a:spAutoFit/>
+          </a:bodyPr>
+          <a:lstStyle/>
+          <a:p>
+            <a:pPr>
+              <a:buNone/>
+            </a:pPr>
+            <a:r>
+              <a:rPr lang="en-US" altLang="ko-KR" sz="1200">
+                <a:solidFill>
+                  <a:srgbClr val="C77DBB"/>
+                </a:solidFill>
+                <a:effectLst/>
+                <a:latin typeface="JetBrains Mono"/>
+              </a:rPr>
+              <a:t>"shrimp-task-manager"</a:t>
+            </a:r>
+            <a:r>
+              <a:rPr lang="en-US" altLang="ko-KR" sz="1200">
+                <a:solidFill>
+                  <a:srgbClr val="BCBEC4"/>
+                </a:solidFill>
+                <a:effectLst/>
+                <a:latin typeface="JetBrains Mono"/>
+              </a:rPr>
+              <a:t>: {</a:t>
+            </a:r>
+            <a:br>
+              <a:rPr lang="en-US" altLang="ko-KR" sz="1200">
+                <a:solidFill>
+                  <a:srgbClr val="BCBEC4"/>
+                </a:solidFill>
+                <a:effectLst/>
+                <a:latin typeface="JetBrains Mono"/>
+              </a:rPr>
+            </a:br>
+            <a:r>
+              <a:rPr lang="en-US" altLang="ko-KR" sz="1200">
+                <a:solidFill>
+                  <a:srgbClr val="BCBEC4"/>
+                </a:solidFill>
+                <a:effectLst/>
+                <a:latin typeface="JetBrains Mono"/>
+              </a:rPr>
+              <a:t>   </a:t>
+            </a:r>
+            <a:r>
+              <a:rPr lang="en-US" altLang="ko-KR" sz="1200">
+                <a:solidFill>
+                  <a:srgbClr val="C77DBB"/>
+                </a:solidFill>
+                <a:effectLst/>
+                <a:latin typeface="JetBrains Mono"/>
+              </a:rPr>
+              <a:t>"command"</a:t>
+            </a:r>
+            <a:r>
+              <a:rPr lang="en-US" altLang="ko-KR" sz="1200">
+                <a:solidFill>
+                  <a:srgbClr val="BCBEC4"/>
+                </a:solidFill>
+                <a:effectLst/>
+                <a:latin typeface="JetBrains Mono"/>
+              </a:rPr>
+              <a:t>: </a:t>
+            </a:r>
+            <a:r>
+              <a:rPr lang="en-US" altLang="ko-KR" sz="1200">
+                <a:solidFill>
+                  <a:srgbClr val="6AAB73"/>
+                </a:solidFill>
+                <a:effectLst/>
+                <a:latin typeface="JetBrains Mono"/>
+              </a:rPr>
+              <a:t>"node"</a:t>
+            </a:r>
+            <a:r>
+              <a:rPr lang="en-US" altLang="ko-KR" sz="1200">
+                <a:solidFill>
+                  <a:srgbClr val="BCBEC4"/>
+                </a:solidFill>
+                <a:effectLst/>
+                <a:latin typeface="JetBrains Mono"/>
+              </a:rPr>
+              <a:t>,</a:t>
+            </a:r>
+            <a:br>
+              <a:rPr lang="en-US" altLang="ko-KR" sz="1200">
+                <a:solidFill>
+                  <a:srgbClr val="BCBEC4"/>
+                </a:solidFill>
+                <a:effectLst/>
+                <a:latin typeface="JetBrains Mono"/>
+              </a:rPr>
+            </a:br>
+            <a:r>
+              <a:rPr lang="en-US" altLang="ko-KR" sz="1200">
+                <a:solidFill>
+                  <a:srgbClr val="BCBEC4"/>
+                </a:solidFill>
+                <a:effectLst/>
+                <a:latin typeface="JetBrains Mono"/>
+              </a:rPr>
+              <a:t>   </a:t>
+            </a:r>
+            <a:r>
+              <a:rPr lang="en-US" altLang="ko-KR" sz="1200">
+                <a:solidFill>
+                  <a:srgbClr val="C77DBB"/>
+                </a:solidFill>
+                <a:effectLst/>
+                <a:latin typeface="JetBrains Mono"/>
+              </a:rPr>
+              <a:t>"args"</a:t>
+            </a:r>
+            <a:r>
+              <a:rPr lang="en-US" altLang="ko-KR" sz="1200">
+                <a:solidFill>
+                  <a:srgbClr val="BCBEC4"/>
+                </a:solidFill>
+                <a:effectLst/>
+                <a:latin typeface="JetBrains Mono"/>
+              </a:rPr>
+              <a:t>: [</a:t>
+            </a:r>
+            <a:r>
+              <a:rPr lang="en-US" altLang="ko-KR" sz="1200">
+                <a:solidFill>
+                  <a:srgbClr val="6AAB73"/>
+                </a:solidFill>
+                <a:effectLst/>
+                <a:latin typeface="JetBrains Mono"/>
+              </a:rPr>
+              <a:t>"D:</a:t>
+            </a:r>
+            <a:r>
+              <a:rPr lang="en-US" altLang="ko-KR" sz="1200">
+                <a:solidFill>
+                  <a:srgbClr val="CF8E6D"/>
+                </a:solidFill>
+                <a:effectLst/>
+                <a:latin typeface="JetBrains Mono"/>
+              </a:rPr>
+              <a:t>\\</a:t>
+            </a:r>
+            <a:r>
+              <a:rPr lang="en-US" altLang="ko-KR" sz="1200">
+                <a:solidFill>
+                  <a:srgbClr val="6AAB73"/>
+                </a:solidFill>
+                <a:effectLst/>
+                <a:latin typeface="JetBrains Mono"/>
+              </a:rPr>
+              <a:t>Study</a:t>
+            </a:r>
+            <a:r>
+              <a:rPr lang="en-US" altLang="ko-KR" sz="1200">
+                <a:solidFill>
+                  <a:srgbClr val="CF8E6D"/>
+                </a:solidFill>
+                <a:effectLst/>
+                <a:latin typeface="JetBrains Mono"/>
+              </a:rPr>
+              <a:t>\\</a:t>
+            </a:r>
+            <a:r>
+              <a:rPr lang="en-US" altLang="ko-KR" sz="1200">
+                <a:solidFill>
+                  <a:srgbClr val="6AAB73"/>
+                </a:solidFill>
+                <a:effectLst/>
+                <a:latin typeface="JetBrains Mono"/>
+              </a:rPr>
+              <a:t>ClaudeAI</a:t>
+            </a:r>
+            <a:r>
+              <a:rPr lang="en-US" altLang="ko-KR" sz="1200">
+                <a:solidFill>
+                  <a:srgbClr val="CF8E6D"/>
+                </a:solidFill>
+                <a:effectLst/>
+                <a:latin typeface="JetBrains Mono"/>
+              </a:rPr>
+              <a:t>\\</a:t>
+            </a:r>
+            <a:r>
+              <a:rPr lang="en-US" altLang="ko-KR" sz="1200">
+                <a:solidFill>
+                  <a:srgbClr val="6AAB73"/>
+                </a:solidFill>
+                <a:effectLst/>
+                <a:latin typeface="JetBrains Mono"/>
+              </a:rPr>
+              <a:t>workspace</a:t>
+            </a:r>
+            <a:r>
+              <a:rPr lang="en-US" altLang="ko-KR" sz="1200">
+                <a:solidFill>
+                  <a:srgbClr val="CF8E6D"/>
+                </a:solidFill>
+                <a:effectLst/>
+                <a:latin typeface="JetBrains Mono"/>
+              </a:rPr>
+              <a:t>\\</a:t>
+            </a:r>
+            <a:r>
+              <a:rPr lang="en-US" altLang="ko-KR" sz="1200">
+                <a:solidFill>
+                  <a:srgbClr val="6AAB73"/>
+                </a:solidFill>
+                <a:effectLst/>
+                <a:latin typeface="JetBrains Mono"/>
+              </a:rPr>
+              <a:t>invoice-web</a:t>
+            </a:r>
+            <a:r>
+              <a:rPr lang="en-US" altLang="ko-KR" sz="1200">
+                <a:solidFill>
+                  <a:srgbClr val="CF8E6D"/>
+                </a:solidFill>
+                <a:effectLst/>
+                <a:latin typeface="JetBrains Mono"/>
+              </a:rPr>
+              <a:t>\\</a:t>
+            </a:r>
+            <a:r>
+              <a:rPr lang="en-US" altLang="ko-KR" sz="1200">
+                <a:solidFill>
+                  <a:srgbClr val="6AAB73"/>
+                </a:solidFill>
+                <a:effectLst/>
+                <a:latin typeface="JetBrains Mono"/>
+              </a:rPr>
+              <a:t>mcp-shrimp-task-manager</a:t>
+            </a:r>
+            <a:r>
+              <a:rPr lang="en-US" altLang="ko-KR" sz="1200">
+                <a:solidFill>
+                  <a:srgbClr val="CF8E6D"/>
+                </a:solidFill>
+                <a:effectLst/>
+                <a:latin typeface="JetBrains Mono"/>
+              </a:rPr>
+              <a:t>\\</a:t>
+            </a:r>
+            <a:r>
+              <a:rPr lang="en-US" altLang="ko-KR" sz="1200">
+                <a:solidFill>
+                  <a:srgbClr val="6AAB73"/>
+                </a:solidFill>
+                <a:effectLst/>
+                <a:latin typeface="JetBrains Mono"/>
+              </a:rPr>
+              <a:t>dist</a:t>
+            </a:r>
+            <a:r>
+              <a:rPr lang="en-US" altLang="ko-KR" sz="1200">
+                <a:solidFill>
+                  <a:srgbClr val="CF8E6D"/>
+                </a:solidFill>
+                <a:effectLst/>
+                <a:latin typeface="JetBrains Mono"/>
+              </a:rPr>
+              <a:t>\\</a:t>
+            </a:r>
+            <a:r>
+              <a:rPr lang="en-US" altLang="ko-KR" sz="1200">
+                <a:solidFill>
+                  <a:srgbClr val="6AAB73"/>
+                </a:solidFill>
+                <a:effectLst/>
+                <a:latin typeface="JetBrains Mono"/>
+              </a:rPr>
+              <a:t>index.js"</a:t>
+            </a:r>
+            <a:r>
+              <a:rPr lang="en-US" altLang="ko-KR" sz="1200">
+                <a:solidFill>
+                  <a:srgbClr val="BCBEC4"/>
+                </a:solidFill>
+                <a:effectLst/>
+                <a:latin typeface="JetBrains Mono"/>
+              </a:rPr>
+              <a:t>],</a:t>
+            </a:r>
+            <a:br>
+              <a:rPr lang="en-US" altLang="ko-KR" sz="1200">
+                <a:solidFill>
+                  <a:srgbClr val="BCBEC4"/>
+                </a:solidFill>
+                <a:effectLst/>
+                <a:latin typeface="JetBrains Mono"/>
+              </a:rPr>
+            </a:br>
+            <a:r>
+              <a:rPr lang="en-US" altLang="ko-KR" sz="1200">
+                <a:solidFill>
+                  <a:srgbClr val="BCBEC4"/>
+                </a:solidFill>
+                <a:effectLst/>
+                <a:latin typeface="JetBrains Mono"/>
+              </a:rPr>
+              <a:t>   </a:t>
+            </a:r>
+            <a:r>
+              <a:rPr lang="en-US" altLang="ko-KR" sz="1200">
+                <a:solidFill>
+                  <a:srgbClr val="C77DBB"/>
+                </a:solidFill>
+                <a:effectLst/>
+                <a:latin typeface="JetBrains Mono"/>
+              </a:rPr>
+              <a:t>"env"</a:t>
+            </a:r>
+            <a:r>
+              <a:rPr lang="en-US" altLang="ko-KR" sz="1200">
+                <a:solidFill>
+                  <a:srgbClr val="BCBEC4"/>
+                </a:solidFill>
+                <a:effectLst/>
+                <a:latin typeface="JetBrains Mono"/>
+              </a:rPr>
+              <a:t>: {</a:t>
+            </a:r>
+            <a:br>
+              <a:rPr lang="en-US" altLang="ko-KR" sz="1200">
+                <a:solidFill>
+                  <a:srgbClr val="BCBEC4"/>
+                </a:solidFill>
+                <a:effectLst/>
+                <a:latin typeface="JetBrains Mono"/>
+              </a:rPr>
+            </a:br>
+            <a:r>
+              <a:rPr lang="en-US" altLang="ko-KR" sz="1200">
+                <a:solidFill>
+                  <a:srgbClr val="BCBEC4"/>
+                </a:solidFill>
+                <a:effectLst/>
+                <a:latin typeface="JetBrains Mono"/>
+              </a:rPr>
+              <a:t>     </a:t>
+            </a:r>
+            <a:r>
+              <a:rPr lang="en-US" altLang="ko-KR" sz="1200">
+                <a:solidFill>
+                  <a:srgbClr val="C77DBB"/>
+                </a:solidFill>
+                <a:effectLst/>
+                <a:latin typeface="JetBrains Mono"/>
+              </a:rPr>
+              <a:t>"DATA_DIR"</a:t>
+            </a:r>
+            <a:r>
+              <a:rPr lang="en-US" altLang="ko-KR" sz="1200">
+                <a:solidFill>
+                  <a:srgbClr val="BCBEC4"/>
+                </a:solidFill>
+                <a:effectLst/>
+                <a:latin typeface="JetBrains Mono"/>
+              </a:rPr>
+              <a:t>: </a:t>
+            </a:r>
+            <a:r>
+              <a:rPr lang="en-US" altLang="ko-KR" sz="1200">
+                <a:solidFill>
+                  <a:srgbClr val="6AAB73"/>
+                </a:solidFill>
+                <a:effectLst/>
+                <a:latin typeface="JetBrains Mono"/>
+              </a:rPr>
+              <a:t>"D:</a:t>
+            </a:r>
+            <a:r>
+              <a:rPr lang="en-US" altLang="ko-KR" sz="1200">
+                <a:solidFill>
+                  <a:srgbClr val="CF8E6D"/>
+                </a:solidFill>
+                <a:effectLst/>
+                <a:latin typeface="JetBrains Mono"/>
+              </a:rPr>
+              <a:t>\\</a:t>
+            </a:r>
+            <a:r>
+              <a:rPr lang="en-US" altLang="ko-KR" sz="1200">
+                <a:solidFill>
+                  <a:srgbClr val="6AAB73"/>
+                </a:solidFill>
+                <a:effectLst/>
+                <a:latin typeface="JetBrains Mono"/>
+              </a:rPr>
+              <a:t>Study</a:t>
+            </a:r>
+            <a:r>
+              <a:rPr lang="en-US" altLang="ko-KR" sz="1200">
+                <a:solidFill>
+                  <a:srgbClr val="CF8E6D"/>
+                </a:solidFill>
+                <a:effectLst/>
+                <a:latin typeface="JetBrains Mono"/>
+              </a:rPr>
+              <a:t>\\</a:t>
+            </a:r>
+            <a:r>
+              <a:rPr lang="en-US" altLang="ko-KR" sz="1200">
+                <a:solidFill>
+                  <a:srgbClr val="6AAB73"/>
+                </a:solidFill>
+                <a:effectLst/>
+                <a:latin typeface="JetBrains Mono"/>
+              </a:rPr>
+              <a:t>ClaudeAI</a:t>
+            </a:r>
+            <a:r>
+              <a:rPr lang="en-US" altLang="ko-KR" sz="1200">
+                <a:solidFill>
+                  <a:srgbClr val="CF8E6D"/>
+                </a:solidFill>
+                <a:effectLst/>
+                <a:latin typeface="JetBrains Mono"/>
+              </a:rPr>
+              <a:t>\\</a:t>
+            </a:r>
+            <a:r>
+              <a:rPr lang="en-US" altLang="ko-KR" sz="1200">
+                <a:solidFill>
+                  <a:srgbClr val="6AAB73"/>
+                </a:solidFill>
+                <a:effectLst/>
+                <a:latin typeface="JetBrains Mono"/>
+              </a:rPr>
+              <a:t>workspace</a:t>
+            </a:r>
+            <a:r>
+              <a:rPr lang="en-US" altLang="ko-KR" sz="1200">
+                <a:solidFill>
+                  <a:srgbClr val="CF8E6D"/>
+                </a:solidFill>
+                <a:effectLst/>
+                <a:latin typeface="JetBrains Mono"/>
+              </a:rPr>
+              <a:t>\\</a:t>
+            </a:r>
+            <a:r>
+              <a:rPr lang="en-US" altLang="ko-KR" sz="1200">
+                <a:solidFill>
+                  <a:srgbClr val="6AAB73"/>
+                </a:solidFill>
+                <a:effectLst/>
+                <a:latin typeface="JetBrains Mono"/>
+              </a:rPr>
+              <a:t>invoice-web</a:t>
+            </a:r>
+            <a:r>
+              <a:rPr lang="en-US" altLang="ko-KR" sz="1200">
+                <a:solidFill>
+                  <a:srgbClr val="CF8E6D"/>
+                </a:solidFill>
+                <a:effectLst/>
+                <a:latin typeface="JetBrains Mono"/>
+              </a:rPr>
+              <a:t>\\</a:t>
+            </a:r>
+            <a:r>
+              <a:rPr lang="en-US" altLang="ko-KR" sz="1200">
+                <a:solidFill>
+                  <a:srgbClr val="6AAB73"/>
+                </a:solidFill>
+                <a:effectLst/>
+                <a:latin typeface="JetBrains Mono"/>
+              </a:rPr>
+              <a:t>.shrimp_data"</a:t>
+            </a:r>
+            <a:r>
+              <a:rPr lang="en-US" altLang="ko-KR" sz="1200">
+                <a:solidFill>
+                  <a:srgbClr val="BCBEC4"/>
+                </a:solidFill>
+                <a:effectLst/>
+                <a:latin typeface="JetBrains Mono"/>
+              </a:rPr>
+              <a:t>,</a:t>
+            </a:r>
+            <a:br>
+              <a:rPr lang="en-US" altLang="ko-KR" sz="1200">
+                <a:solidFill>
+                  <a:srgbClr val="BCBEC4"/>
+                </a:solidFill>
+                <a:effectLst/>
+                <a:latin typeface="JetBrains Mono"/>
+              </a:rPr>
+            </a:br>
+            <a:r>
+              <a:rPr lang="en-US" altLang="ko-KR" sz="1200">
+                <a:solidFill>
+                  <a:srgbClr val="BCBEC4"/>
+                </a:solidFill>
+                <a:effectLst/>
+                <a:latin typeface="JetBrains Mono"/>
+              </a:rPr>
+              <a:t>     </a:t>
+            </a:r>
+            <a:r>
+              <a:rPr lang="en-US" altLang="ko-KR" sz="1200">
+                <a:solidFill>
+                  <a:srgbClr val="C77DBB"/>
+                </a:solidFill>
+                <a:effectLst/>
+                <a:latin typeface="JetBrains Mono"/>
+              </a:rPr>
+              <a:t>"TEMPLATES_USE"</a:t>
+            </a:r>
+            <a:r>
+              <a:rPr lang="en-US" altLang="ko-KR" sz="1200">
+                <a:solidFill>
+                  <a:srgbClr val="BCBEC4"/>
+                </a:solidFill>
+                <a:effectLst/>
+                <a:latin typeface="JetBrains Mono"/>
+              </a:rPr>
+              <a:t>: </a:t>
+            </a:r>
+            <a:r>
+              <a:rPr lang="en-US" altLang="ko-KR" sz="1200">
+                <a:solidFill>
+                  <a:srgbClr val="6AAB73"/>
+                </a:solidFill>
+                <a:effectLst/>
+                <a:latin typeface="JetBrains Mono"/>
+              </a:rPr>
+              <a:t>"en"</a:t>
+            </a:r>
+            <a:r>
+              <a:rPr lang="en-US" altLang="ko-KR" sz="1200">
+                <a:solidFill>
+                  <a:srgbClr val="BCBEC4"/>
+                </a:solidFill>
+                <a:effectLst/>
+                <a:latin typeface="JetBrains Mono"/>
+              </a:rPr>
+              <a:t>,</a:t>
+            </a:r>
+            <a:br>
+              <a:rPr lang="en-US" altLang="ko-KR" sz="1200">
+                <a:solidFill>
+                  <a:srgbClr val="BCBEC4"/>
+                </a:solidFill>
+                <a:effectLst/>
+                <a:latin typeface="JetBrains Mono"/>
+              </a:rPr>
+            </a:br>
+            <a:r>
+              <a:rPr lang="en-US" altLang="ko-KR" sz="1200">
+                <a:solidFill>
+                  <a:srgbClr val="BCBEC4"/>
+                </a:solidFill>
+                <a:effectLst/>
+                <a:latin typeface="JetBrains Mono"/>
+              </a:rPr>
+              <a:t>     </a:t>
+            </a:r>
+            <a:r>
+              <a:rPr lang="en-US" altLang="ko-KR" sz="1200">
+                <a:solidFill>
+                  <a:srgbClr val="C77DBB"/>
+                </a:solidFill>
+                <a:effectLst/>
+                <a:latin typeface="JetBrains Mono"/>
+              </a:rPr>
+              <a:t>"ENABLE_GUI"</a:t>
+            </a:r>
+            <a:r>
+              <a:rPr lang="en-US" altLang="ko-KR" sz="1200">
+                <a:solidFill>
+                  <a:srgbClr val="BCBEC4"/>
+                </a:solidFill>
+                <a:effectLst/>
+                <a:latin typeface="JetBrains Mono"/>
+              </a:rPr>
+              <a:t>: </a:t>
+            </a:r>
+            <a:r>
+              <a:rPr lang="en-US" altLang="ko-KR" sz="1200">
+                <a:solidFill>
+                  <a:srgbClr val="6AAB73"/>
+                </a:solidFill>
+                <a:effectLst/>
+                <a:latin typeface="JetBrains Mono"/>
+              </a:rPr>
+              <a:t>"false"</a:t>
+            </a:r>
+            <a:br>
+              <a:rPr lang="en-US" altLang="ko-KR" sz="1200">
+                <a:solidFill>
+                  <a:srgbClr val="6AAB73"/>
+                </a:solidFill>
+                <a:effectLst/>
+                <a:latin typeface="JetBrains Mono"/>
+              </a:rPr>
+            </a:br>
+            <a:r>
+              <a:rPr lang="en-US" altLang="ko-KR" sz="1200">
+                <a:solidFill>
+                  <a:srgbClr val="6AAB73"/>
+                </a:solidFill>
+                <a:effectLst/>
+                <a:latin typeface="JetBrains Mono"/>
+              </a:rPr>
+              <a:t>   </a:t>
+            </a:r>
+            <a:r>
+              <a:rPr lang="en-US" altLang="ko-KR" sz="1200">
+                <a:solidFill>
+                  <a:srgbClr val="BCBEC4"/>
+                </a:solidFill>
+                <a:effectLst/>
+                <a:latin typeface="JetBrains Mono"/>
+              </a:rPr>
+              <a:t>}</a:t>
+            </a:r>
+            <a:br>
+              <a:rPr lang="en-US" altLang="ko-KR" sz="1200">
+                <a:solidFill>
+                  <a:srgbClr val="BCBEC4"/>
+                </a:solidFill>
+                <a:effectLst/>
+                <a:latin typeface="JetBrains Mono"/>
+              </a:rPr>
+            </a:br>
+            <a:r>
+              <a:rPr lang="en-US" altLang="ko-KR" sz="1200">
+                <a:solidFill>
+                  <a:srgbClr val="BCBEC4"/>
+                </a:solidFill>
+                <a:effectLst/>
+                <a:latin typeface="JetBrains Mono"/>
+              </a:rPr>
+              <a:t> },</a:t>
+            </a:r>
+          </a:p>
+        </p:txBody>
+      </p:sp>
+      <p:pic>
+        <p:nvPicPr>
+          <p:cNvPr id="8" name="그림 7">
+            <a:extLst>
+              <a:ext uri="{FF2B5EF4-FFF2-40B4-BE49-F238E27FC236}">
+                <a16:creationId xmlns:a16="http://schemas.microsoft.com/office/drawing/2014/main" id="{E95D981F-1830-25E2-ACF7-7B3AD3D303B2}"/>
+              </a:ext>
+            </a:extLst>
+          </p:cNvPr>
+          <p:cNvPicPr>
+            <a:picLocks noChangeAspect="1"/>
+          </p:cNvPicPr>
+          <p:nvPr/>
+        </p:nvPicPr>
+        <p:blipFill>
+          <a:blip r:embed="rId2"/>
+          <a:stretch>
+            <a:fillRect/>
+          </a:stretch>
+        </p:blipFill>
+        <p:spPr>
+          <a:xfrm>
+            <a:off x="612544" y="1887184"/>
+            <a:ext cx="8459381" cy="1962424"/>
+          </a:xfrm>
+          <a:prstGeom prst="rect">
+            <a:avLst/>
+          </a:prstGeom>
+        </p:spPr>
+      </p:pic>
+    </p:spTree>
+    <p:extLst>
+      <p:ext uri="{BB962C8B-B14F-4D97-AF65-F5344CB8AC3E}">
+        <p14:creationId xmlns:p14="http://schemas.microsoft.com/office/powerpoint/2010/main" val="4254094712"/>
+      </p:ext>
+    </p:extLst>
+  </p:cSld>
+  <p:clrMapOvr>
+    <a:masterClrMapping/>
+  </p:clrMapOvr>
+</p:sld>
+</file>
+
+<file path=ppt/slides/slide7.xml><?xml version="1.0" encoding="utf-8"?>
+<p:sld xmlns:a="http://schemas.openxmlformats.org/drawingml/2006/main" xmlns:r="http://schemas.openxmlformats.org/officeDocument/2006/relationships" xmlns:p="http://schemas.openxmlformats.org/presentationml/2006/main">
+  <p:cSld>
+    <p:spTree>
+      <p:nvGrpSpPr>
         <p:cNvPr id="1" name=""/>
         <p:cNvGrpSpPr/>
         <p:nvPr/>
@@ -6701,7 +8302,7 @@
 </p:sld>
 </file>
 
-<file path=ppt/slides/slide6.xml><?xml version="1.0" encoding="utf-8"?>
+<file path=ppt/slides/slide8.xml><?xml version="1.0" encoding="utf-8"?>
 <p:sld xmlns:a="http://schemas.openxmlformats.org/drawingml/2006/main" xmlns:r="http://schemas.openxmlformats.org/officeDocument/2006/relationships" xmlns:p="http://schemas.openxmlformats.org/presentationml/2006/main">
   <p:cSld>
     <p:spTree>
@@ -6938,7 +8539,7 @@
 </p:sld>
 </file>
 
-<file path=ppt/slides/slide7.xml><?xml version="1.0" encoding="utf-8"?>
+<file path=ppt/slides/slide9.xml><?xml version="1.0" encoding="utf-8"?>
 <p:sld xmlns:a="http://schemas.openxmlformats.org/drawingml/2006/main" xmlns:r="http://schemas.openxmlformats.org/officeDocument/2006/relationships" xmlns:p="http://schemas.openxmlformats.org/presentationml/2006/main">
   <p:cSld>
     <p:spTree>
@@ -7207,395 +8808,6 @@
     <p:extLst>
       <p:ext uri="{BB962C8B-B14F-4D97-AF65-F5344CB8AC3E}">
         <p14:creationId xmlns:p14="http://schemas.microsoft.com/office/powerpoint/2010/main" val="377350782"/>
-      </p:ext>
-    </p:extLst>
-  </p:cSld>
-  <p:clrMapOvr>
-    <a:masterClrMapping/>
-  </p:clrMapOvr>
-</p:sld>
-</file>
-
-<file path=ppt/slides/slide8.xml><?xml version="1.0" encoding="utf-8"?>
-<p:sld xmlns:a="http://schemas.openxmlformats.org/drawingml/2006/main" xmlns:r="http://schemas.openxmlformats.org/officeDocument/2006/relationships" xmlns:p="http://schemas.openxmlformats.org/presentationml/2006/main">
-  <p:cSld>
-    <p:spTree>
-      <p:nvGrpSpPr>
-        <p:cNvPr id="1" name=""/>
-        <p:cNvGrpSpPr/>
-        <p:nvPr/>
-      </p:nvGrpSpPr>
-      <p:grpSpPr>
-        <a:xfrm>
-          <a:off x="0" y="0"/>
-          <a:ext cx="0" cy="0"/>
-          <a:chOff x="0" y="0"/>
-          <a:chExt cx="0" cy="0"/>
-        </a:xfrm>
-      </p:grpSpPr>
-      <p:sp>
-        <p:nvSpPr>
-          <p:cNvPr id="2" name="제목 1">
-            <a:extLst>
-              <a:ext uri="{FF2B5EF4-FFF2-40B4-BE49-F238E27FC236}">
-                <a16:creationId xmlns:a16="http://schemas.microsoft.com/office/drawing/2014/main" id="{15AC5E2E-9825-558B-AD91-28F979A66DC4}"/>
-              </a:ext>
-            </a:extLst>
-          </p:cNvPr>
-          <p:cNvSpPr>
-            <a:spLocks noGrp="1"/>
-          </p:cNvSpPr>
-          <p:nvPr>
-            <p:ph type="title"/>
-          </p:nvPr>
-        </p:nvSpPr>
-        <p:spPr/>
-        <p:txBody>
-          <a:bodyPr/>
-          <a:lstStyle/>
-          <a:p>
-            <a:r>
-              <a:rPr lang="en-US" altLang="ko-KR" dirty="0" err="1"/>
-              <a:t>Plan_task</a:t>
-            </a:r>
-            <a:endParaRPr lang="ko-KR" altLang="en-US" dirty="0"/>
-          </a:p>
-        </p:txBody>
-      </p:sp>
-      <p:pic>
-        <p:nvPicPr>
-          <p:cNvPr id="4" name="그림 3">
-            <a:extLst>
-              <a:ext uri="{FF2B5EF4-FFF2-40B4-BE49-F238E27FC236}">
-                <a16:creationId xmlns:a16="http://schemas.microsoft.com/office/drawing/2014/main" id="{4B17CF49-0026-3A32-FCE9-E9B2744B205E}"/>
-              </a:ext>
-            </a:extLst>
-          </p:cNvPr>
-          <p:cNvPicPr>
-            <a:picLocks noChangeAspect="1"/>
-          </p:cNvPicPr>
-          <p:nvPr/>
-        </p:nvPicPr>
-        <p:blipFill>
-          <a:blip r:embed="rId2"/>
-          <a:stretch>
-            <a:fillRect/>
-          </a:stretch>
-        </p:blipFill>
-        <p:spPr>
-          <a:xfrm>
-            <a:off x="6096000" y="1875541"/>
-            <a:ext cx="2397551" cy="982602"/>
-          </a:xfrm>
-          <a:prstGeom prst="rect">
-            <a:avLst/>
-          </a:prstGeom>
-        </p:spPr>
-      </p:pic>
-      <p:pic>
-        <p:nvPicPr>
-          <p:cNvPr id="5" name="그림 4">
-            <a:extLst>
-              <a:ext uri="{FF2B5EF4-FFF2-40B4-BE49-F238E27FC236}">
-                <a16:creationId xmlns:a16="http://schemas.microsoft.com/office/drawing/2014/main" id="{2F3E1275-53C1-952C-EEFA-575CF5A4B093}"/>
-              </a:ext>
-            </a:extLst>
-          </p:cNvPr>
-          <p:cNvPicPr>
-            <a:picLocks noChangeAspect="1"/>
-          </p:cNvPicPr>
-          <p:nvPr/>
-        </p:nvPicPr>
-        <p:blipFill>
-          <a:blip r:embed="rId3"/>
-          <a:stretch>
-            <a:fillRect/>
-          </a:stretch>
-        </p:blipFill>
-        <p:spPr>
-          <a:xfrm>
-            <a:off x="399068" y="1875540"/>
-            <a:ext cx="5539611" cy="4852937"/>
-          </a:xfrm>
-          <a:prstGeom prst="rect">
-            <a:avLst/>
-          </a:prstGeom>
-        </p:spPr>
-      </p:pic>
-      <p:sp>
-        <p:nvSpPr>
-          <p:cNvPr id="6" name="TextBox 5">
-            <a:extLst>
-              <a:ext uri="{FF2B5EF4-FFF2-40B4-BE49-F238E27FC236}">
-                <a16:creationId xmlns:a16="http://schemas.microsoft.com/office/drawing/2014/main" id="{1B52CE1E-FF17-1232-CEE2-A52994EBA2CB}"/>
-              </a:ext>
-            </a:extLst>
-          </p:cNvPr>
-          <p:cNvSpPr txBox="1"/>
-          <p:nvPr/>
-        </p:nvSpPr>
-        <p:spPr>
-          <a:xfrm>
-            <a:off x="6096000" y="2858143"/>
-            <a:ext cx="5894895" cy="430887"/>
-          </a:xfrm>
-          <a:prstGeom prst="rect">
-            <a:avLst/>
-          </a:prstGeom>
-          <a:noFill/>
-        </p:spPr>
-        <p:txBody>
-          <a:bodyPr wrap="square" rtlCol="0">
-            <a:spAutoFit/>
-          </a:bodyPr>
-          <a:lstStyle/>
-          <a:p>
-            <a:r>
-              <a:rPr lang="ko-KR" altLang="en-US" sz="1100" dirty="0"/>
-              <a:t>프로젝트 룰을 통해 </a:t>
-            </a:r>
-            <a:r>
-              <a:rPr lang="en-US" altLang="ko-KR" sz="1100" dirty="0"/>
-              <a:t>Plan</a:t>
-            </a:r>
-            <a:r>
-              <a:rPr lang="ko-KR" altLang="en-US" sz="1100" dirty="0"/>
-              <a:t>을 세우고 싶을 때 사용하는 명령어</a:t>
-            </a:r>
-            <a:r>
-              <a:rPr lang="en-US" altLang="ko-KR" sz="1100" dirty="0"/>
-              <a:t>.</a:t>
-            </a:r>
-            <a:br>
-              <a:rPr lang="en-US" altLang="ko-KR" sz="1100" dirty="0"/>
-            </a:br>
-            <a:endParaRPr lang="ko-KR" altLang="en-US" sz="1100" dirty="0"/>
-          </a:p>
-        </p:txBody>
-      </p:sp>
-      <p:pic>
-        <p:nvPicPr>
-          <p:cNvPr id="8" name="그림 7">
-            <a:extLst>
-              <a:ext uri="{FF2B5EF4-FFF2-40B4-BE49-F238E27FC236}">
-                <a16:creationId xmlns:a16="http://schemas.microsoft.com/office/drawing/2014/main" id="{5678FDE4-4D56-05C4-376A-BB57555FDB12}"/>
-              </a:ext>
-            </a:extLst>
-          </p:cNvPr>
-          <p:cNvPicPr>
-            <a:picLocks noChangeAspect="1"/>
-          </p:cNvPicPr>
-          <p:nvPr/>
-        </p:nvPicPr>
-        <p:blipFill>
-          <a:blip r:embed="rId4"/>
-          <a:stretch>
-            <a:fillRect/>
-          </a:stretch>
-        </p:blipFill>
-        <p:spPr>
-          <a:xfrm>
-            <a:off x="6096000" y="3355669"/>
-            <a:ext cx="5195948" cy="3372808"/>
-          </a:xfrm>
-          <a:prstGeom prst="rect">
-            <a:avLst/>
-          </a:prstGeom>
-        </p:spPr>
-      </p:pic>
-    </p:spTree>
-    <p:extLst>
-      <p:ext uri="{BB962C8B-B14F-4D97-AF65-F5344CB8AC3E}">
-        <p14:creationId xmlns:p14="http://schemas.microsoft.com/office/powerpoint/2010/main" val="1020397168"/>
-      </p:ext>
-    </p:extLst>
-  </p:cSld>
-  <p:clrMapOvr>
-    <a:masterClrMapping/>
-  </p:clrMapOvr>
-</p:sld>
-</file>
-
-<file path=ppt/slides/slide9.xml><?xml version="1.0" encoding="utf-8"?>
-<p:sld xmlns:a="http://schemas.openxmlformats.org/drawingml/2006/main" xmlns:r="http://schemas.openxmlformats.org/officeDocument/2006/relationships" xmlns:p="http://schemas.openxmlformats.org/presentationml/2006/main">
-  <p:cSld>
-    <p:spTree>
-      <p:nvGrpSpPr>
-        <p:cNvPr id="1" name=""/>
-        <p:cNvGrpSpPr/>
-        <p:nvPr/>
-      </p:nvGrpSpPr>
-      <p:grpSpPr>
-        <a:xfrm>
-          <a:off x="0" y="0"/>
-          <a:ext cx="0" cy="0"/>
-          <a:chOff x="0" y="0"/>
-          <a:chExt cx="0" cy="0"/>
-        </a:xfrm>
-      </p:grpSpPr>
-      <p:sp>
-        <p:nvSpPr>
-          <p:cNvPr id="2" name="제목 1">
-            <a:extLst>
-              <a:ext uri="{FF2B5EF4-FFF2-40B4-BE49-F238E27FC236}">
-                <a16:creationId xmlns:a16="http://schemas.microsoft.com/office/drawing/2014/main" id="{EE4AD1B9-E4BD-CE0B-4F94-7F5692E2E8AF}"/>
-              </a:ext>
-            </a:extLst>
-          </p:cNvPr>
-          <p:cNvSpPr>
-            <a:spLocks noGrp="1"/>
-          </p:cNvSpPr>
-          <p:nvPr>
-            <p:ph type="title"/>
-          </p:nvPr>
-        </p:nvSpPr>
-        <p:spPr/>
-        <p:txBody>
-          <a:bodyPr/>
-          <a:lstStyle/>
-          <a:p>
-            <a:r>
-              <a:rPr lang="en-US" altLang="ko-KR" dirty="0" err="1"/>
-              <a:t>Plan_task</a:t>
-            </a:r>
-            <a:r>
-              <a:rPr lang="en-US" altLang="ko-KR" dirty="0"/>
-              <a:t> -2 [</a:t>
-            </a:r>
-            <a:r>
-              <a:rPr lang="en-US" altLang="ko-KR" dirty="0" err="1"/>
-              <a:t>list_tasks</a:t>
-            </a:r>
-            <a:r>
-              <a:rPr lang="en-US" altLang="ko-KR" dirty="0"/>
-              <a:t>]</a:t>
-            </a:r>
-            <a:endParaRPr lang="ko-KR" altLang="en-US" dirty="0"/>
-          </a:p>
-        </p:txBody>
-      </p:sp>
-      <p:pic>
-        <p:nvPicPr>
-          <p:cNvPr id="4" name="그림 3">
-            <a:extLst>
-              <a:ext uri="{FF2B5EF4-FFF2-40B4-BE49-F238E27FC236}">
-                <a16:creationId xmlns:a16="http://schemas.microsoft.com/office/drawing/2014/main" id="{43736846-A781-C48D-D8DE-3D91F1A91064}"/>
-              </a:ext>
-            </a:extLst>
-          </p:cNvPr>
-          <p:cNvPicPr>
-            <a:picLocks noChangeAspect="1"/>
-          </p:cNvPicPr>
-          <p:nvPr/>
-        </p:nvPicPr>
-        <p:blipFill>
-          <a:blip r:embed="rId2"/>
-          <a:stretch>
-            <a:fillRect/>
-          </a:stretch>
-        </p:blipFill>
-        <p:spPr>
-          <a:xfrm>
-            <a:off x="1185275" y="1961376"/>
-            <a:ext cx="2547739" cy="904935"/>
-          </a:xfrm>
-          <a:prstGeom prst="rect">
-            <a:avLst/>
-          </a:prstGeom>
-        </p:spPr>
-      </p:pic>
-      <p:pic>
-        <p:nvPicPr>
-          <p:cNvPr id="6" name="그림 5">
-            <a:extLst>
-              <a:ext uri="{FF2B5EF4-FFF2-40B4-BE49-F238E27FC236}">
-                <a16:creationId xmlns:a16="http://schemas.microsoft.com/office/drawing/2014/main" id="{F06BA195-F50F-4854-F19E-664DDCB05B82}"/>
-              </a:ext>
-            </a:extLst>
-          </p:cNvPr>
-          <p:cNvPicPr>
-            <a:picLocks noChangeAspect="1"/>
-          </p:cNvPicPr>
-          <p:nvPr/>
-        </p:nvPicPr>
-        <p:blipFill>
-          <a:blip r:embed="rId3"/>
-          <a:stretch>
-            <a:fillRect/>
-          </a:stretch>
-        </p:blipFill>
-        <p:spPr>
-          <a:xfrm>
-            <a:off x="1185275" y="2967950"/>
-            <a:ext cx="3358445" cy="3748162"/>
-          </a:xfrm>
-          <a:prstGeom prst="rect">
-            <a:avLst/>
-          </a:prstGeom>
-        </p:spPr>
-      </p:pic>
-      <p:sp>
-        <p:nvSpPr>
-          <p:cNvPr id="7" name="TextBox 6">
-            <a:extLst>
-              <a:ext uri="{FF2B5EF4-FFF2-40B4-BE49-F238E27FC236}">
-                <a16:creationId xmlns:a16="http://schemas.microsoft.com/office/drawing/2014/main" id="{790450A5-6854-83EC-9EE0-63D36BFC54DB}"/>
-              </a:ext>
-            </a:extLst>
-          </p:cNvPr>
-          <p:cNvSpPr txBox="1"/>
-          <p:nvPr/>
-        </p:nvSpPr>
-        <p:spPr>
-          <a:xfrm>
-            <a:off x="4901938" y="1961376"/>
-            <a:ext cx="6104787" cy="307777"/>
-          </a:xfrm>
-          <a:prstGeom prst="rect">
-            <a:avLst/>
-          </a:prstGeom>
-          <a:noFill/>
-        </p:spPr>
-        <p:txBody>
-          <a:bodyPr wrap="square" rtlCol="0">
-            <a:spAutoFit/>
-          </a:bodyPr>
-          <a:lstStyle/>
-          <a:p>
-            <a:r>
-              <a:rPr lang="en-US" altLang="ko-KR" sz="1400" dirty="0" err="1"/>
-              <a:t>list_tasks</a:t>
-            </a:r>
-            <a:r>
-              <a:rPr lang="en-US" altLang="ko-KR" sz="1400" dirty="0"/>
-              <a:t> </a:t>
-            </a:r>
-            <a:r>
-              <a:rPr lang="en-US" altLang="ko-KR" sz="1400" dirty="0">
-                <a:sym typeface="Wingdings" panose="05000000000000000000" pitchFamily="2" charset="2"/>
-              </a:rPr>
-              <a:t> </a:t>
-            </a:r>
-            <a:r>
-              <a:rPr lang="ko-KR" altLang="en-US" sz="1400" dirty="0">
-                <a:sym typeface="Wingdings" panose="05000000000000000000" pitchFamily="2" charset="2"/>
-              </a:rPr>
-              <a:t>세워진 계획 중 진행 상태 확인 명령어</a:t>
-            </a:r>
-            <a:r>
-              <a:rPr lang="en-US" altLang="ko-KR" sz="1400" dirty="0">
-                <a:sym typeface="Wingdings" panose="05000000000000000000" pitchFamily="2" charset="2"/>
-              </a:rPr>
-              <a:t>.</a:t>
-            </a:r>
-            <a:endParaRPr lang="ko-KR" altLang="en-US" sz="1400" dirty="0"/>
-          </a:p>
-        </p:txBody>
-      </p:sp>
-    </p:spTree>
-    <p:extLst>
-      <p:ext uri="{BB962C8B-B14F-4D97-AF65-F5344CB8AC3E}">
-        <p14:creationId xmlns:p14="http://schemas.microsoft.com/office/powerpoint/2010/main" val="1328418983"/>
       </p:ext>
     </p:extLst>
   </p:cSld>

</xml_diff>